<commit_message>
fix(training-deck): void and PIN markers on the right controls; deck done for operators
void_dialog.voidBtn now marks the dialog's own Void (was a row's Void below
it); pin_pad.display marks the PIN dashes (was the heading). Placed from the
screenshots by hand; the capture specs were already corrected, so a
re-capture measures the same. README for rebuilding and the pending team lead
capture; PROJECT_STATUS entry.
</commit_message>
<xml_diff>
--- a/docs/training/diecast/MPP_DieCast_Training.pptx
+++ b/docs/training/diecast/MPP_DieCast_Training.pptx
@@ -5224,7 +5224,7 @@
         </p:nvSpPr>
         <p:spPr>
           <a:xfrm>
-            <a:off x="4573829" y="2593238"/>
+            <a:off x="4910328" y="2999232"/>
             <a:ext cx="760781" cy="381305"/>
           </a:xfrm>
           <a:prstGeom prst="rect">
@@ -5248,7 +5248,7 @@
         </p:nvSpPr>
         <p:spPr>
           <a:xfrm>
-            <a:off x="4582973" y="2602382"/>
+            <a:off x="4919472" y="3008376"/>
             <a:ext cx="742493" cy="363017"/>
           </a:xfrm>
           <a:prstGeom prst="rect">
@@ -5270,7 +5270,7 @@
         </p:nvSpPr>
         <p:spPr>
           <a:xfrm>
-            <a:off x="4436669" y="2456078"/>
+            <a:off x="4773168" y="2862072"/>
             <a:ext cx="256032" cy="256032"/>
           </a:xfrm>
           <a:prstGeom prst="ellipse">
@@ -5295,7 +5295,7 @@
         </p:nvSpPr>
         <p:spPr>
           <a:xfrm>
-            <a:off x="4436669" y="2456078"/>
+            <a:off x="4773168" y="2862072"/>
             <a:ext cx="256032" cy="256032"/>
           </a:xfrm>
           <a:prstGeom prst="rect">
@@ -5334,8 +5334,8 @@
         </p:nvSpPr>
         <p:spPr>
           <a:xfrm>
-            <a:off x="4573829" y="4623206"/>
-            <a:ext cx="760781" cy="381305"/>
+            <a:off x="2924251" y="4044391"/>
+            <a:ext cx="933602" cy="554126"/>
           </a:xfrm>
           <a:prstGeom prst="rect">
             <a:avLst/>
@@ -5358,8 +5358,8 @@
         </p:nvSpPr>
         <p:spPr>
           <a:xfrm>
-            <a:off x="4582973" y="4632350"/>
-            <a:ext cx="742493" cy="363017"/>
+            <a:off x="2933395" y="4053535"/>
+            <a:ext cx="915314" cy="535838"/>
           </a:xfrm>
           <a:prstGeom prst="rect">
             <a:avLst/>
@@ -5380,7 +5380,7 @@
         </p:nvSpPr>
         <p:spPr>
           <a:xfrm>
-            <a:off x="4436669" y="4486046"/>
+            <a:off x="2787091" y="3907231"/>
             <a:ext cx="256032" cy="256032"/>
           </a:xfrm>
           <a:prstGeom prst="ellipse">
@@ -5405,7 +5405,7 @@
         </p:nvSpPr>
         <p:spPr>
           <a:xfrm>
-            <a:off x="4436669" y="4486046"/>
+            <a:off x="2787091" y="3907231"/>
             <a:ext cx="256032" cy="256032"/>
           </a:xfrm>
           <a:prstGeom prst="rect">
@@ -20642,8 +20642,8 @@
         </p:nvSpPr>
         <p:spPr>
           <a:xfrm>
-            <a:off x="2926994" y="1862633"/>
-            <a:ext cx="1475842" cy="351130"/>
+            <a:off x="2616098" y="2675534"/>
+            <a:ext cx="2040026" cy="317297"/>
           </a:xfrm>
           <a:prstGeom prst="rect">
             <a:avLst/>
@@ -20666,8 +20666,8 @@
         </p:nvSpPr>
         <p:spPr>
           <a:xfrm>
-            <a:off x="2936138" y="1871777"/>
-            <a:ext cx="1457554" cy="332842"/>
+            <a:off x="2625242" y="2684678"/>
+            <a:ext cx="2021738" cy="299009"/>
           </a:xfrm>
           <a:prstGeom prst="rect">
             <a:avLst/>
@@ -20688,7 +20688,7 @@
         </p:nvSpPr>
         <p:spPr>
           <a:xfrm>
-            <a:off x="2789834" y="1725473"/>
+            <a:off x="2478938" y="2538374"/>
             <a:ext cx="256032" cy="256032"/>
           </a:xfrm>
           <a:prstGeom prst="ellipse">
@@ -20713,7 +20713,7 @@
         </p:nvSpPr>
         <p:spPr>
           <a:xfrm>
-            <a:off x="2789834" y="1725473"/>
+            <a:off x="2478938" y="2538374"/>
             <a:ext cx="256032" cy="256032"/>
           </a:xfrm>
           <a:prstGeom prst="rect">

</xml_diff>

<commit_message>
fix(training-deck): Jacques's review -- tag positions, die name, arrow, release and void steps
- Overview letter tags follow a fixed preference order (1 above-left, 2 left,
  3 below-left, 4 right, 5 above-right, 6 below-right), moving on only when a
  spot is off the usable area or on another tag or zone; a zone may pin one.
  Lot Management: A at 2, D at 5, E at 6. Reconcile Shift: all at 1.
- Pick your machine: marker 2 on the die name itself (DMO125).
- Open a basket: arrow to the first row's 'no basket' text, from above.
- Release: #2 on the pieces entry, Release basket added as step 5.
- The release follow-up slide is now only 'the press counter number is wrong'.
- Void: step 1 is finding the LOT on Lot Management.
- TRAINING_OUT lets the build write elsewhere while PowerPoint locks the deck.
</commit_message>
<xml_diff>
--- a/docs/training/diecast/MPP_DieCast_Training.pptx
+++ b/docs/training/diecast/MPP_DieCast_Training.pptx
@@ -618,7 +618,7 @@
           <a:p>
             <a:r>
               <a:rPr lang="en-US" dirty="0"/>
-              <a:t>The counter number fills in the piece count by itself. You never subtract anything. The screen does it. Did you swap the basket earlier? Use the number you wrote down then, not the number now. If your line counts pieces, type the count in the top box instead.</a:t>
+              <a:t>Type the count going in, or type the press counter number and the count fills in by itself. You never subtract anything. The screen does it. Did you swap the basket earlier? Use the number you wrote down then, not the number now. Cannot see Release basket? Scroll down inside the box.</a:t>
             </a:r>
             <a:endParaRPr lang="en-US" dirty="0"/>
           </a:p>
@@ -706,7 +706,7 @@
           <a:p>
             <a:r>
               <a:rPr lang="en-US" dirty="0"/>
-              <a:t>The buttons are at the bottom of the box, so scroll down to reach them. If you type no number, the screen warns you. The basket then closes at the count it already has.</a:t>
+              <a:t>Use this only when the press counter number is wrong. For example, the counter was set back to zero, or a wrong number was typed before. Type what the counter really shows. Then finish the release.</a:t>
             </a:r>
             <a:endParaRPr lang="en-US" dirty="0"/>
           </a:p>
@@ -3580,7 +3580,7 @@
         </p:nvSpPr>
         <p:spPr>
           <a:xfrm>
-            <a:off x="6836054" y="2780690"/>
+            <a:off x="6836054" y="2472538"/>
             <a:ext cx="781812" cy="299009"/>
           </a:xfrm>
           <a:prstGeom prst="rect">
@@ -3604,7 +3604,7 @@
         </p:nvSpPr>
         <p:spPr>
           <a:xfrm>
-            <a:off x="6845198" y="2789834"/>
+            <a:off x="6845198" y="2481682"/>
             <a:ext cx="763524" cy="280721"/>
           </a:xfrm>
           <a:prstGeom prst="rect">
@@ -3626,7 +3626,7 @@
         </p:nvSpPr>
         <p:spPr>
           <a:xfrm>
-            <a:off x="6698894" y="2643530"/>
+            <a:off x="6698894" y="2335378"/>
             <a:ext cx="256032" cy="256032"/>
           </a:xfrm>
           <a:prstGeom prst="ellipse">
@@ -3651,7 +3651,7 @@
         </p:nvSpPr>
         <p:spPr>
           <a:xfrm>
-            <a:off x="6698894" y="2643530"/>
+            <a:off x="6698894" y="2335378"/>
             <a:ext cx="256032" cy="256032"/>
           </a:xfrm>
           <a:prstGeom prst="rect">
@@ -3690,8 +3690,8 @@
         </p:nvSpPr>
         <p:spPr>
           <a:xfrm>
-            <a:off x="978408" y="3543300"/>
-            <a:ext cx="1209751" cy="299009"/>
+            <a:off x="978408" y="2686507"/>
+            <a:ext cx="1209751" cy="352958"/>
           </a:xfrm>
           <a:prstGeom prst="rect">
             <a:avLst/>
@@ -3714,8 +3714,8 @@
         </p:nvSpPr>
         <p:spPr>
           <a:xfrm>
-            <a:off x="987552" y="3552444"/>
-            <a:ext cx="1191463" cy="280721"/>
+            <a:off x="987552" y="2695651"/>
+            <a:ext cx="1191463" cy="334670"/>
           </a:xfrm>
           <a:prstGeom prst="rect">
             <a:avLst/>
@@ -3736,7 +3736,7 @@
         </p:nvSpPr>
         <p:spPr>
           <a:xfrm>
-            <a:off x="841248" y="3406140"/>
+            <a:off x="841248" y="2549347"/>
             <a:ext cx="256032" cy="256032"/>
           </a:xfrm>
           <a:prstGeom prst="ellipse">
@@ -3761,7 +3761,7 @@
         </p:nvSpPr>
         <p:spPr>
           <a:xfrm>
-            <a:off x="841248" y="3406140"/>
+            <a:off x="841248" y="2549347"/>
             <a:ext cx="256032" cy="256032"/>
           </a:xfrm>
           <a:prstGeom prst="rect">
@@ -3800,7 +3800,7 @@
         </p:nvSpPr>
         <p:spPr>
           <a:xfrm>
-            <a:off x="978408" y="3865169"/>
+            <a:off x="978408" y="3557016"/>
             <a:ext cx="4825289" cy="607162"/>
           </a:xfrm>
           <a:prstGeom prst="rect">
@@ -3824,7 +3824,7 @@
         </p:nvSpPr>
         <p:spPr>
           <a:xfrm>
-            <a:off x="987552" y="3874313"/>
+            <a:off x="987552" y="3566160"/>
             <a:ext cx="4807001" cy="588874"/>
           </a:xfrm>
           <a:prstGeom prst="rect">
@@ -3846,7 +3846,7 @@
         </p:nvSpPr>
         <p:spPr>
           <a:xfrm>
-            <a:off x="841248" y="3728009"/>
+            <a:off x="841248" y="3419856"/>
             <a:ext cx="256032" cy="256032"/>
           </a:xfrm>
           <a:prstGeom prst="ellipse">
@@ -3871,7 +3871,7 @@
         </p:nvSpPr>
         <p:spPr>
           <a:xfrm>
-            <a:off x="841248" y="3728009"/>
+            <a:off x="841248" y="3419856"/>
             <a:ext cx="256032" cy="256032"/>
           </a:xfrm>
           <a:prstGeom prst="rect">
@@ -3910,7 +3910,7 @@
         </p:nvSpPr>
         <p:spPr>
           <a:xfrm>
-            <a:off x="4332427" y="4494276"/>
+            <a:off x="4332427" y="4186123"/>
             <a:ext cx="1471270" cy="312725"/>
           </a:xfrm>
           <a:prstGeom prst="rect">
@@ -3934,7 +3934,7 @@
         </p:nvSpPr>
         <p:spPr>
           <a:xfrm>
-            <a:off x="4341571" y="4503420"/>
+            <a:off x="4341571" y="4195267"/>
             <a:ext cx="1452982" cy="294437"/>
           </a:xfrm>
           <a:prstGeom prst="rect">
@@ -3956,7 +3956,7 @@
         </p:nvSpPr>
         <p:spPr>
           <a:xfrm>
-            <a:off x="4195267" y="4357116"/>
+            <a:off x="4195267" y="4048963"/>
             <a:ext cx="256032" cy="256032"/>
           </a:xfrm>
           <a:prstGeom prst="ellipse">
@@ -3981,7 +3981,7 @@
         </p:nvSpPr>
         <p:spPr>
           <a:xfrm>
-            <a:off x="4195267" y="4357116"/>
+            <a:off x="4195267" y="4048963"/>
             <a:ext cx="256032" cy="256032"/>
           </a:xfrm>
           <a:prstGeom prst="rect">
@@ -4020,8 +4020,54 @@
         </p:nvSpPr>
         <p:spPr>
           <a:xfrm>
-            <a:off x="8458200" y="1179576"/>
-            <a:ext cx="310896" cy="310896"/>
+            <a:off x="4419295" y="4795114"/>
+            <a:ext cx="1384402" cy="326441"/>
+          </a:xfrm>
+          <a:prstGeom prst="rect">
+            <a:avLst/>
+          </a:prstGeom>
+          <a:ln w="31750">
+            <a:solidFill>
+              <a:srgbClr val="000000">
+                <a:alpha val="55000"/>
+              </a:srgbClr>
+            </a:solidFill>
+            <a:prstDash val="solid"/>
+          </a:ln>
+        </p:spPr>
+      </p:sp>
+      <p:sp>
+        <p:nvSpPr>
+          <p:cNvPr id="22" name="Shape 19"/>
+          <p:cNvSpPr/>
+          <p:nvPr/>
+        </p:nvSpPr>
+        <p:spPr>
+          <a:xfrm>
+            <a:off x="4428439" y="4804258"/>
+            <a:ext cx="1366114" cy="308153"/>
+          </a:xfrm>
+          <a:prstGeom prst="rect">
+            <a:avLst/>
+          </a:prstGeom>
+          <a:ln w="19050">
+            <a:solidFill>
+              <a:srgbClr val="FFB400"/>
+            </a:solidFill>
+            <a:prstDash val="solid"/>
+          </a:ln>
+        </p:spPr>
+      </p:sp>
+      <p:sp>
+        <p:nvSpPr>
+          <p:cNvPr id="23" name="Shape 20"/>
+          <p:cNvSpPr/>
+          <p:nvPr/>
+        </p:nvSpPr>
+        <p:spPr>
+          <a:xfrm>
+            <a:off x="4282135" y="4657954"/>
+            <a:ext cx="256032" cy="256032"/>
           </a:xfrm>
           <a:prstGeom prst="ellipse">
             <a:avLst/>
@@ -4039,14 +4085,14 @@
       </p:sp>
       <p:sp>
         <p:nvSpPr>
-          <p:cNvPr id="22" name="Text 19"/>
-          <p:cNvSpPr txBox="1"/>
-          <p:nvPr/>
-        </p:nvSpPr>
-        <p:spPr>
-          <a:xfrm>
-            <a:off x="8458200" y="1179576"/>
-            <a:ext cx="310896" cy="310896"/>
+          <p:cNvPr id="24" name="Text 21"/>
+          <p:cNvSpPr txBox="1"/>
+          <p:nvPr/>
+        </p:nvSpPr>
+        <p:spPr>
+          <a:xfrm>
+            <a:off x="4282135" y="4657954"/>
+            <a:ext cx="256032" cy="256032"/>
           </a:xfrm>
           <a:prstGeom prst="rect">
             <a:avLst/>
@@ -4070,7 +4116,7 @@
                 <a:ea typeface="Arial" pitchFamily="34" charset="-122"/>
                 <a:cs typeface="Arial" pitchFamily="34" charset="-120"/>
               </a:rPr>
-              <a:t>1</a:t>
+              <a:t>5</a:t>
             </a:r>
             <a:endParaRPr lang="en-US" sz="1200" dirty="0"/>
           </a:p>
@@ -4078,80 +4124,13 @@
       </p:sp>
       <p:sp>
         <p:nvSpPr>
-          <p:cNvPr id="23" name="Text 20"/>
-          <p:cNvSpPr txBox="1"/>
-          <p:nvPr/>
-        </p:nvSpPr>
-        <p:spPr>
-          <a:xfrm>
-            <a:off x="8897112" y="1143000"/>
-            <a:ext cx="2898648" cy="822960"/>
-          </a:xfrm>
-          <a:prstGeom prst="rect">
-            <a:avLst/>
-          </a:prstGeom>
-          <a:noFill/>
-          <a:ln/>
-        </p:spPr>
-        <p:txBody>
-          <a:bodyPr wrap="square" lIns="0" tIns="0" rIns="0" bIns="0" rtlCol="0" anchor="t"/>
-          <a:lstStyle/>
-          <a:p>
-            <a:pPr indent="0" marL="0">
-              <a:buNone/>
-            </a:pPr>
-            <a:r>
-              <a:rPr lang="en-US" sz="1700" dirty="0">
-                <a:solidFill>
-                  <a:srgbClr val="1B1B1B"/>
-                </a:solidFill>
-                <a:latin typeface="Calibri" pitchFamily="34" charset="0"/>
-                <a:ea typeface="Calibri" pitchFamily="34" charset="-122"/>
-                <a:cs typeface="Calibri" pitchFamily="34" charset="-120"/>
-              </a:rPr>
-              <a:t>Tap </a:t>
-            </a:r>
-            <a:pPr indent="0" marL="0">
-              <a:buNone/>
-            </a:pPr>
-            <a:r>
-              <a:rPr lang="en-US" sz="1700" b="1" dirty="0">
-                <a:solidFill>
-                  <a:srgbClr val="12263F"/>
-                </a:solidFill>
-                <a:latin typeface="Calibri" pitchFamily="34" charset="0"/>
-                <a:ea typeface="Calibri" pitchFamily="34" charset="-122"/>
-                <a:cs typeface="Calibri" pitchFamily="34" charset="-120"/>
-              </a:rPr>
-              <a:t>Release</a:t>
-            </a:r>
-            <a:pPr indent="0" marL="0">
-              <a:buNone/>
-            </a:pPr>
-            <a:r>
-              <a:rPr lang="en-US" sz="1700" dirty="0">
-                <a:solidFill>
-                  <a:srgbClr val="1B1B1B"/>
-                </a:solidFill>
-                <a:latin typeface="Calibri" pitchFamily="34" charset="0"/>
-                <a:ea typeface="Calibri" pitchFamily="34" charset="-122"/>
-                <a:cs typeface="Calibri" pitchFamily="34" charset="-120"/>
-              </a:rPr>
-              <a:t> on the full basket.</a:t>
-            </a:r>
-            <a:endParaRPr lang="en-US" sz="1700" dirty="0"/>
-          </a:p>
-        </p:txBody>
-      </p:sp>
-      <p:sp>
-        <p:nvSpPr>
-          <p:cNvPr id="24" name="Shape 21"/>
-          <p:cNvSpPr/>
-          <p:nvPr/>
-        </p:nvSpPr>
-        <p:spPr>
-          <a:xfrm>
-            <a:off x="8458200" y="2093976"/>
+          <p:cNvPr id="25" name="Shape 22"/>
+          <p:cNvSpPr/>
+          <p:nvPr/>
+        </p:nvSpPr>
+        <p:spPr>
+          <a:xfrm>
+            <a:off x="8458200" y="1179576"/>
             <a:ext cx="310896" cy="310896"/>
           </a:xfrm>
           <a:prstGeom prst="ellipse">
@@ -4170,13 +4149,13 @@
       </p:sp>
       <p:sp>
         <p:nvSpPr>
-          <p:cNvPr id="25" name="Text 22"/>
-          <p:cNvSpPr txBox="1"/>
-          <p:nvPr/>
-        </p:nvSpPr>
-        <p:spPr>
-          <a:xfrm>
-            <a:off x="8458200" y="2093976"/>
+          <p:cNvPr id="26" name="Text 23"/>
+          <p:cNvSpPr txBox="1"/>
+          <p:nvPr/>
+        </p:nvSpPr>
+        <p:spPr>
+          <a:xfrm>
+            <a:off x="8458200" y="1179576"/>
             <a:ext cx="310896" cy="310896"/>
           </a:xfrm>
           <a:prstGeom prst="rect">
@@ -4201,7 +4180,7 @@
                 <a:ea typeface="Arial" pitchFamily="34" charset="-122"/>
                 <a:cs typeface="Arial" pitchFamily="34" charset="-120"/>
               </a:rPr>
-              <a:t>2</a:t>
+              <a:t>1</a:t>
             </a:r>
             <a:endParaRPr lang="en-US" sz="1200" dirty="0"/>
           </a:p>
@@ -4209,13 +4188,13 @@
       </p:sp>
       <p:sp>
         <p:nvSpPr>
-          <p:cNvPr id="26" name="Text 23"/>
-          <p:cNvSpPr txBox="1"/>
-          <p:nvPr/>
-        </p:nvSpPr>
-        <p:spPr>
-          <a:xfrm>
-            <a:off x="8897112" y="2057400"/>
+          <p:cNvPr id="27" name="Text 24"/>
+          <p:cNvSpPr txBox="1"/>
+          <p:nvPr/>
+        </p:nvSpPr>
+        <p:spPr>
+          <a:xfrm>
+            <a:off x="8897112" y="1143000"/>
             <a:ext cx="2898648" cy="822960"/>
           </a:xfrm>
           <a:prstGeom prst="rect">
@@ -4240,7 +4219,35 @@
                 <a:ea typeface="Calibri" pitchFamily="34" charset="-122"/>
                 <a:cs typeface="Calibri" pitchFamily="34" charset="-120"/>
               </a:rPr>
-              <a:t>Type the number on the press counter.</a:t>
+              <a:t>Tap </a:t>
+            </a:r>
+            <a:pPr indent="0" marL="0">
+              <a:buNone/>
+            </a:pPr>
+            <a:r>
+              <a:rPr lang="en-US" sz="1700" b="1" dirty="0">
+                <a:solidFill>
+                  <a:srgbClr val="12263F"/>
+                </a:solidFill>
+                <a:latin typeface="Calibri" pitchFamily="34" charset="0"/>
+                <a:ea typeface="Calibri" pitchFamily="34" charset="-122"/>
+                <a:cs typeface="Calibri" pitchFamily="34" charset="-120"/>
+              </a:rPr>
+              <a:t>Release</a:t>
+            </a:r>
+            <a:pPr indent="0" marL="0">
+              <a:buNone/>
+            </a:pPr>
+            <a:r>
+              <a:rPr lang="en-US" sz="1700" dirty="0">
+                <a:solidFill>
+                  <a:srgbClr val="1B1B1B"/>
+                </a:solidFill>
+                <a:latin typeface="Calibri" pitchFamily="34" charset="0"/>
+                <a:ea typeface="Calibri" pitchFamily="34" charset="-122"/>
+                <a:cs typeface="Calibri" pitchFamily="34" charset="-120"/>
+              </a:rPr>
+              <a:t> on the full basket.</a:t>
             </a:r>
             <a:endParaRPr lang="en-US" sz="1700" dirty="0"/>
           </a:p>
@@ -4248,13 +4255,13 @@
       </p:sp>
       <p:sp>
         <p:nvSpPr>
-          <p:cNvPr id="27" name="Shape 24"/>
-          <p:cNvSpPr/>
-          <p:nvPr/>
-        </p:nvSpPr>
-        <p:spPr>
-          <a:xfrm>
-            <a:off x="8458200" y="3008376"/>
+          <p:cNvPr id="28" name="Shape 25"/>
+          <p:cNvSpPr/>
+          <p:nvPr/>
+        </p:nvSpPr>
+        <p:spPr>
+          <a:xfrm>
+            <a:off x="8458200" y="2093976"/>
             <a:ext cx="310896" cy="310896"/>
           </a:xfrm>
           <a:prstGeom prst="ellipse">
@@ -4273,13 +4280,13 @@
       </p:sp>
       <p:sp>
         <p:nvSpPr>
-          <p:cNvPr id="28" name="Text 25"/>
-          <p:cNvSpPr txBox="1"/>
-          <p:nvPr/>
-        </p:nvSpPr>
-        <p:spPr>
-          <a:xfrm>
-            <a:off x="8458200" y="3008376"/>
+          <p:cNvPr id="29" name="Text 26"/>
+          <p:cNvSpPr txBox="1"/>
+          <p:nvPr/>
+        </p:nvSpPr>
+        <p:spPr>
+          <a:xfrm>
+            <a:off x="8458200" y="2093976"/>
             <a:ext cx="310896" cy="310896"/>
           </a:xfrm>
           <a:prstGeom prst="rect">
@@ -4304,7 +4311,7 @@
                 <a:ea typeface="Arial" pitchFamily="34" charset="-122"/>
                 <a:cs typeface="Arial" pitchFamily="34" charset="-120"/>
               </a:rPr>
-              <a:t>3</a:t>
+              <a:t>2</a:t>
             </a:r>
             <a:endParaRPr lang="en-US" sz="1200" dirty="0"/>
           </a:p>
@@ -4312,13 +4319,13 @@
       </p:sp>
       <p:sp>
         <p:nvSpPr>
-          <p:cNvPr id="29" name="Text 26"/>
-          <p:cNvSpPr txBox="1"/>
-          <p:nvPr/>
-        </p:nvSpPr>
-        <p:spPr>
-          <a:xfrm>
-            <a:off x="8897112" y="2971800"/>
+          <p:cNvPr id="30" name="Text 27"/>
+          <p:cNvSpPr txBox="1"/>
+          <p:nvPr/>
+        </p:nvSpPr>
+        <p:spPr>
+          <a:xfrm>
+            <a:off x="8897112" y="2057400"/>
             <a:ext cx="2898648" cy="822960"/>
           </a:xfrm>
           <a:prstGeom prst="rect">
@@ -4343,7 +4350,7 @@
                 <a:ea typeface="Calibri" pitchFamily="34" charset="-122"/>
                 <a:cs typeface="Calibri" pitchFamily="34" charset="-120"/>
               </a:rPr>
-              <a:t>Check the three boxes. They add up for you.</a:t>
+              <a:t>Type the pieces you put in. Or type the press counter number below it.</a:t>
             </a:r>
             <a:endParaRPr lang="en-US" sz="1700" dirty="0"/>
           </a:p>
@@ -4351,13 +4358,13 @@
       </p:sp>
       <p:sp>
         <p:nvSpPr>
-          <p:cNvPr id="30" name="Shape 27"/>
-          <p:cNvSpPr/>
-          <p:nvPr/>
-        </p:nvSpPr>
-        <p:spPr>
-          <a:xfrm>
-            <a:off x="8458200" y="3922776"/>
+          <p:cNvPr id="31" name="Shape 28"/>
+          <p:cNvSpPr/>
+          <p:nvPr/>
+        </p:nvSpPr>
+        <p:spPr>
+          <a:xfrm>
+            <a:off x="8458200" y="3008376"/>
             <a:ext cx="310896" cy="310896"/>
           </a:xfrm>
           <a:prstGeom prst="ellipse">
@@ -4376,13 +4383,13 @@
       </p:sp>
       <p:sp>
         <p:nvSpPr>
-          <p:cNvPr id="31" name="Text 28"/>
-          <p:cNvSpPr txBox="1"/>
-          <p:nvPr/>
-        </p:nvSpPr>
-        <p:spPr>
-          <a:xfrm>
-            <a:off x="8458200" y="3922776"/>
+          <p:cNvPr id="32" name="Text 29"/>
+          <p:cNvSpPr txBox="1"/>
+          <p:nvPr/>
+        </p:nvSpPr>
+        <p:spPr>
+          <a:xfrm>
+            <a:off x="8458200" y="3008376"/>
             <a:ext cx="310896" cy="310896"/>
           </a:xfrm>
           <a:prstGeom prst="rect">
@@ -4407,6 +4414,109 @@
                 <a:ea typeface="Arial" pitchFamily="34" charset="-122"/>
                 <a:cs typeface="Arial" pitchFamily="34" charset="-120"/>
               </a:rPr>
+              <a:t>3</a:t>
+            </a:r>
+            <a:endParaRPr lang="en-US" sz="1200" dirty="0"/>
+          </a:p>
+        </p:txBody>
+      </p:sp>
+      <p:sp>
+        <p:nvSpPr>
+          <p:cNvPr id="33" name="Text 30"/>
+          <p:cNvSpPr txBox="1"/>
+          <p:nvPr/>
+        </p:nvSpPr>
+        <p:spPr>
+          <a:xfrm>
+            <a:off x="8897112" y="2971800"/>
+            <a:ext cx="2898648" cy="822960"/>
+          </a:xfrm>
+          <a:prstGeom prst="rect">
+            <a:avLst/>
+          </a:prstGeom>
+          <a:noFill/>
+          <a:ln/>
+        </p:spPr>
+        <p:txBody>
+          <a:bodyPr wrap="square" lIns="0" tIns="0" rIns="0" bIns="0" rtlCol="0" anchor="t"/>
+          <a:lstStyle/>
+          <a:p>
+            <a:pPr indent="0" marL="0">
+              <a:buNone/>
+            </a:pPr>
+            <a:r>
+              <a:rPr lang="en-US" sz="1700" dirty="0">
+                <a:solidFill>
+                  <a:srgbClr val="1B1B1B"/>
+                </a:solidFill>
+                <a:latin typeface="Calibri" pitchFamily="34" charset="0"/>
+                <a:ea typeface="Calibri" pitchFamily="34" charset="-122"/>
+                <a:cs typeface="Calibri" pitchFamily="34" charset="-120"/>
+              </a:rPr>
+              <a:t>Check the three boxes. They add up for you.</a:t>
+            </a:r>
+            <a:endParaRPr lang="en-US" sz="1700" dirty="0"/>
+          </a:p>
+        </p:txBody>
+      </p:sp>
+      <p:sp>
+        <p:nvSpPr>
+          <p:cNvPr id="34" name="Shape 31"/>
+          <p:cNvSpPr/>
+          <p:nvPr/>
+        </p:nvSpPr>
+        <p:spPr>
+          <a:xfrm>
+            <a:off x="8458200" y="3922776"/>
+            <a:ext cx="310896" cy="310896"/>
+          </a:xfrm>
+          <a:prstGeom prst="ellipse">
+            <a:avLst/>
+          </a:prstGeom>
+          <a:solidFill>
+            <a:srgbClr val="FFB400"/>
+          </a:solidFill>
+          <a:ln w="9525">
+            <a:solidFill>
+              <a:srgbClr val="111111"/>
+            </a:solidFill>
+            <a:prstDash val="solid"/>
+          </a:ln>
+        </p:spPr>
+      </p:sp>
+      <p:sp>
+        <p:nvSpPr>
+          <p:cNvPr id="35" name="Text 32"/>
+          <p:cNvSpPr txBox="1"/>
+          <p:nvPr/>
+        </p:nvSpPr>
+        <p:spPr>
+          <a:xfrm>
+            <a:off x="8458200" y="3922776"/>
+            <a:ext cx="310896" cy="310896"/>
+          </a:xfrm>
+          <a:prstGeom prst="rect">
+            <a:avLst/>
+          </a:prstGeom>
+          <a:noFill/>
+          <a:ln/>
+        </p:spPr>
+        <p:txBody>
+          <a:bodyPr wrap="square" lIns="0" tIns="0" rIns="0" bIns="0" rtlCol="0" anchor="ctr"/>
+          <a:lstStyle/>
+          <a:p>
+            <a:pPr algn="ctr" indent="0" marL="0">
+              <a:buNone/>
+            </a:pPr>
+            <a:r>
+              <a:rPr lang="en-US" sz="1200" b="1" dirty="0">
+                <a:solidFill>
+                  <a:srgbClr val="111111"/>
+                </a:solidFill>
+                <a:latin typeface="Arial" pitchFamily="34" charset="0"/>
+                <a:ea typeface="Arial" pitchFamily="34" charset="-122"/>
+                <a:cs typeface="Arial" pitchFamily="34" charset="-120"/>
+              </a:rPr>
               <a:t>4</a:t>
             </a:r>
             <a:endParaRPr lang="en-US" sz="1200" dirty="0"/>
@@ -4415,7 +4525,7 @@
       </p:sp>
       <p:sp>
         <p:nvSpPr>
-          <p:cNvPr id="32" name="Text 29"/>
+          <p:cNvPr id="36" name="Text 33"/>
           <p:cNvSpPr txBox="1"/>
           <p:nvPr/>
         </p:nvSpPr>
@@ -4461,6 +4571,137 @@
                 <a:cs typeface="Calibri" pitchFamily="34" charset="-120"/>
               </a:rPr>
               <a:t>Add scrap reason</a:t>
+            </a:r>
+            <a:pPr indent="0" marL="0">
+              <a:buNone/>
+            </a:pPr>
+            <a:r>
+              <a:rPr lang="en-US" sz="1700" dirty="0">
+                <a:solidFill>
+                  <a:srgbClr val="1B1B1B"/>
+                </a:solidFill>
+                <a:latin typeface="Calibri" pitchFamily="34" charset="0"/>
+                <a:ea typeface="Calibri" pitchFamily="34" charset="-122"/>
+                <a:cs typeface="Calibri" pitchFamily="34" charset="-120"/>
+              </a:rPr>
+              <a:t>.</a:t>
+            </a:r>
+            <a:endParaRPr lang="en-US" sz="1700" dirty="0"/>
+          </a:p>
+        </p:txBody>
+      </p:sp>
+      <p:sp>
+        <p:nvSpPr>
+          <p:cNvPr id="37" name="Shape 34"/>
+          <p:cNvSpPr/>
+          <p:nvPr/>
+        </p:nvSpPr>
+        <p:spPr>
+          <a:xfrm>
+            <a:off x="8458200" y="4837176"/>
+            <a:ext cx="310896" cy="310896"/>
+          </a:xfrm>
+          <a:prstGeom prst="ellipse">
+            <a:avLst/>
+          </a:prstGeom>
+          <a:solidFill>
+            <a:srgbClr val="FFB400"/>
+          </a:solidFill>
+          <a:ln w="9525">
+            <a:solidFill>
+              <a:srgbClr val="111111"/>
+            </a:solidFill>
+            <a:prstDash val="solid"/>
+          </a:ln>
+        </p:spPr>
+      </p:sp>
+      <p:sp>
+        <p:nvSpPr>
+          <p:cNvPr id="38" name="Text 35"/>
+          <p:cNvSpPr txBox="1"/>
+          <p:nvPr/>
+        </p:nvSpPr>
+        <p:spPr>
+          <a:xfrm>
+            <a:off x="8458200" y="4837176"/>
+            <a:ext cx="310896" cy="310896"/>
+          </a:xfrm>
+          <a:prstGeom prst="rect">
+            <a:avLst/>
+          </a:prstGeom>
+          <a:noFill/>
+          <a:ln/>
+        </p:spPr>
+        <p:txBody>
+          <a:bodyPr wrap="square" lIns="0" tIns="0" rIns="0" bIns="0" rtlCol="0" anchor="ctr"/>
+          <a:lstStyle/>
+          <a:p>
+            <a:pPr algn="ctr" indent="0" marL="0">
+              <a:buNone/>
+            </a:pPr>
+            <a:r>
+              <a:rPr lang="en-US" sz="1200" b="1" dirty="0">
+                <a:solidFill>
+                  <a:srgbClr val="111111"/>
+                </a:solidFill>
+                <a:latin typeface="Arial" pitchFamily="34" charset="0"/>
+                <a:ea typeface="Arial" pitchFamily="34" charset="-122"/>
+                <a:cs typeface="Arial" pitchFamily="34" charset="-120"/>
+              </a:rPr>
+              <a:t>5</a:t>
+            </a:r>
+            <a:endParaRPr lang="en-US" sz="1200" dirty="0"/>
+          </a:p>
+        </p:txBody>
+      </p:sp>
+      <p:sp>
+        <p:nvSpPr>
+          <p:cNvPr id="39" name="Text 36"/>
+          <p:cNvSpPr txBox="1"/>
+          <p:nvPr/>
+        </p:nvSpPr>
+        <p:spPr>
+          <a:xfrm>
+            <a:off x="8897112" y="4800600"/>
+            <a:ext cx="2898648" cy="822960"/>
+          </a:xfrm>
+          <a:prstGeom prst="rect">
+            <a:avLst/>
+          </a:prstGeom>
+          <a:noFill/>
+          <a:ln/>
+        </p:spPr>
+        <p:txBody>
+          <a:bodyPr wrap="square" lIns="0" tIns="0" rIns="0" bIns="0" rtlCol="0" anchor="t"/>
+          <a:lstStyle/>
+          <a:p>
+            <a:pPr indent="0" marL="0">
+              <a:buNone/>
+            </a:pPr>
+            <a:r>
+              <a:rPr lang="en-US" sz="1700" dirty="0">
+                <a:solidFill>
+                  <a:srgbClr val="1B1B1B"/>
+                </a:solidFill>
+                <a:latin typeface="Calibri" pitchFamily="34" charset="0"/>
+                <a:ea typeface="Calibri" pitchFamily="34" charset="-122"/>
+                <a:cs typeface="Calibri" pitchFamily="34" charset="-120"/>
+              </a:rPr>
+              <a:t>Tap </a:t>
+            </a:r>
+            <a:pPr indent="0" marL="0">
+              <a:buNone/>
+            </a:pPr>
+            <a:r>
+              <a:rPr lang="en-US" sz="1700" b="1" dirty="0">
+                <a:solidFill>
+                  <a:srgbClr val="12263F"/>
+                </a:solidFill>
+                <a:latin typeface="Calibri" pitchFamily="34" charset="0"/>
+                <a:ea typeface="Calibri" pitchFamily="34" charset="-122"/>
+                <a:cs typeface="Calibri" pitchFamily="34" charset="-120"/>
+              </a:rPr>
+              <a:t>Release basket</a:t>
             </a:r>
             <a:pPr indent="0" marL="0">
               <a:buNone/>
@@ -4577,7 +4818,7 @@
                 <a:ea typeface="Calibri" pitchFamily="34" charset="-122"/>
                 <a:cs typeface="Calibri" pitchFamily="34" charset="-120"/>
               </a:rPr>
-              <a:t>Release a full basket (continued)</a:t>
+              <a:t>The press counter number is wrong</a:t>
             </a:r>
             <a:endParaRPr lang="en-US" sz="3200" dirty="0"/>
           </a:p>
@@ -4615,8 +4856,8 @@
         </p:nvSpPr>
         <p:spPr>
           <a:xfrm>
-            <a:off x="5065776" y="3984041"/>
-            <a:ext cx="1780337" cy="570586"/>
+            <a:off x="3062326" y="4079138"/>
+            <a:ext cx="2470709" cy="381305"/>
           </a:xfrm>
           <a:prstGeom prst="rect">
             <a:avLst/>
@@ -4639,8 +4880,8 @@
         </p:nvSpPr>
         <p:spPr>
           <a:xfrm>
-            <a:off x="5074920" y="3993185"/>
-            <a:ext cx="1762049" cy="552298"/>
+            <a:off x="3071470" y="4088282"/>
+            <a:ext cx="2452421" cy="363017"/>
           </a:xfrm>
           <a:prstGeom prst="rect">
             <a:avLst/>
@@ -4661,7 +4902,7 @@
         </p:nvSpPr>
         <p:spPr>
           <a:xfrm>
-            <a:off x="4928616" y="3846881"/>
+            <a:off x="2925166" y="3941978"/>
             <a:ext cx="256032" cy="256032"/>
           </a:xfrm>
           <a:prstGeom prst="ellipse">
@@ -4686,7 +4927,7 @@
         </p:nvSpPr>
         <p:spPr>
           <a:xfrm>
-            <a:off x="4928616" y="3846881"/>
+            <a:off x="2925166" y="3941978"/>
             <a:ext cx="256032" cy="256032"/>
           </a:xfrm>
           <a:prstGeom prst="rect">
@@ -4725,54 +4966,8 @@
         </p:nvSpPr>
         <p:spPr>
           <a:xfrm>
-            <a:off x="1741018" y="4079138"/>
-            <a:ext cx="2470709" cy="381305"/>
-          </a:xfrm>
-          <a:prstGeom prst="rect">
-            <a:avLst/>
-          </a:prstGeom>
-          <a:ln w="31750">
-            <a:solidFill>
-              <a:srgbClr val="000000">
-                <a:alpha val="55000"/>
-              </a:srgbClr>
-            </a:solidFill>
-            <a:prstDash val="solid"/>
-          </a:ln>
-        </p:spPr>
-      </p:sp>
-      <p:sp>
-        <p:nvSpPr>
-          <p:cNvPr id="10" name="Shape 7"/>
-          <p:cNvSpPr/>
-          <p:nvPr/>
-        </p:nvSpPr>
-        <p:spPr>
-          <a:xfrm>
-            <a:off x="1750162" y="4088282"/>
-            <a:ext cx="2452421" cy="363017"/>
-          </a:xfrm>
-          <a:prstGeom prst="rect">
-            <a:avLst/>
-          </a:prstGeom>
-          <a:ln w="19050">
-            <a:solidFill>
-              <a:srgbClr val="FFB400"/>
-            </a:solidFill>
-            <a:prstDash val="solid"/>
-          </a:ln>
-        </p:spPr>
-      </p:sp>
-      <p:sp>
-        <p:nvSpPr>
-          <p:cNvPr id="11" name="Shape 8"/>
-          <p:cNvSpPr/>
-          <p:nvPr/>
-        </p:nvSpPr>
-        <p:spPr>
-          <a:xfrm>
-            <a:off x="1603858" y="3941978"/>
-            <a:ext cx="256032" cy="256032"/>
+            <a:off x="8458200" y="1179576"/>
+            <a:ext cx="310896" cy="310896"/>
           </a:xfrm>
           <a:prstGeom prst="ellipse">
             <a:avLst/>
@@ -4790,14 +4985,14 @@
       </p:sp>
       <p:sp>
         <p:nvSpPr>
-          <p:cNvPr id="12" name="Text 9"/>
-          <p:cNvSpPr txBox="1"/>
-          <p:nvPr/>
-        </p:nvSpPr>
-        <p:spPr>
-          <a:xfrm>
-            <a:off x="1603858" y="3941978"/>
-            <a:ext cx="256032" cy="256032"/>
+          <p:cNvPr id="10" name="Text 7"/>
+          <p:cNvSpPr txBox="1"/>
+          <p:nvPr/>
+        </p:nvSpPr>
+        <p:spPr>
+          <a:xfrm>
+            <a:off x="8458200" y="1179576"/>
+            <a:ext cx="310896" cy="310896"/>
           </a:xfrm>
           <a:prstGeom prst="rect">
             <a:avLst/>
@@ -4821,7 +5016,7 @@
                 <a:ea typeface="Arial" pitchFamily="34" charset="-122"/>
                 <a:cs typeface="Arial" pitchFamily="34" charset="-120"/>
               </a:rPr>
-              <a:t>2</a:t>
+              <a:t>1</a:t>
             </a:r>
             <a:endParaRPr lang="en-US" sz="1200" dirty="0"/>
           </a:p>
@@ -4829,71 +5024,7 @@
       </p:sp>
       <p:sp>
         <p:nvSpPr>
-          <p:cNvPr id="13" name="Shape 10"/>
-          <p:cNvSpPr/>
-          <p:nvPr/>
-        </p:nvSpPr>
-        <p:spPr>
-          <a:xfrm>
-            <a:off x="8458200" y="1179576"/>
-            <a:ext cx="310896" cy="310896"/>
-          </a:xfrm>
-          <a:prstGeom prst="ellipse">
-            <a:avLst/>
-          </a:prstGeom>
-          <a:solidFill>
-            <a:srgbClr val="FFB400"/>
-          </a:solidFill>
-          <a:ln w="9525">
-            <a:solidFill>
-              <a:srgbClr val="111111"/>
-            </a:solidFill>
-            <a:prstDash val="solid"/>
-          </a:ln>
-        </p:spPr>
-      </p:sp>
-      <p:sp>
-        <p:nvSpPr>
-          <p:cNvPr id="14" name="Text 11"/>
-          <p:cNvSpPr txBox="1"/>
-          <p:nvPr/>
-        </p:nvSpPr>
-        <p:spPr>
-          <a:xfrm>
-            <a:off x="8458200" y="1179576"/>
-            <a:ext cx="310896" cy="310896"/>
-          </a:xfrm>
-          <a:prstGeom prst="rect">
-            <a:avLst/>
-          </a:prstGeom>
-          <a:noFill/>
-          <a:ln/>
-        </p:spPr>
-        <p:txBody>
-          <a:bodyPr wrap="square" lIns="0" tIns="0" rIns="0" bIns="0" rtlCol="0" anchor="ctr"/>
-          <a:lstStyle/>
-          <a:p>
-            <a:pPr algn="ctr" indent="0" marL="0">
-              <a:buNone/>
-            </a:pPr>
-            <a:r>
-              <a:rPr lang="en-US" sz="1200" b="1" dirty="0">
-                <a:solidFill>
-                  <a:srgbClr val="111111"/>
-                </a:solidFill>
-                <a:latin typeface="Arial" pitchFamily="34" charset="0"/>
-                <a:ea typeface="Arial" pitchFamily="34" charset="-122"/>
-                <a:cs typeface="Arial" pitchFamily="34" charset="-120"/>
-              </a:rPr>
-              <a:t>1</a:t>
-            </a:r>
-            <a:endParaRPr lang="en-US" sz="1200" dirty="0"/>
-          </a:p>
-        </p:txBody>
-      </p:sp>
-      <p:sp>
-        <p:nvSpPr>
-          <p:cNvPr id="15" name="Text 12"/>
+          <p:cNvPr id="11" name="Text 8"/>
           <p:cNvSpPr txBox="1"/>
           <p:nvPr/>
         </p:nvSpPr>
@@ -4924,7 +5055,7 @@
                 <a:ea typeface="Calibri" pitchFamily="34" charset="-122"/>
                 <a:cs typeface="Calibri" pitchFamily="34" charset="-120"/>
               </a:rPr>
-              <a:t>Scroll down in the box. Tap </a:t>
+              <a:t>Press shot counter wrong? Reset it here with </a:t>
             </a:r>
             <a:pPr indent="0" marL="0">
               <a:buNone/>
@@ -4938,152 +5069,7 @@
                 <a:ea typeface="Calibri" pitchFamily="34" charset="-122"/>
                 <a:cs typeface="Calibri" pitchFamily="34" charset="-120"/>
               </a:rPr>
-              <a:t>Release basket</a:t>
-            </a:r>
-            <a:pPr indent="0" marL="0">
-              <a:buNone/>
-            </a:pPr>
-            <a:r>
-              <a:rPr lang="en-US" sz="1700" dirty="0">
-                <a:solidFill>
-                  <a:srgbClr val="1B1B1B"/>
-                </a:solidFill>
-                <a:latin typeface="Calibri" pitchFamily="34" charset="0"/>
-                <a:ea typeface="Calibri" pitchFamily="34" charset="-122"/>
-                <a:cs typeface="Calibri" pitchFamily="34" charset="-120"/>
-              </a:rPr>
-              <a:t>.</a:t>
-            </a:r>
-            <a:endParaRPr lang="en-US" sz="1700" dirty="0"/>
-          </a:p>
-        </p:txBody>
-      </p:sp>
-      <p:sp>
-        <p:nvSpPr>
-          <p:cNvPr id="16" name="Shape 13"/>
-          <p:cNvSpPr/>
-          <p:nvPr/>
-        </p:nvSpPr>
-        <p:spPr>
-          <a:xfrm>
-            <a:off x="8458200" y="2093976"/>
-            <a:ext cx="310896" cy="310896"/>
-          </a:xfrm>
-          <a:prstGeom prst="ellipse">
-            <a:avLst/>
-          </a:prstGeom>
-          <a:solidFill>
-            <a:srgbClr val="FFB400"/>
-          </a:solidFill>
-          <a:ln w="9525">
-            <a:solidFill>
-              <a:srgbClr val="111111"/>
-            </a:solidFill>
-            <a:prstDash val="solid"/>
-          </a:ln>
-        </p:spPr>
-      </p:sp>
-      <p:sp>
-        <p:nvSpPr>
-          <p:cNvPr id="17" name="Text 14"/>
-          <p:cNvSpPr txBox="1"/>
-          <p:nvPr/>
-        </p:nvSpPr>
-        <p:spPr>
-          <a:xfrm>
-            <a:off x="8458200" y="2093976"/>
-            <a:ext cx="310896" cy="310896"/>
-          </a:xfrm>
-          <a:prstGeom prst="rect">
-            <a:avLst/>
-          </a:prstGeom>
-          <a:noFill/>
-          <a:ln/>
-        </p:spPr>
-        <p:txBody>
-          <a:bodyPr wrap="square" lIns="0" tIns="0" rIns="0" bIns="0" rtlCol="0" anchor="ctr"/>
-          <a:lstStyle/>
-          <a:p>
-            <a:pPr algn="ctr" indent="0" marL="0">
-              <a:buNone/>
-            </a:pPr>
-            <a:r>
-              <a:rPr lang="en-US" sz="1200" b="1" dirty="0">
-                <a:solidFill>
-                  <a:srgbClr val="111111"/>
-                </a:solidFill>
-                <a:latin typeface="Arial" pitchFamily="34" charset="0"/>
-                <a:ea typeface="Arial" pitchFamily="34" charset="-122"/>
-                <a:cs typeface="Arial" pitchFamily="34" charset="-120"/>
-              </a:rPr>
-              <a:t>2</a:t>
-            </a:r>
-            <a:endParaRPr lang="en-US" sz="1200" dirty="0"/>
-          </a:p>
-        </p:txBody>
-      </p:sp>
-      <p:sp>
-        <p:nvSpPr>
-          <p:cNvPr id="18" name="Text 15"/>
-          <p:cNvSpPr txBox="1"/>
-          <p:nvPr/>
-        </p:nvSpPr>
-        <p:spPr>
-          <a:xfrm>
-            <a:off x="8897112" y="2057400"/>
-            <a:ext cx="2898648" cy="822960"/>
-          </a:xfrm>
-          <a:prstGeom prst="rect">
-            <a:avLst/>
-          </a:prstGeom>
-          <a:noFill/>
-          <a:ln/>
-        </p:spPr>
-        <p:txBody>
-          <a:bodyPr wrap="square" lIns="0" tIns="0" rIns="0" bIns="0" rtlCol="0" anchor="t"/>
-          <a:lstStyle/>
-          <a:p>
-            <a:pPr indent="0" marL="0">
-              <a:buNone/>
-            </a:pPr>
-            <a:r>
-              <a:rPr lang="en-US" sz="1700" dirty="0">
-                <a:solidFill>
-                  <a:srgbClr val="1B1B1B"/>
-                </a:solidFill>
-                <a:latin typeface="Calibri" pitchFamily="34" charset="0"/>
-                <a:ea typeface="Calibri" pitchFamily="34" charset="-122"/>
-                <a:cs typeface="Calibri" pitchFamily="34" charset="-120"/>
-              </a:rPr>
-              <a:t>Counter was reset? Tap </a:t>
-            </a:r>
-            <a:pPr indent="0" marL="0">
-              <a:buNone/>
-            </a:pPr>
-            <a:r>
-              <a:rPr lang="en-US" sz="1700" b="1" dirty="0">
-                <a:solidFill>
-                  <a:srgbClr val="12263F"/>
-                </a:solidFill>
-                <a:latin typeface="Calibri" pitchFamily="34" charset="0"/>
-                <a:ea typeface="Calibri" pitchFamily="34" charset="-122"/>
-                <a:cs typeface="Calibri" pitchFamily="34" charset="-120"/>
-              </a:rPr>
               <a:t>Counter reset / wrong total?</a:t>
-            </a:r>
-            <a:pPr indent="0" marL="0">
-              <a:buNone/>
-            </a:pPr>
-            <a:r>
-              <a:rPr lang="en-US" sz="1700" dirty="0">
-                <a:solidFill>
-                  <a:srgbClr val="1B1B1B"/>
-                </a:solidFill>
-                <a:latin typeface="Calibri" pitchFamily="34" charset="0"/>
-                <a:ea typeface="Calibri" pitchFamily="34" charset="-122"/>
-                <a:cs typeface="Calibri" pitchFamily="34" charset="-120"/>
-              </a:rPr>
-              <a:t> here.</a:t>
             </a:r>
             <a:endParaRPr lang="en-US" sz="1700" dirty="0"/>
           </a:p>
@@ -5209,7 +5195,7 @@
         <p:spPr>
           <a:xfrm>
             <a:off x="411480" y="1143000"/>
-            <a:ext cx="7772400" cy="5302606"/>
+            <a:ext cx="7772400" cy="4858207"/>
           </a:xfrm>
           <a:prstGeom prst="rect">
             <a:avLst/>
@@ -5224,8 +5210,8 @@
         </p:nvSpPr>
         <p:spPr>
           <a:xfrm>
-            <a:off x="4910328" y="2999232"/>
-            <a:ext cx="760781" cy="381305"/>
+            <a:off x="538582" y="3280867"/>
+            <a:ext cx="7469734" cy="396850"/>
           </a:xfrm>
           <a:prstGeom prst="rect">
             <a:avLst/>
@@ -5248,8 +5234,8 @@
         </p:nvSpPr>
         <p:spPr>
           <a:xfrm>
-            <a:off x="4919472" y="3008376"/>
-            <a:ext cx="742493" cy="363017"/>
+            <a:off x="547726" y="3290011"/>
+            <a:ext cx="7451446" cy="378562"/>
           </a:xfrm>
           <a:prstGeom prst="rect">
             <a:avLst/>
@@ -5270,7 +5256,7 @@
         </p:nvSpPr>
         <p:spPr>
           <a:xfrm>
-            <a:off x="4773168" y="2862072"/>
+            <a:off x="411480" y="3143707"/>
             <a:ext cx="256032" cy="256032"/>
           </a:xfrm>
           <a:prstGeom prst="ellipse">
@@ -5295,7 +5281,7 @@
         </p:nvSpPr>
         <p:spPr>
           <a:xfrm>
-            <a:off x="4773168" y="2862072"/>
+            <a:off x="411480" y="3143707"/>
             <a:ext cx="256032" cy="256032"/>
           </a:xfrm>
           <a:prstGeom prst="rect">
@@ -5334,8 +5320,8 @@
         </p:nvSpPr>
         <p:spPr>
           <a:xfrm>
-            <a:off x="2924251" y="4044391"/>
-            <a:ext cx="933602" cy="554126"/>
+            <a:off x="6149340" y="3373222"/>
+            <a:ext cx="436169" cy="222199"/>
           </a:xfrm>
           <a:prstGeom prst="rect">
             <a:avLst/>
@@ -5358,8 +5344,8 @@
         </p:nvSpPr>
         <p:spPr>
           <a:xfrm>
-            <a:off x="2933395" y="4053535"/>
-            <a:ext cx="915314" cy="535838"/>
+            <a:off x="6158484" y="3382366"/>
+            <a:ext cx="417881" cy="203911"/>
           </a:xfrm>
           <a:prstGeom prst="rect">
             <a:avLst/>
@@ -5380,7 +5366,7 @@
         </p:nvSpPr>
         <p:spPr>
           <a:xfrm>
-            <a:off x="2787091" y="3907231"/>
+            <a:off x="6012180" y="3236062"/>
             <a:ext cx="256032" cy="256032"/>
           </a:xfrm>
           <a:prstGeom prst="ellipse">
@@ -5405,7 +5391,7 @@
         </p:nvSpPr>
         <p:spPr>
           <a:xfrm>
-            <a:off x="2787091" y="3907231"/>
+            <a:off x="6012180" y="3236062"/>
             <a:ext cx="256032" cy="256032"/>
           </a:xfrm>
           <a:prstGeom prst="rect">
@@ -5444,8 +5430,54 @@
         </p:nvSpPr>
         <p:spPr>
           <a:xfrm>
-            <a:off x="8458200" y="1179576"/>
-            <a:ext cx="310896" cy="310896"/>
+            <a:off x="5031943" y="3961181"/>
+            <a:ext cx="533095" cy="319126"/>
+          </a:xfrm>
+          <a:prstGeom prst="rect">
+            <a:avLst/>
+          </a:prstGeom>
+          <a:ln w="31750">
+            <a:solidFill>
+              <a:srgbClr val="000000">
+                <a:alpha val="55000"/>
+              </a:srgbClr>
+            </a:solidFill>
+            <a:prstDash val="solid"/>
+          </a:ln>
+        </p:spPr>
+      </p:sp>
+      <p:sp>
+        <p:nvSpPr>
+          <p:cNvPr id="14" name="Shape 11"/>
+          <p:cNvSpPr/>
+          <p:nvPr/>
+        </p:nvSpPr>
+        <p:spPr>
+          <a:xfrm>
+            <a:off x="5041087" y="3970325"/>
+            <a:ext cx="514807" cy="300838"/>
+          </a:xfrm>
+          <a:prstGeom prst="rect">
+            <a:avLst/>
+          </a:prstGeom>
+          <a:ln w="19050">
+            <a:solidFill>
+              <a:srgbClr val="FFB400"/>
+            </a:solidFill>
+            <a:prstDash val="solid"/>
+          </a:ln>
+        </p:spPr>
+      </p:sp>
+      <p:sp>
+        <p:nvSpPr>
+          <p:cNvPr id="15" name="Shape 12"/>
+          <p:cNvSpPr/>
+          <p:nvPr/>
+        </p:nvSpPr>
+        <p:spPr>
+          <a:xfrm>
+            <a:off x="4894783" y="3824021"/>
+            <a:ext cx="256032" cy="256032"/>
           </a:xfrm>
           <a:prstGeom prst="ellipse">
             <a:avLst/>
@@ -5463,14 +5495,14 @@
       </p:sp>
       <p:sp>
         <p:nvSpPr>
-          <p:cNvPr id="14" name="Text 11"/>
-          <p:cNvSpPr txBox="1"/>
-          <p:nvPr/>
-        </p:nvSpPr>
-        <p:spPr>
-          <a:xfrm>
-            <a:off x="8458200" y="1179576"/>
-            <a:ext cx="310896" cy="310896"/>
+          <p:cNvPr id="16" name="Text 13"/>
+          <p:cNvSpPr txBox="1"/>
+          <p:nvPr/>
+        </p:nvSpPr>
+        <p:spPr>
+          <a:xfrm>
+            <a:off x="4894783" y="3824021"/>
+            <a:ext cx="256032" cy="256032"/>
           </a:xfrm>
           <a:prstGeom prst="rect">
             <a:avLst/>
@@ -5494,7 +5526,7 @@
                 <a:ea typeface="Arial" pitchFamily="34" charset="-122"/>
                 <a:cs typeface="Arial" pitchFamily="34" charset="-120"/>
               </a:rPr>
-              <a:t>1</a:t>
+              <a:t>3</a:t>
             </a:r>
             <a:endParaRPr lang="en-US" sz="1200" dirty="0"/>
           </a:p>
@@ -5502,80 +5534,13 @@
       </p:sp>
       <p:sp>
         <p:nvSpPr>
-          <p:cNvPr id="15" name="Text 12"/>
-          <p:cNvSpPr txBox="1"/>
-          <p:nvPr/>
-        </p:nvSpPr>
-        <p:spPr>
-          <a:xfrm>
-            <a:off x="8897112" y="1143000"/>
-            <a:ext cx="2898648" cy="822960"/>
-          </a:xfrm>
-          <a:prstGeom prst="rect">
-            <a:avLst/>
-          </a:prstGeom>
-          <a:noFill/>
-          <a:ln/>
-        </p:spPr>
-        <p:txBody>
-          <a:bodyPr wrap="square" lIns="0" tIns="0" rIns="0" bIns="0" rtlCol="0" anchor="t"/>
-          <a:lstStyle/>
-          <a:p>
-            <a:pPr indent="0" marL="0">
-              <a:buNone/>
-            </a:pPr>
-            <a:r>
-              <a:rPr lang="en-US" sz="1700" dirty="0">
-                <a:solidFill>
-                  <a:srgbClr val="1B1B1B"/>
-                </a:solidFill>
-                <a:latin typeface="Calibri" pitchFamily="34" charset="0"/>
-                <a:ea typeface="Calibri" pitchFamily="34" charset="-122"/>
-                <a:cs typeface="Calibri" pitchFamily="34" charset="-120"/>
-              </a:rPr>
-              <a:t>Tap </a:t>
-            </a:r>
-            <a:pPr indent="0" marL="0">
-              <a:buNone/>
-            </a:pPr>
-            <a:r>
-              <a:rPr lang="en-US" sz="1700" b="1" dirty="0">
-                <a:solidFill>
-                  <a:srgbClr val="12263F"/>
-                </a:solidFill>
-                <a:latin typeface="Calibri" pitchFamily="34" charset="0"/>
-                <a:ea typeface="Calibri" pitchFamily="34" charset="-122"/>
-                <a:cs typeface="Calibri" pitchFamily="34" charset="-120"/>
-              </a:rPr>
-              <a:t>Void</a:t>
-            </a:r>
-            <a:pPr indent="0" marL="0">
-              <a:buNone/>
-            </a:pPr>
-            <a:r>
-              <a:rPr lang="en-US" sz="1700" dirty="0">
-                <a:solidFill>
-                  <a:srgbClr val="1B1B1B"/>
-                </a:solidFill>
-                <a:latin typeface="Calibri" pitchFamily="34" charset="0"/>
-                <a:ea typeface="Calibri" pitchFamily="34" charset="-122"/>
-                <a:cs typeface="Calibri" pitchFamily="34" charset="-120"/>
-              </a:rPr>
-              <a:t> on the basket.</a:t>
-            </a:r>
-            <a:endParaRPr lang="en-US" sz="1700" dirty="0"/>
-          </a:p>
-        </p:txBody>
-      </p:sp>
-      <p:sp>
-        <p:nvSpPr>
-          <p:cNvPr id="16" name="Shape 13"/>
-          <p:cNvSpPr/>
-          <p:nvPr/>
-        </p:nvSpPr>
-        <p:spPr>
-          <a:xfrm>
-            <a:off x="8458200" y="2093976"/>
+          <p:cNvPr id="17" name="Shape 14"/>
+          <p:cNvSpPr/>
+          <p:nvPr/>
+        </p:nvSpPr>
+        <p:spPr>
+          <a:xfrm>
+            <a:off x="8458200" y="1179576"/>
             <a:ext cx="310896" cy="310896"/>
           </a:xfrm>
           <a:prstGeom prst="ellipse">
@@ -5594,13 +5559,13 @@
       </p:sp>
       <p:sp>
         <p:nvSpPr>
-          <p:cNvPr id="17" name="Text 14"/>
-          <p:cNvSpPr txBox="1"/>
-          <p:nvPr/>
-        </p:nvSpPr>
-        <p:spPr>
-          <a:xfrm>
-            <a:off x="8458200" y="2093976"/>
+          <p:cNvPr id="18" name="Text 15"/>
+          <p:cNvSpPr txBox="1"/>
+          <p:nvPr/>
+        </p:nvSpPr>
+        <p:spPr>
+          <a:xfrm>
+            <a:off x="8458200" y="1179576"/>
             <a:ext cx="310896" cy="310896"/>
           </a:xfrm>
           <a:prstGeom prst="rect">
@@ -5625,6 +5590,137 @@
                 <a:ea typeface="Arial" pitchFamily="34" charset="-122"/>
                 <a:cs typeface="Arial" pitchFamily="34" charset="-120"/>
               </a:rPr>
+              <a:t>1</a:t>
+            </a:r>
+            <a:endParaRPr lang="en-US" sz="1200" dirty="0"/>
+          </a:p>
+        </p:txBody>
+      </p:sp>
+      <p:sp>
+        <p:nvSpPr>
+          <p:cNvPr id="19" name="Text 16"/>
+          <p:cNvSpPr txBox="1"/>
+          <p:nvPr/>
+        </p:nvSpPr>
+        <p:spPr>
+          <a:xfrm>
+            <a:off x="8897112" y="1143000"/>
+            <a:ext cx="2898648" cy="822960"/>
+          </a:xfrm>
+          <a:prstGeom prst="rect">
+            <a:avLst/>
+          </a:prstGeom>
+          <a:noFill/>
+          <a:ln/>
+        </p:spPr>
+        <p:txBody>
+          <a:bodyPr wrap="square" lIns="0" tIns="0" rIns="0" bIns="0" rtlCol="0" anchor="t"/>
+          <a:lstStyle/>
+          <a:p>
+            <a:pPr indent="0" marL="0">
+              <a:buNone/>
+            </a:pPr>
+            <a:r>
+              <a:rPr lang="en-US" sz="1700" dirty="0">
+                <a:solidFill>
+                  <a:srgbClr val="1B1B1B"/>
+                </a:solidFill>
+                <a:latin typeface="Calibri" pitchFamily="34" charset="0"/>
+                <a:ea typeface="Calibri" pitchFamily="34" charset="-122"/>
+                <a:cs typeface="Calibri" pitchFamily="34" charset="-120"/>
+              </a:rPr>
+              <a:t>Find the LOT you want to remove on the </a:t>
+            </a:r>
+            <a:pPr indent="0" marL="0">
+              <a:buNone/>
+            </a:pPr>
+            <a:r>
+              <a:rPr lang="en-US" sz="1700" b="1" dirty="0">
+                <a:solidFill>
+                  <a:srgbClr val="12263F"/>
+                </a:solidFill>
+                <a:latin typeface="Calibri" pitchFamily="34" charset="0"/>
+                <a:ea typeface="Calibri" pitchFamily="34" charset="-122"/>
+                <a:cs typeface="Calibri" pitchFamily="34" charset="-120"/>
+              </a:rPr>
+              <a:t>Lot Management</a:t>
+            </a:r>
+            <a:pPr indent="0" marL="0">
+              <a:buNone/>
+            </a:pPr>
+            <a:r>
+              <a:rPr lang="en-US" sz="1700" dirty="0">
+                <a:solidFill>
+                  <a:srgbClr val="1B1B1B"/>
+                </a:solidFill>
+                <a:latin typeface="Calibri" pitchFamily="34" charset="0"/>
+                <a:ea typeface="Calibri" pitchFamily="34" charset="-122"/>
+                <a:cs typeface="Calibri" pitchFamily="34" charset="-120"/>
+              </a:rPr>
+              <a:t> screen.</a:t>
+            </a:r>
+            <a:endParaRPr lang="en-US" sz="1700" dirty="0"/>
+          </a:p>
+        </p:txBody>
+      </p:sp>
+      <p:sp>
+        <p:nvSpPr>
+          <p:cNvPr id="20" name="Shape 17"/>
+          <p:cNvSpPr/>
+          <p:nvPr/>
+        </p:nvSpPr>
+        <p:spPr>
+          <a:xfrm>
+            <a:off x="8458200" y="2093976"/>
+            <a:ext cx="310896" cy="310896"/>
+          </a:xfrm>
+          <a:prstGeom prst="ellipse">
+            <a:avLst/>
+          </a:prstGeom>
+          <a:solidFill>
+            <a:srgbClr val="FFB400"/>
+          </a:solidFill>
+          <a:ln w="9525">
+            <a:solidFill>
+              <a:srgbClr val="111111"/>
+            </a:solidFill>
+            <a:prstDash val="solid"/>
+          </a:ln>
+        </p:spPr>
+      </p:sp>
+      <p:sp>
+        <p:nvSpPr>
+          <p:cNvPr id="21" name="Text 18"/>
+          <p:cNvSpPr txBox="1"/>
+          <p:nvPr/>
+        </p:nvSpPr>
+        <p:spPr>
+          <a:xfrm>
+            <a:off x="8458200" y="2093976"/>
+            <a:ext cx="310896" cy="310896"/>
+          </a:xfrm>
+          <a:prstGeom prst="rect">
+            <a:avLst/>
+          </a:prstGeom>
+          <a:noFill/>
+          <a:ln/>
+        </p:spPr>
+        <p:txBody>
+          <a:bodyPr wrap="square" lIns="0" tIns="0" rIns="0" bIns="0" rtlCol="0" anchor="ctr"/>
+          <a:lstStyle/>
+          <a:p>
+            <a:pPr algn="ctr" indent="0" marL="0">
+              <a:buNone/>
+            </a:pPr>
+            <a:r>
+              <a:rPr lang="en-US" sz="1200" b="1" dirty="0">
+                <a:solidFill>
+                  <a:srgbClr val="111111"/>
+                </a:solidFill>
+                <a:latin typeface="Arial" pitchFamily="34" charset="0"/>
+                <a:ea typeface="Arial" pitchFamily="34" charset="-122"/>
+                <a:cs typeface="Arial" pitchFamily="34" charset="-120"/>
+              </a:rPr>
               <a:t>2</a:t>
             </a:r>
             <a:endParaRPr lang="en-US" sz="1200" dirty="0"/>
@@ -5633,7 +5729,7 @@
       </p:sp>
       <p:sp>
         <p:nvSpPr>
-          <p:cNvPr id="18" name="Text 15"/>
+          <p:cNvPr id="22" name="Text 19"/>
           <p:cNvSpPr txBox="1"/>
           <p:nvPr/>
         </p:nvSpPr>
@@ -5664,6 +5760,137 @@
                 <a:ea typeface="Calibri" pitchFamily="34" charset="-122"/>
                 <a:cs typeface="Calibri" pitchFamily="34" charset="-120"/>
               </a:rPr>
+              <a:t>Tap </a:t>
+            </a:r>
+            <a:pPr indent="0" marL="0">
+              <a:buNone/>
+            </a:pPr>
+            <a:r>
+              <a:rPr lang="en-US" sz="1700" b="1" dirty="0">
+                <a:solidFill>
+                  <a:srgbClr val="12263F"/>
+                </a:solidFill>
+                <a:latin typeface="Calibri" pitchFamily="34" charset="0"/>
+                <a:ea typeface="Calibri" pitchFamily="34" charset="-122"/>
+                <a:cs typeface="Calibri" pitchFamily="34" charset="-120"/>
+              </a:rPr>
+              <a:t>Void</a:t>
+            </a:r>
+            <a:pPr indent="0" marL="0">
+              <a:buNone/>
+            </a:pPr>
+            <a:r>
+              <a:rPr lang="en-US" sz="1700" dirty="0">
+                <a:solidFill>
+                  <a:srgbClr val="1B1B1B"/>
+                </a:solidFill>
+                <a:latin typeface="Calibri" pitchFamily="34" charset="0"/>
+                <a:ea typeface="Calibri" pitchFamily="34" charset="-122"/>
+                <a:cs typeface="Calibri" pitchFamily="34" charset="-120"/>
+              </a:rPr>
+              <a:t> on that row.</a:t>
+            </a:r>
+            <a:endParaRPr lang="en-US" sz="1700" dirty="0"/>
+          </a:p>
+        </p:txBody>
+      </p:sp>
+      <p:sp>
+        <p:nvSpPr>
+          <p:cNvPr id="23" name="Shape 20"/>
+          <p:cNvSpPr/>
+          <p:nvPr/>
+        </p:nvSpPr>
+        <p:spPr>
+          <a:xfrm>
+            <a:off x="8458200" y="3008376"/>
+            <a:ext cx="310896" cy="310896"/>
+          </a:xfrm>
+          <a:prstGeom prst="ellipse">
+            <a:avLst/>
+          </a:prstGeom>
+          <a:solidFill>
+            <a:srgbClr val="FFB400"/>
+          </a:solidFill>
+          <a:ln w="9525">
+            <a:solidFill>
+              <a:srgbClr val="111111"/>
+            </a:solidFill>
+            <a:prstDash val="solid"/>
+          </a:ln>
+        </p:spPr>
+      </p:sp>
+      <p:sp>
+        <p:nvSpPr>
+          <p:cNvPr id="24" name="Text 21"/>
+          <p:cNvSpPr txBox="1"/>
+          <p:nvPr/>
+        </p:nvSpPr>
+        <p:spPr>
+          <a:xfrm>
+            <a:off x="8458200" y="3008376"/>
+            <a:ext cx="310896" cy="310896"/>
+          </a:xfrm>
+          <a:prstGeom prst="rect">
+            <a:avLst/>
+          </a:prstGeom>
+          <a:noFill/>
+          <a:ln/>
+        </p:spPr>
+        <p:txBody>
+          <a:bodyPr wrap="square" lIns="0" tIns="0" rIns="0" bIns="0" rtlCol="0" anchor="ctr"/>
+          <a:lstStyle/>
+          <a:p>
+            <a:pPr algn="ctr" indent="0" marL="0">
+              <a:buNone/>
+            </a:pPr>
+            <a:r>
+              <a:rPr lang="en-US" sz="1200" b="1" dirty="0">
+                <a:solidFill>
+                  <a:srgbClr val="111111"/>
+                </a:solidFill>
+                <a:latin typeface="Arial" pitchFamily="34" charset="0"/>
+                <a:ea typeface="Arial" pitchFamily="34" charset="-122"/>
+                <a:cs typeface="Arial" pitchFamily="34" charset="-120"/>
+              </a:rPr>
+              <a:t>3</a:t>
+            </a:r>
+            <a:endParaRPr lang="en-US" sz="1200" dirty="0"/>
+          </a:p>
+        </p:txBody>
+      </p:sp>
+      <p:sp>
+        <p:nvSpPr>
+          <p:cNvPr id="25" name="Text 22"/>
+          <p:cNvSpPr txBox="1"/>
+          <p:nvPr/>
+        </p:nvSpPr>
+        <p:spPr>
+          <a:xfrm>
+            <a:off x="8897112" y="2971800"/>
+            <a:ext cx="2898648" cy="822960"/>
+          </a:xfrm>
+          <a:prstGeom prst="rect">
+            <a:avLst/>
+          </a:prstGeom>
+          <a:noFill/>
+          <a:ln/>
+        </p:spPr>
+        <p:txBody>
+          <a:bodyPr wrap="square" lIns="0" tIns="0" rIns="0" bIns="0" rtlCol="0" anchor="t"/>
+          <a:lstStyle/>
+          <a:p>
+            <a:pPr indent="0" marL="0">
+              <a:buNone/>
+            </a:pPr>
+            <a:r>
+              <a:rPr lang="en-US" sz="1700" dirty="0">
+                <a:solidFill>
+                  <a:srgbClr val="1B1B1B"/>
+                </a:solidFill>
+                <a:latin typeface="Calibri" pitchFamily="34" charset="0"/>
+                <a:ea typeface="Calibri" pitchFamily="34" charset="-122"/>
+                <a:cs typeface="Calibri" pitchFamily="34" charset="-120"/>
+              </a:rPr>
               <a:t>Check the ticket number. Tap </a:t>
             </a:r>
             <a:pPr indent="0" marL="0">
@@ -5700,13 +5927,13 @@
       </p:sp>
       <p:sp>
         <p:nvSpPr>
-          <p:cNvPr id="19" name="Text 16"/>
-          <p:cNvSpPr txBox="1"/>
-          <p:nvPr/>
-        </p:nvSpPr>
-        <p:spPr>
-          <a:xfrm>
-            <a:off x="8458200" y="3063240"/>
+          <p:cNvPr id="26" name="Text 23"/>
+          <p:cNvSpPr txBox="1"/>
+          <p:nvPr/>
+        </p:nvSpPr>
+        <p:spPr>
+          <a:xfrm>
+            <a:off x="8458200" y="3977640"/>
             <a:ext cx="3337560" cy="822960"/>
           </a:xfrm>
           <a:prstGeom prst="rect">
@@ -5920,7 +6147,145 @@
         </p:nvSpPr>
         <p:spPr>
           <a:xfrm>
-            <a:off x="3809390" y="2153412"/>
+            <a:off x="3783787" y="2144268"/>
+            <a:ext cx="4268419" cy="159106"/>
+          </a:xfrm>
+          <a:prstGeom prst="rect">
+            <a:avLst/>
+          </a:prstGeom>
+          <a:ln w="31750">
+            <a:solidFill>
+              <a:srgbClr val="000000">
+                <a:alpha val="55000"/>
+              </a:srgbClr>
+            </a:solidFill>
+            <a:prstDash val="solid"/>
+          </a:ln>
+        </p:spPr>
+      </p:sp>
+      <p:sp>
+        <p:nvSpPr>
+          <p:cNvPr id="8" name="Shape 5"/>
+          <p:cNvSpPr/>
+          <p:nvPr/>
+        </p:nvSpPr>
+        <p:spPr>
+          <a:xfrm>
+            <a:off x="3792931" y="2153412"/>
+            <a:ext cx="4250131" cy="140818"/>
+          </a:xfrm>
+          <a:prstGeom prst="rect">
+            <a:avLst/>
+          </a:prstGeom>
+          <a:ln w="19050">
+            <a:solidFill>
+              <a:srgbClr val="E67E22"/>
+            </a:solidFill>
+            <a:prstDash val="solid"/>
+          </a:ln>
+        </p:spPr>
+      </p:sp>
+      <p:sp>
+        <p:nvSpPr>
+          <p:cNvPr id="9" name="Shape 6"/>
+          <p:cNvSpPr/>
+          <p:nvPr/>
+        </p:nvSpPr>
+        <p:spPr>
+          <a:xfrm>
+            <a:off x="543154" y="3135478"/>
+            <a:ext cx="7509053" cy="163678"/>
+          </a:xfrm>
+          <a:prstGeom prst="rect">
+            <a:avLst/>
+          </a:prstGeom>
+          <a:ln w="31750">
+            <a:solidFill>
+              <a:srgbClr val="000000">
+                <a:alpha val="55000"/>
+              </a:srgbClr>
+            </a:solidFill>
+            <a:prstDash val="solid"/>
+          </a:ln>
+        </p:spPr>
+      </p:sp>
+      <p:sp>
+        <p:nvSpPr>
+          <p:cNvPr id="10" name="Shape 7"/>
+          <p:cNvSpPr/>
+          <p:nvPr/>
+        </p:nvSpPr>
+        <p:spPr>
+          <a:xfrm>
+            <a:off x="552298" y="3144622"/>
+            <a:ext cx="7490765" cy="145390"/>
+          </a:xfrm>
+          <a:prstGeom prst="rect">
+            <a:avLst/>
+          </a:prstGeom>
+          <a:ln w="19050">
+            <a:solidFill>
+              <a:srgbClr val="8E44AD"/>
+            </a:solidFill>
+            <a:prstDash val="solid"/>
+          </a:ln>
+        </p:spPr>
+      </p:sp>
+      <p:sp>
+        <p:nvSpPr>
+          <p:cNvPr id="11" name="Shape 8"/>
+          <p:cNvSpPr/>
+          <p:nvPr/>
+        </p:nvSpPr>
+        <p:spPr>
+          <a:xfrm>
+            <a:off x="543154" y="5418734"/>
+            <a:ext cx="7509053" cy="450799"/>
+          </a:xfrm>
+          <a:prstGeom prst="rect">
+            <a:avLst/>
+          </a:prstGeom>
+          <a:ln w="31750">
+            <a:solidFill>
+              <a:srgbClr val="000000">
+                <a:alpha val="55000"/>
+              </a:srgbClr>
+            </a:solidFill>
+            <a:prstDash val="solid"/>
+          </a:ln>
+        </p:spPr>
+      </p:sp>
+      <p:sp>
+        <p:nvSpPr>
+          <p:cNvPr id="12" name="Shape 9"/>
+          <p:cNvSpPr/>
+          <p:nvPr/>
+        </p:nvSpPr>
+        <p:spPr>
+          <a:xfrm>
+            <a:off x="552298" y="5427878"/>
+            <a:ext cx="7490765" cy="432511"/>
+          </a:xfrm>
+          <a:prstGeom prst="rect">
+            <a:avLst/>
+          </a:prstGeom>
+          <a:ln w="19050">
+            <a:solidFill>
+              <a:srgbClr val="16A085"/>
+            </a:solidFill>
+            <a:prstDash val="solid"/>
+          </a:ln>
+        </p:spPr>
+      </p:sp>
+      <p:sp>
+        <p:nvSpPr>
+          <p:cNvPr id="13" name="Shape 10"/>
+          <p:cNvSpPr/>
+          <p:nvPr/>
+        </p:nvSpPr>
+        <p:spPr>
+          <a:xfrm>
+            <a:off x="552298" y="1869948"/>
             <a:ext cx="237744" cy="237744"/>
           </a:xfrm>
           <a:prstGeom prst="roundRect">
@@ -5941,13 +6306,13 @@
       </p:sp>
       <p:sp>
         <p:nvSpPr>
-          <p:cNvPr id="8" name="Text 5"/>
-          <p:cNvSpPr txBox="1"/>
-          <p:nvPr/>
-        </p:nvSpPr>
-        <p:spPr>
-          <a:xfrm>
-            <a:off x="3809390" y="2153412"/>
+          <p:cNvPr id="14" name="Text 11"/>
+          <p:cNvSpPr txBox="1"/>
+          <p:nvPr/>
+        </p:nvSpPr>
+        <p:spPr>
+          <a:xfrm>
+            <a:off x="552298" y="1869948"/>
             <a:ext cx="237744" cy="237744"/>
           </a:xfrm>
           <a:prstGeom prst="rect">
@@ -5980,59 +6345,13 @@
       </p:sp>
       <p:sp>
         <p:nvSpPr>
-          <p:cNvPr id="9" name="Shape 6"/>
-          <p:cNvSpPr/>
-          <p:nvPr/>
-        </p:nvSpPr>
-        <p:spPr>
-          <a:xfrm>
-            <a:off x="3783787" y="2144268"/>
-            <a:ext cx="4268419" cy="159106"/>
-          </a:xfrm>
-          <a:prstGeom prst="rect">
-            <a:avLst/>
-          </a:prstGeom>
-          <a:ln w="31750">
-            <a:solidFill>
-              <a:srgbClr val="000000">
-                <a:alpha val="55000"/>
-              </a:srgbClr>
-            </a:solidFill>
-            <a:prstDash val="solid"/>
-          </a:ln>
-        </p:spPr>
-      </p:sp>
-      <p:sp>
-        <p:nvSpPr>
-          <p:cNvPr id="10" name="Shape 7"/>
-          <p:cNvSpPr/>
-          <p:nvPr/>
-        </p:nvSpPr>
-        <p:spPr>
-          <a:xfrm>
-            <a:off x="3792931" y="2153412"/>
-            <a:ext cx="4250131" cy="140818"/>
-          </a:xfrm>
-          <a:prstGeom prst="rect">
-            <a:avLst/>
-          </a:prstGeom>
-          <a:ln w="19050">
-            <a:solidFill>
-              <a:srgbClr val="E67E22"/>
-            </a:solidFill>
-            <a:prstDash val="solid"/>
-          </a:ln>
-        </p:spPr>
-      </p:sp>
-      <p:sp>
-        <p:nvSpPr>
-          <p:cNvPr id="11" name="Shape 8"/>
-          <p:cNvSpPr/>
-          <p:nvPr/>
-        </p:nvSpPr>
-        <p:spPr>
-          <a:xfrm>
-            <a:off x="3829507" y="2189988"/>
+          <p:cNvPr id="15" name="Shape 12"/>
+          <p:cNvSpPr/>
+          <p:nvPr/>
+        </p:nvSpPr>
+        <p:spPr>
+          <a:xfrm>
+            <a:off x="3792931" y="1869948"/>
             <a:ext cx="237744" cy="237744"/>
           </a:xfrm>
           <a:prstGeom prst="roundRect">
@@ -6053,13 +6372,13 @@
       </p:sp>
       <p:sp>
         <p:nvSpPr>
-          <p:cNvPr id="12" name="Text 9"/>
-          <p:cNvSpPr txBox="1"/>
-          <p:nvPr/>
-        </p:nvSpPr>
-        <p:spPr>
-          <a:xfrm>
-            <a:off x="3829507" y="2189988"/>
+          <p:cNvPr id="16" name="Text 13"/>
+          <p:cNvSpPr txBox="1"/>
+          <p:nvPr/>
+        </p:nvSpPr>
+        <p:spPr>
+          <a:xfrm>
+            <a:off x="3792931" y="1869948"/>
             <a:ext cx="237744" cy="237744"/>
           </a:xfrm>
           <a:prstGeom prst="rect">
@@ -6092,59 +6411,13 @@
       </p:sp>
       <p:sp>
         <p:nvSpPr>
-          <p:cNvPr id="13" name="Shape 10"/>
-          <p:cNvSpPr/>
-          <p:nvPr/>
-        </p:nvSpPr>
-        <p:spPr>
-          <a:xfrm>
-            <a:off x="543154" y="3135478"/>
-            <a:ext cx="7509053" cy="163678"/>
-          </a:xfrm>
-          <a:prstGeom prst="rect">
-            <a:avLst/>
-          </a:prstGeom>
-          <a:ln w="31750">
-            <a:solidFill>
-              <a:srgbClr val="000000">
-                <a:alpha val="55000"/>
-              </a:srgbClr>
-            </a:solidFill>
-            <a:prstDash val="solid"/>
-          </a:ln>
-        </p:spPr>
-      </p:sp>
-      <p:sp>
-        <p:nvSpPr>
-          <p:cNvPr id="14" name="Shape 11"/>
-          <p:cNvSpPr/>
-          <p:nvPr/>
-        </p:nvSpPr>
-        <p:spPr>
-          <a:xfrm>
-            <a:off x="552298" y="3144622"/>
-            <a:ext cx="7490765" cy="145390"/>
-          </a:xfrm>
-          <a:prstGeom prst="rect">
-            <a:avLst/>
-          </a:prstGeom>
-          <a:ln w="19050">
-            <a:solidFill>
-              <a:srgbClr val="8E44AD"/>
-            </a:solidFill>
-            <a:prstDash val="solid"/>
-          </a:ln>
-        </p:spPr>
-      </p:sp>
-      <p:sp>
-        <p:nvSpPr>
-          <p:cNvPr id="15" name="Shape 12"/>
-          <p:cNvSpPr/>
-          <p:nvPr/>
-        </p:nvSpPr>
-        <p:spPr>
-          <a:xfrm>
-            <a:off x="588874" y="3181198"/>
+          <p:cNvPr id="17" name="Shape 14"/>
+          <p:cNvSpPr/>
+          <p:nvPr/>
+        </p:nvSpPr>
+        <p:spPr>
+          <a:xfrm>
+            <a:off x="552298" y="2861158"/>
             <a:ext cx="237744" cy="237744"/>
           </a:xfrm>
           <a:prstGeom prst="roundRect">
@@ -6165,13 +6438,13 @@
       </p:sp>
       <p:sp>
         <p:nvSpPr>
-          <p:cNvPr id="16" name="Text 13"/>
-          <p:cNvSpPr txBox="1"/>
-          <p:nvPr/>
-        </p:nvSpPr>
-        <p:spPr>
-          <a:xfrm>
-            <a:off x="588874" y="3181198"/>
+          <p:cNvPr id="18" name="Text 15"/>
+          <p:cNvSpPr txBox="1"/>
+          <p:nvPr/>
+        </p:nvSpPr>
+        <p:spPr>
+          <a:xfrm>
+            <a:off x="552298" y="2861158"/>
             <a:ext cx="237744" cy="237744"/>
           </a:xfrm>
           <a:prstGeom prst="rect">
@@ -6204,59 +6477,13 @@
       </p:sp>
       <p:sp>
         <p:nvSpPr>
-          <p:cNvPr id="17" name="Shape 14"/>
-          <p:cNvSpPr/>
-          <p:nvPr/>
-        </p:nvSpPr>
-        <p:spPr>
-          <a:xfrm>
-            <a:off x="543154" y="5418734"/>
-            <a:ext cx="7509053" cy="450799"/>
-          </a:xfrm>
-          <a:prstGeom prst="rect">
-            <a:avLst/>
-          </a:prstGeom>
-          <a:ln w="31750">
-            <a:solidFill>
-              <a:srgbClr val="000000">
-                <a:alpha val="55000"/>
-              </a:srgbClr>
-            </a:solidFill>
-            <a:prstDash val="solid"/>
-          </a:ln>
-        </p:spPr>
-      </p:sp>
-      <p:sp>
-        <p:nvSpPr>
-          <p:cNvPr id="18" name="Shape 15"/>
-          <p:cNvSpPr/>
-          <p:nvPr/>
-        </p:nvSpPr>
-        <p:spPr>
-          <a:xfrm>
-            <a:off x="552298" y="5427878"/>
-            <a:ext cx="7490765" cy="432511"/>
-          </a:xfrm>
-          <a:prstGeom prst="rect">
-            <a:avLst/>
-          </a:prstGeom>
-          <a:ln w="19050">
-            <a:solidFill>
-              <a:srgbClr val="16A085"/>
-            </a:solidFill>
-            <a:prstDash val="solid"/>
-          </a:ln>
-        </p:spPr>
-      </p:sp>
-      <p:sp>
-        <p:nvSpPr>
           <p:cNvPr id="19" name="Shape 16"/>
           <p:cNvSpPr/>
           <p:nvPr/>
         </p:nvSpPr>
         <p:spPr>
           <a:xfrm>
-            <a:off x="588874" y="5464454"/>
+            <a:off x="552298" y="5144414"/>
             <a:ext cx="237744" cy="237744"/>
           </a:xfrm>
           <a:prstGeom prst="roundRect">
@@ -6283,7 +6510,7 @@
         </p:nvSpPr>
         <p:spPr>
           <a:xfrm>
-            <a:off x="588874" y="5464454"/>
+            <a:off x="552298" y="5144414"/>
             <a:ext cx="237744" cy="237744"/>
           </a:xfrm>
           <a:prstGeom prst="rect">
@@ -19025,7 +19252,237 @@
         </p:nvSpPr>
         <p:spPr>
           <a:xfrm>
-            <a:off x="875995" y="1257300"/>
+            <a:off x="2553919" y="1634033"/>
+            <a:ext cx="1505102" cy="213055"/>
+          </a:xfrm>
+          <a:prstGeom prst="rect">
+            <a:avLst/>
+          </a:prstGeom>
+          <a:ln w="31750">
+            <a:solidFill>
+              <a:srgbClr val="000000">
+                <a:alpha val="55000"/>
+              </a:srgbClr>
+            </a:solidFill>
+            <a:prstDash val="solid"/>
+          </a:ln>
+        </p:spPr>
+      </p:sp>
+      <p:sp>
+        <p:nvSpPr>
+          <p:cNvPr id="8" name="Shape 5"/>
+          <p:cNvSpPr/>
+          <p:nvPr/>
+        </p:nvSpPr>
+        <p:spPr>
+          <a:xfrm>
+            <a:off x="2563063" y="1643177"/>
+            <a:ext cx="1486814" cy="194767"/>
+          </a:xfrm>
+          <a:prstGeom prst="rect">
+            <a:avLst/>
+          </a:prstGeom>
+          <a:ln w="19050">
+            <a:solidFill>
+              <a:srgbClr val="E67E22"/>
+            </a:solidFill>
+            <a:prstDash val="solid"/>
+          </a:ln>
+        </p:spPr>
+      </p:sp>
+      <p:sp>
+        <p:nvSpPr>
+          <p:cNvPr id="9" name="Shape 6"/>
+          <p:cNvSpPr/>
+          <p:nvPr/>
+        </p:nvSpPr>
+        <p:spPr>
+          <a:xfrm>
+            <a:off x="427025" y="1858061"/>
+            <a:ext cx="2087575" cy="217627"/>
+          </a:xfrm>
+          <a:prstGeom prst="rect">
+            <a:avLst/>
+          </a:prstGeom>
+          <a:ln w="31750">
+            <a:solidFill>
+              <a:srgbClr val="000000">
+                <a:alpha val="55000"/>
+              </a:srgbClr>
+            </a:solidFill>
+            <a:prstDash val="solid"/>
+          </a:ln>
+        </p:spPr>
+      </p:sp>
+      <p:sp>
+        <p:nvSpPr>
+          <p:cNvPr id="10" name="Shape 7"/>
+          <p:cNvSpPr/>
+          <p:nvPr/>
+        </p:nvSpPr>
+        <p:spPr>
+          <a:xfrm>
+            <a:off x="436169" y="1867205"/>
+            <a:ext cx="2069287" cy="199339"/>
+          </a:xfrm>
+          <a:prstGeom prst="rect">
+            <a:avLst/>
+          </a:prstGeom>
+          <a:ln w="19050">
+            <a:solidFill>
+              <a:srgbClr val="8E44AD"/>
+            </a:solidFill>
+            <a:prstDash val="solid"/>
+          </a:ln>
+        </p:spPr>
+      </p:sp>
+      <p:sp>
+        <p:nvSpPr>
+          <p:cNvPr id="11" name="Shape 8"/>
+          <p:cNvSpPr/>
+          <p:nvPr/>
+        </p:nvSpPr>
+        <p:spPr>
+          <a:xfrm>
+            <a:off x="543154" y="2144268"/>
+            <a:ext cx="7509053" cy="213055"/>
+          </a:xfrm>
+          <a:prstGeom prst="rect">
+            <a:avLst/>
+          </a:prstGeom>
+          <a:ln w="31750">
+            <a:solidFill>
+              <a:srgbClr val="000000">
+                <a:alpha val="55000"/>
+              </a:srgbClr>
+            </a:solidFill>
+            <a:prstDash val="solid"/>
+          </a:ln>
+        </p:spPr>
+      </p:sp>
+      <p:sp>
+        <p:nvSpPr>
+          <p:cNvPr id="12" name="Shape 9"/>
+          <p:cNvSpPr/>
+          <p:nvPr/>
+        </p:nvSpPr>
+        <p:spPr>
+          <a:xfrm>
+            <a:off x="552298" y="2153412"/>
+            <a:ext cx="7490765" cy="194767"/>
+          </a:xfrm>
+          <a:prstGeom prst="rect">
+            <a:avLst/>
+          </a:prstGeom>
+          <a:ln w="19050">
+            <a:solidFill>
+              <a:srgbClr val="16A085"/>
+            </a:solidFill>
+            <a:prstDash val="solid"/>
+          </a:ln>
+        </p:spPr>
+      </p:sp>
+      <p:sp>
+        <p:nvSpPr>
+          <p:cNvPr id="13" name="Shape 10"/>
+          <p:cNvSpPr/>
+          <p:nvPr/>
+        </p:nvSpPr>
+        <p:spPr>
+          <a:xfrm>
+            <a:off x="543154" y="2557577"/>
+            <a:ext cx="7460590" cy="2904134"/>
+          </a:xfrm>
+          <a:prstGeom prst="rect">
+            <a:avLst/>
+          </a:prstGeom>
+          <a:ln w="31750">
+            <a:solidFill>
+              <a:srgbClr val="000000">
+                <a:alpha val="55000"/>
+              </a:srgbClr>
+            </a:solidFill>
+            <a:prstDash val="solid"/>
+          </a:ln>
+        </p:spPr>
+      </p:sp>
+      <p:sp>
+        <p:nvSpPr>
+          <p:cNvPr id="14" name="Shape 11"/>
+          <p:cNvSpPr/>
+          <p:nvPr/>
+        </p:nvSpPr>
+        <p:spPr>
+          <a:xfrm>
+            <a:off x="552298" y="2566721"/>
+            <a:ext cx="7442302" cy="2885846"/>
+          </a:xfrm>
+          <a:prstGeom prst="rect">
+            <a:avLst/>
+          </a:prstGeom>
+          <a:ln w="19050">
+            <a:solidFill>
+              <a:srgbClr val="C0392B"/>
+            </a:solidFill>
+            <a:prstDash val="solid"/>
+          </a:ln>
+        </p:spPr>
+      </p:sp>
+      <p:sp>
+        <p:nvSpPr>
+          <p:cNvPr id="15" name="Shape 12"/>
+          <p:cNvSpPr/>
+          <p:nvPr/>
+        </p:nvSpPr>
+        <p:spPr>
+          <a:xfrm>
+            <a:off x="543154" y="5550408"/>
+            <a:ext cx="3224174" cy="319126"/>
+          </a:xfrm>
+          <a:prstGeom prst="rect">
+            <a:avLst/>
+          </a:prstGeom>
+          <a:ln w="31750">
+            <a:solidFill>
+              <a:srgbClr val="000000">
+                <a:alpha val="55000"/>
+              </a:srgbClr>
+            </a:solidFill>
+            <a:prstDash val="solid"/>
+          </a:ln>
+        </p:spPr>
+      </p:sp>
+      <p:sp>
+        <p:nvSpPr>
+          <p:cNvPr id="16" name="Shape 13"/>
+          <p:cNvSpPr/>
+          <p:nvPr/>
+        </p:nvSpPr>
+        <p:spPr>
+          <a:xfrm>
+            <a:off x="552298" y="5559552"/>
+            <a:ext cx="3205886" cy="300838"/>
+          </a:xfrm>
+          <a:prstGeom prst="rect">
+            <a:avLst/>
+          </a:prstGeom>
+          <a:ln w="19050">
+            <a:solidFill>
+              <a:srgbClr val="B7950B"/>
+            </a:solidFill>
+            <a:prstDash val="solid"/>
+          </a:ln>
+        </p:spPr>
+      </p:sp>
+      <p:sp>
+        <p:nvSpPr>
+          <p:cNvPr id="17" name="Shape 14"/>
+          <p:cNvSpPr/>
+          <p:nvPr/>
+        </p:nvSpPr>
+        <p:spPr>
+          <a:xfrm>
+            <a:off x="555955" y="1233068"/>
             <a:ext cx="237744" cy="237744"/>
           </a:xfrm>
           <a:prstGeom prst="roundRect">
@@ -19046,13 +19503,13 @@
       </p:sp>
       <p:sp>
         <p:nvSpPr>
-          <p:cNvPr id="8" name="Text 5"/>
-          <p:cNvSpPr txBox="1"/>
-          <p:nvPr/>
-        </p:nvSpPr>
-        <p:spPr>
-          <a:xfrm>
-            <a:off x="875995" y="1257300"/>
+          <p:cNvPr id="18" name="Text 15"/>
+          <p:cNvSpPr txBox="1"/>
+          <p:nvPr/>
+        </p:nvSpPr>
+        <p:spPr>
+          <a:xfrm>
+            <a:off x="555955" y="1233068"/>
             <a:ext cx="237744" cy="237744"/>
           </a:xfrm>
           <a:prstGeom prst="rect">
@@ -19085,59 +19542,13 @@
       </p:sp>
       <p:sp>
         <p:nvSpPr>
-          <p:cNvPr id="9" name="Shape 6"/>
-          <p:cNvSpPr/>
-          <p:nvPr/>
-        </p:nvSpPr>
-        <p:spPr>
-          <a:xfrm>
-            <a:off x="2553919" y="1634033"/>
-            <a:ext cx="1505102" cy="213055"/>
-          </a:xfrm>
-          <a:prstGeom prst="rect">
-            <a:avLst/>
-          </a:prstGeom>
-          <a:ln w="31750">
-            <a:solidFill>
-              <a:srgbClr val="000000">
-                <a:alpha val="55000"/>
-              </a:srgbClr>
-            </a:solidFill>
-            <a:prstDash val="solid"/>
-          </a:ln>
-        </p:spPr>
-      </p:sp>
-      <p:sp>
-        <p:nvSpPr>
-          <p:cNvPr id="10" name="Shape 7"/>
-          <p:cNvSpPr/>
-          <p:nvPr/>
-        </p:nvSpPr>
-        <p:spPr>
-          <a:xfrm>
-            <a:off x="2563063" y="1643177"/>
-            <a:ext cx="1486814" cy="194767"/>
-          </a:xfrm>
-          <a:prstGeom prst="rect">
-            <a:avLst/>
-          </a:prstGeom>
-          <a:ln w="19050">
-            <a:solidFill>
-              <a:srgbClr val="E67E22"/>
-            </a:solidFill>
-            <a:prstDash val="solid"/>
-          </a:ln>
-        </p:spPr>
-      </p:sp>
-      <p:sp>
-        <p:nvSpPr>
-          <p:cNvPr id="11" name="Shape 8"/>
-          <p:cNvSpPr/>
-          <p:nvPr/>
-        </p:nvSpPr>
-        <p:spPr>
-          <a:xfrm>
-            <a:off x="4095598" y="1643177"/>
+          <p:cNvPr id="19" name="Shape 16"/>
+          <p:cNvSpPr/>
+          <p:nvPr/>
+        </p:nvSpPr>
+        <p:spPr>
+          <a:xfrm>
+            <a:off x="2279599" y="1621688"/>
             <a:ext cx="237744" cy="237744"/>
           </a:xfrm>
           <a:prstGeom prst="roundRect">
@@ -19158,13 +19569,13 @@
       </p:sp>
       <p:sp>
         <p:nvSpPr>
-          <p:cNvPr id="12" name="Text 9"/>
-          <p:cNvSpPr txBox="1"/>
-          <p:nvPr/>
-        </p:nvSpPr>
-        <p:spPr>
-          <a:xfrm>
-            <a:off x="4095598" y="1643177"/>
+          <p:cNvPr id="20" name="Text 17"/>
+          <p:cNvSpPr txBox="1"/>
+          <p:nvPr/>
+        </p:nvSpPr>
+        <p:spPr>
+          <a:xfrm>
+            <a:off x="2279599" y="1621688"/>
             <a:ext cx="237744" cy="237744"/>
           </a:xfrm>
           <a:prstGeom prst="rect">
@@ -19197,59 +19608,13 @@
       </p:sp>
       <p:sp>
         <p:nvSpPr>
-          <p:cNvPr id="13" name="Shape 10"/>
-          <p:cNvSpPr/>
-          <p:nvPr/>
-        </p:nvSpPr>
-        <p:spPr>
-          <a:xfrm>
-            <a:off x="427025" y="1858061"/>
-            <a:ext cx="2087575" cy="217627"/>
-          </a:xfrm>
-          <a:prstGeom prst="rect">
-            <a:avLst/>
-          </a:prstGeom>
-          <a:ln w="31750">
-            <a:solidFill>
-              <a:srgbClr val="000000">
-                <a:alpha val="55000"/>
-              </a:srgbClr>
-            </a:solidFill>
-            <a:prstDash val="solid"/>
-          </a:ln>
-        </p:spPr>
-      </p:sp>
-      <p:sp>
-        <p:nvSpPr>
-          <p:cNvPr id="14" name="Shape 11"/>
-          <p:cNvSpPr/>
-          <p:nvPr/>
-        </p:nvSpPr>
-        <p:spPr>
-          <a:xfrm>
-            <a:off x="436169" y="1867205"/>
-            <a:ext cx="2069287" cy="199339"/>
-          </a:xfrm>
-          <a:prstGeom prst="rect">
-            <a:avLst/>
-          </a:prstGeom>
-          <a:ln w="19050">
-            <a:solidFill>
-              <a:srgbClr val="8E44AD"/>
-            </a:solidFill>
-            <a:prstDash val="solid"/>
-          </a:ln>
-        </p:spPr>
-      </p:sp>
-      <p:sp>
-        <p:nvSpPr>
-          <p:cNvPr id="15" name="Shape 12"/>
-          <p:cNvSpPr/>
-          <p:nvPr/>
-        </p:nvSpPr>
-        <p:spPr>
-          <a:xfrm>
-            <a:off x="2551176" y="1867205"/>
+          <p:cNvPr id="21" name="Shape 18"/>
+          <p:cNvSpPr/>
+          <p:nvPr/>
+        </p:nvSpPr>
+        <p:spPr>
+          <a:xfrm>
+            <a:off x="436169" y="1583741"/>
             <a:ext cx="237744" cy="237744"/>
           </a:xfrm>
           <a:prstGeom prst="roundRect">
@@ -19270,13 +19635,13 @@
       </p:sp>
       <p:sp>
         <p:nvSpPr>
-          <p:cNvPr id="16" name="Text 13"/>
-          <p:cNvSpPr txBox="1"/>
-          <p:nvPr/>
-        </p:nvSpPr>
-        <p:spPr>
-          <a:xfrm>
-            <a:off x="2551176" y="1867205"/>
+          <p:cNvPr id="22" name="Text 19"/>
+          <p:cNvSpPr txBox="1"/>
+          <p:nvPr/>
+        </p:nvSpPr>
+        <p:spPr>
+          <a:xfrm>
+            <a:off x="436169" y="1583741"/>
             <a:ext cx="237744" cy="237744"/>
           </a:xfrm>
           <a:prstGeom prst="rect">
@@ -19309,59 +19674,13 @@
       </p:sp>
       <p:sp>
         <p:nvSpPr>
-          <p:cNvPr id="17" name="Shape 14"/>
-          <p:cNvSpPr/>
-          <p:nvPr/>
-        </p:nvSpPr>
-        <p:spPr>
-          <a:xfrm>
-            <a:off x="543154" y="2144268"/>
-            <a:ext cx="7509053" cy="213055"/>
-          </a:xfrm>
-          <a:prstGeom prst="rect">
-            <a:avLst/>
-          </a:prstGeom>
-          <a:ln w="31750">
-            <a:solidFill>
-              <a:srgbClr val="000000">
-                <a:alpha val="55000"/>
-              </a:srgbClr>
-            </a:solidFill>
-            <a:prstDash val="solid"/>
-          </a:ln>
-        </p:spPr>
-      </p:sp>
-      <p:sp>
-        <p:nvSpPr>
-          <p:cNvPr id="18" name="Shape 15"/>
-          <p:cNvSpPr/>
-          <p:nvPr/>
-        </p:nvSpPr>
-        <p:spPr>
-          <a:xfrm>
-            <a:off x="552298" y="2153412"/>
-            <a:ext cx="7490765" cy="194767"/>
-          </a:xfrm>
-          <a:prstGeom prst="rect">
-            <a:avLst/>
-          </a:prstGeom>
-          <a:ln w="19050">
-            <a:solidFill>
-              <a:srgbClr val="16A085"/>
-            </a:solidFill>
-            <a:prstDash val="solid"/>
-          </a:ln>
-        </p:spPr>
-      </p:sp>
-      <p:sp>
-        <p:nvSpPr>
-          <p:cNvPr id="19" name="Shape 16"/>
-          <p:cNvSpPr/>
-          <p:nvPr/>
-        </p:nvSpPr>
-        <p:spPr>
-          <a:xfrm>
-            <a:off x="588874" y="2189988"/>
+          <p:cNvPr id="23" name="Shape 20"/>
+          <p:cNvSpPr/>
+          <p:nvPr/>
+        </p:nvSpPr>
+        <p:spPr>
+          <a:xfrm>
+            <a:off x="7805318" y="1869948"/>
             <a:ext cx="237744" cy="237744"/>
           </a:xfrm>
           <a:prstGeom prst="roundRect">
@@ -19382,13 +19701,13 @@
       </p:sp>
       <p:sp>
         <p:nvSpPr>
-          <p:cNvPr id="20" name="Text 17"/>
-          <p:cNvSpPr txBox="1"/>
-          <p:nvPr/>
-        </p:nvSpPr>
-        <p:spPr>
-          <a:xfrm>
-            <a:off x="588874" y="2189988"/>
+          <p:cNvPr id="24" name="Text 21"/>
+          <p:cNvSpPr txBox="1"/>
+          <p:nvPr/>
+        </p:nvSpPr>
+        <p:spPr>
+          <a:xfrm>
+            <a:off x="7805318" y="1869948"/>
             <a:ext cx="237744" cy="237744"/>
           </a:xfrm>
           <a:prstGeom prst="rect">
@@ -19421,59 +19740,13 @@
       </p:sp>
       <p:sp>
         <p:nvSpPr>
-          <p:cNvPr id="21" name="Shape 18"/>
-          <p:cNvSpPr/>
-          <p:nvPr/>
-        </p:nvSpPr>
-        <p:spPr>
-          <a:xfrm>
-            <a:off x="543154" y="2557577"/>
-            <a:ext cx="7460590" cy="2904134"/>
-          </a:xfrm>
-          <a:prstGeom prst="rect">
-            <a:avLst/>
-          </a:prstGeom>
-          <a:ln w="31750">
-            <a:solidFill>
-              <a:srgbClr val="000000">
-                <a:alpha val="55000"/>
-              </a:srgbClr>
-            </a:solidFill>
-            <a:prstDash val="solid"/>
-          </a:ln>
-        </p:spPr>
-      </p:sp>
-      <p:sp>
-        <p:nvSpPr>
-          <p:cNvPr id="22" name="Shape 19"/>
-          <p:cNvSpPr/>
-          <p:nvPr/>
-        </p:nvSpPr>
-        <p:spPr>
-          <a:xfrm>
-            <a:off x="552298" y="2566721"/>
-            <a:ext cx="7442302" cy="2885846"/>
-          </a:xfrm>
-          <a:prstGeom prst="rect">
-            <a:avLst/>
-          </a:prstGeom>
-          <a:ln w="19050">
-            <a:solidFill>
-              <a:srgbClr val="C0392B"/>
-            </a:solidFill>
-            <a:prstDash val="solid"/>
-          </a:ln>
-        </p:spPr>
-      </p:sp>
-      <p:sp>
-        <p:nvSpPr>
-          <p:cNvPr id="23" name="Shape 20"/>
-          <p:cNvSpPr/>
-          <p:nvPr/>
-        </p:nvSpPr>
-        <p:spPr>
-          <a:xfrm>
-            <a:off x="588874" y="2603297"/>
+          <p:cNvPr id="25" name="Shape 22"/>
+          <p:cNvSpPr/>
+          <p:nvPr/>
+        </p:nvSpPr>
+        <p:spPr>
+          <a:xfrm>
+            <a:off x="7756855" y="5498287"/>
             <a:ext cx="237744" cy="237744"/>
           </a:xfrm>
           <a:prstGeom prst="roundRect">
@@ -19494,13 +19767,13 @@
       </p:sp>
       <p:sp>
         <p:nvSpPr>
-          <p:cNvPr id="24" name="Text 21"/>
-          <p:cNvSpPr txBox="1"/>
-          <p:nvPr/>
-        </p:nvSpPr>
-        <p:spPr>
-          <a:xfrm>
-            <a:off x="588874" y="2603297"/>
+          <p:cNvPr id="26" name="Text 23"/>
+          <p:cNvSpPr txBox="1"/>
+          <p:nvPr/>
+        </p:nvSpPr>
+        <p:spPr>
+          <a:xfrm>
+            <a:off x="7756855" y="5498287"/>
             <a:ext cx="237744" cy="237744"/>
           </a:xfrm>
           <a:prstGeom prst="rect">
@@ -19533,59 +19806,13 @@
       </p:sp>
       <p:sp>
         <p:nvSpPr>
-          <p:cNvPr id="25" name="Shape 22"/>
-          <p:cNvSpPr/>
-          <p:nvPr/>
-        </p:nvSpPr>
-        <p:spPr>
-          <a:xfrm>
-            <a:off x="543154" y="5550408"/>
-            <a:ext cx="3224174" cy="319126"/>
-          </a:xfrm>
-          <a:prstGeom prst="rect">
-            <a:avLst/>
-          </a:prstGeom>
-          <a:ln w="31750">
-            <a:solidFill>
-              <a:srgbClr val="000000">
-                <a:alpha val="55000"/>
-              </a:srgbClr>
-            </a:solidFill>
-            <a:prstDash val="solid"/>
-          </a:ln>
-        </p:spPr>
-      </p:sp>
-      <p:sp>
-        <p:nvSpPr>
-          <p:cNvPr id="26" name="Shape 23"/>
-          <p:cNvSpPr/>
-          <p:nvPr/>
-        </p:nvSpPr>
-        <p:spPr>
-          <a:xfrm>
-            <a:off x="552298" y="5559552"/>
-            <a:ext cx="3205886" cy="300838"/>
-          </a:xfrm>
-          <a:prstGeom prst="rect">
-            <a:avLst/>
-          </a:prstGeom>
-          <a:ln w="19050">
-            <a:solidFill>
-              <a:srgbClr val="B7950B"/>
-            </a:solidFill>
-            <a:prstDash val="solid"/>
-          </a:ln>
-        </p:spPr>
-      </p:sp>
-      <p:sp>
-        <p:nvSpPr>
           <p:cNvPr id="27" name="Shape 24"/>
           <p:cNvSpPr/>
           <p:nvPr/>
         </p:nvSpPr>
         <p:spPr>
           <a:xfrm>
-            <a:off x="3803904" y="5591099"/>
+            <a:off x="268834" y="5591099"/>
             <a:ext cx="237744" cy="237744"/>
           </a:xfrm>
           <a:prstGeom prst="roundRect">
@@ -19612,7 +19839,7 @@
         </p:nvSpPr>
         <p:spPr>
           <a:xfrm>
-            <a:off x="3803904" y="5591099"/>
+            <a:off x="268834" y="5591099"/>
             <a:ext cx="237744" cy="237744"/>
           </a:xfrm>
           <a:prstGeom prst="rect">
@@ -21823,7 +22050,7 @@
         <p:spPr>
           <a:xfrm>
             <a:off x="411480" y="1143000"/>
-            <a:ext cx="7772400" cy="5299862"/>
+            <a:ext cx="7772400" cy="5302606"/>
           </a:xfrm>
           <a:prstGeom prst="rect">
             <a:avLst/>
@@ -21838,8 +22065,8 @@
         </p:nvSpPr>
         <p:spPr>
           <a:xfrm>
-            <a:off x="4144975" y="1997050"/>
-            <a:ext cx="2626157" cy="373990"/>
+            <a:off x="2595982" y="2014423"/>
+            <a:ext cx="2678278" cy="381305"/>
           </a:xfrm>
           <a:prstGeom prst="rect">
             <a:avLst/>
@@ -21862,8 +22089,8 @@
         </p:nvSpPr>
         <p:spPr>
           <a:xfrm>
-            <a:off x="4154119" y="2006194"/>
-            <a:ext cx="2607869" cy="355702"/>
+            <a:off x="2605126" y="2023567"/>
+            <a:ext cx="2659990" cy="363017"/>
           </a:xfrm>
           <a:prstGeom prst="rect">
             <a:avLst/>
@@ -21884,7 +22111,7 @@
         </p:nvSpPr>
         <p:spPr>
           <a:xfrm>
-            <a:off x="4007815" y="1859890"/>
+            <a:off x="2458822" y="1877263"/>
             <a:ext cx="256032" cy="256032"/>
           </a:xfrm>
           <a:prstGeom prst="ellipse">
@@ -21909,7 +22136,7 @@
         </p:nvSpPr>
         <p:spPr>
           <a:xfrm>
-            <a:off x="4007815" y="1859890"/>
+            <a:off x="2458822" y="1877263"/>
             <a:ext cx="256032" cy="256032"/>
           </a:xfrm>
           <a:prstGeom prst="rect">
@@ -21948,8 +22175,8 @@
         </p:nvSpPr>
         <p:spPr>
           <a:xfrm>
-            <a:off x="436169" y="1912925"/>
-            <a:ext cx="2820924" cy="543154"/>
+            <a:off x="5324551" y="2049170"/>
+            <a:ext cx="674827" cy="311810"/>
           </a:xfrm>
           <a:prstGeom prst="rect">
             <a:avLst/>
@@ -21972,8 +22199,8 @@
         </p:nvSpPr>
         <p:spPr>
           <a:xfrm>
-            <a:off x="445313" y="1922069"/>
-            <a:ext cx="2802636" cy="524866"/>
+            <a:off x="5333695" y="2058314"/>
+            <a:ext cx="656539" cy="293522"/>
           </a:xfrm>
           <a:prstGeom prst="rect">
             <a:avLst/>
@@ -21994,7 +22221,7 @@
         </p:nvSpPr>
         <p:spPr>
           <a:xfrm>
-            <a:off x="411480" y="1775765"/>
+            <a:off x="5187391" y="1912010"/>
             <a:ext cx="256032" cy="256032"/>
           </a:xfrm>
           <a:prstGeom prst="ellipse">
@@ -22019,7 +22246,7 @@
         </p:nvSpPr>
         <p:spPr>
           <a:xfrm>
-            <a:off x="411480" y="1775765"/>
+            <a:off x="5187391" y="1912010"/>
             <a:ext cx="256032" cy="256032"/>
           </a:xfrm>
           <a:prstGeom prst="rect">
@@ -22250,7 +22477,7 @@
                 <a:ea typeface="Calibri" pitchFamily="34" charset="-122"/>
                 <a:cs typeface="Calibri" pitchFamily="34" charset="-120"/>
               </a:rPr>
-              <a:t>Check the die name. It must match the die in the press.</a:t>
+              <a:t>Check the die name here. It must match the die in the press.</a:t>
             </a:r>
             <a:endParaRPr lang="en-US" sz="1700" dirty="0"/>
           </a:p>
@@ -22761,6 +22988,55 @@
           <p:nvPr/>
         </p:nvSpPr>
         <p:spPr>
+          <a:xfrm flipH="1">
+            <a:off x="2733142" y="2540203"/>
+            <a:ext cx="502920" cy="402336"/>
+          </a:xfrm>
+          <a:prstGeom prst="line">
+            <a:avLst/>
+          </a:prstGeom>
+          <a:noFill/>
+          <a:ln w="57150">
+            <a:solidFill>
+              <a:srgbClr val="000000">
+                <a:alpha val="60000"/>
+              </a:srgbClr>
+            </a:solidFill>
+            <a:prstDash val="solid"/>
+          </a:ln>
+        </p:spPr>
+      </p:sp>
+      <p:sp>
+        <p:nvSpPr>
+          <p:cNvPr id="18" name="Shape 15"/>
+          <p:cNvSpPr/>
+          <p:nvPr/>
+        </p:nvSpPr>
+        <p:spPr>
+          <a:xfrm flipH="1">
+            <a:off x="2733142" y="2540203"/>
+            <a:ext cx="502920" cy="402336"/>
+          </a:xfrm>
+          <a:prstGeom prst="line">
+            <a:avLst/>
+          </a:prstGeom>
+          <a:noFill/>
+          <a:ln w="31750">
+            <a:solidFill>
+              <a:srgbClr val="FFB400"/>
+            </a:solidFill>
+            <a:prstDash val="solid"/>
+            <a:tailEnd type="triangle"/>
+          </a:ln>
+        </p:spPr>
+      </p:sp>
+      <p:sp>
+        <p:nvSpPr>
+          <p:cNvPr id="19" name="Shape 16"/>
+          <p:cNvSpPr/>
+          <p:nvPr/>
+        </p:nvSpPr>
+        <p:spPr>
           <a:xfrm>
             <a:off x="8458200" y="1179576"/>
             <a:ext cx="310896" cy="310896"/>
@@ -22781,7 +23057,7 @@
       </p:sp>
       <p:sp>
         <p:nvSpPr>
-          <p:cNvPr id="18" name="Text 15"/>
+          <p:cNvPr id="20" name="Text 17"/>
           <p:cNvSpPr txBox="1"/>
           <p:nvPr/>
         </p:nvSpPr>
@@ -22820,7 +23096,7 @@
       </p:sp>
       <p:sp>
         <p:nvSpPr>
-          <p:cNvPr id="19" name="Text 16"/>
+          <p:cNvPr id="21" name="Text 18"/>
           <p:cNvSpPr txBox="1"/>
           <p:nvPr/>
         </p:nvSpPr>
@@ -22887,7 +23163,7 @@
       </p:sp>
       <p:sp>
         <p:nvSpPr>
-          <p:cNvPr id="20" name="Shape 17"/>
+          <p:cNvPr id="22" name="Shape 19"/>
           <p:cNvSpPr/>
           <p:nvPr/>
         </p:nvSpPr>
@@ -22912,7 +23188,7 @@
       </p:sp>
       <p:sp>
         <p:nvSpPr>
-          <p:cNvPr id="21" name="Text 18"/>
+          <p:cNvPr id="23" name="Text 20"/>
           <p:cNvSpPr txBox="1"/>
           <p:nvPr/>
         </p:nvSpPr>
@@ -22951,7 +23227,7 @@
       </p:sp>
       <p:sp>
         <p:nvSpPr>
-          <p:cNvPr id="22" name="Text 19"/>
+          <p:cNvPr id="24" name="Text 21"/>
           <p:cNvSpPr txBox="1"/>
           <p:nvPr/>
         </p:nvSpPr>
@@ -23018,7 +23294,7 @@
       </p:sp>
       <p:sp>
         <p:nvSpPr>
-          <p:cNvPr id="23" name="Shape 20"/>
+          <p:cNvPr id="25" name="Shape 22"/>
           <p:cNvSpPr/>
           <p:nvPr/>
         </p:nvSpPr>
@@ -23043,7 +23319,7 @@
       </p:sp>
       <p:sp>
         <p:nvSpPr>
-          <p:cNvPr id="24" name="Text 21"/>
+          <p:cNvPr id="26" name="Text 23"/>
           <p:cNvSpPr txBox="1"/>
           <p:nvPr/>
         </p:nvSpPr>
@@ -23082,7 +23358,7 @@
       </p:sp>
       <p:sp>
         <p:nvSpPr>
-          <p:cNvPr id="25" name="Text 22"/>
+          <p:cNvPr id="27" name="Text 24"/>
           <p:cNvSpPr txBox="1"/>
           <p:nvPr/>
         </p:nvSpPr>
@@ -23149,7 +23425,7 @@
       </p:sp>
       <p:sp>
         <p:nvSpPr>
-          <p:cNvPr id="26" name="Text 23"/>
+          <p:cNvPr id="28" name="Text 25"/>
           <p:cNvSpPr txBox="1"/>
           <p:nvPr/>
         </p:nvSpPr>

</xml_diff>

<commit_message>
feat(training-deck): team lead slides -- Supervisor Access, Die Mount, Reset Terminal, production dashboard
The four placeholders become real slides from Dev captures: the
'Authorize: Supervisor access' and 'Authorize: Die Mount' AD sign-in boxes,
Reset Terminal (signs the operator out at once and brings up the PIN pad, no
confirmation), and the Die Cast Production dashboard with a real entry for
the current shift (7,000 good, submitted on Dev).

Not captured: the Die Mount screen behind the sign-in. The visible-Chrome
session never resolved to the DC1-T1 terminal, so it had no machines to pick.
Dashboard zones and the sign-in box targets were placed from the screenshots.
</commit_message>
<xml_diff>
--- a/docs/training/diecast/MPP_DieCast_Training.pptx
+++ b/docs/training/diecast/MPP_DieCast_Training.pptx
@@ -2026,7 +2026,7 @@
           <a:p>
             <a:r>
               <a:rPr lang="en-US" dirty="0"/>
-              <a:t>Your sign-in covers the protected job you are doing. After five minutes it ends by itself.</a:t>
+              <a:t>Some jobs need a team lead. Use your own account, never someone else's. After five minutes it ends by itself.</a:t>
             </a:r>
             <a:endParaRPr lang="en-US" dirty="0"/>
           </a:p>
@@ -2114,7 +2114,7 @@
           <a:p>
             <a:r>
               <a:rPr lang="en-US" dirty="0"/>
-              <a:t>If the screen shows the wrong die, every basket is saved against the wrong die.</a:t>
+              <a:t>If the screen shows the wrong die, every basket is saved against the wrong die. Check the die name after you finish.</a:t>
             </a:r>
             <a:endParaRPr lang="en-US" dirty="0"/>
           </a:p>
@@ -2202,7 +2202,7 @@
           <a:p>
             <a:r>
               <a:rPr lang="en-US" dirty="0"/>
-              <a:t>The steps, and when not to use it, are added with the screen pictures.</a:t>
+              <a:t>Use it when the screen is stuck, or the wrong person is signed in. Make sure nothing is half done before you tap it.</a:t>
             </a:r>
             <a:endParaRPr lang="en-US" dirty="0"/>
           </a:p>
@@ -2290,7 +2290,7 @@
           <a:p>
             <a:r>
               <a:rPr lang="en-US" dirty="0"/>
-              <a:t>This screen only reads numbers. It never changes anything. Good parts come from the shift entries operators send.</a:t>
+              <a:t>This screen only reads numbers. It never changes anything. Good parts come from the shift entries operators send, so a press with no entry shows nothing.</a:t>
             </a:r>
             <a:endParaRPr lang="en-US" dirty="0"/>
           </a:p>
@@ -16004,16 +16004,86 @@
           </a:p>
         </p:txBody>
       </p:sp>
-      <p:sp>
-        <p:nvSpPr>
-          <p:cNvPr id="4" name="Shape 2"/>
-          <p:cNvSpPr/>
-          <p:nvPr/>
-        </p:nvSpPr>
-        <p:spPr>
-          <a:xfrm>
-            <a:off x="731520" y="1490472"/>
-            <a:ext cx="384048" cy="384048"/>
+      <p:pic>
+        <p:nvPicPr>
+          <p:cNvPr id="4" name="Image 0" descr="Screenshot of the die cast terminal">    </p:cNvPr>
+          <p:cNvPicPr>
+            <a:picLocks noChangeAspect="1"/>
+          </p:cNvPicPr>
+          <p:nvPr/>
+        </p:nvPicPr>
+        <p:blipFill>
+          <a:blip r:embed="rId1"/>
+          <a:stretch>
+            <a:fillRect/>
+          </a:stretch>
+        </p:blipFill>
+        <p:spPr>
+          <a:xfrm>
+            <a:off x="411480" y="1143000"/>
+            <a:ext cx="7772400" cy="5303520"/>
+          </a:xfrm>
+          <a:prstGeom prst="rect">
+            <a:avLst/>
+          </a:prstGeom>
+        </p:spPr>
+      </p:pic>
+      <p:sp>
+        <p:nvSpPr>
+          <p:cNvPr id="5" name="Shape 2"/>
+          <p:cNvSpPr/>
+          <p:nvPr/>
+        </p:nvSpPr>
+        <p:spPr>
+          <a:xfrm>
+            <a:off x="5981090" y="1265530"/>
+            <a:ext cx="1152144" cy="258775"/>
+          </a:xfrm>
+          <a:prstGeom prst="rect">
+            <a:avLst/>
+          </a:prstGeom>
+          <a:ln w="31750">
+            <a:solidFill>
+              <a:srgbClr val="000000">
+                <a:alpha val="55000"/>
+              </a:srgbClr>
+            </a:solidFill>
+            <a:prstDash val="solid"/>
+          </a:ln>
+        </p:spPr>
+      </p:sp>
+      <p:sp>
+        <p:nvSpPr>
+          <p:cNvPr id="6" name="Shape 3"/>
+          <p:cNvSpPr/>
+          <p:nvPr/>
+        </p:nvSpPr>
+        <p:spPr>
+          <a:xfrm>
+            <a:off x="5990234" y="1274674"/>
+            <a:ext cx="1133856" cy="240487"/>
+          </a:xfrm>
+          <a:prstGeom prst="rect">
+            <a:avLst/>
+          </a:prstGeom>
+          <a:ln w="19050">
+            <a:solidFill>
+              <a:srgbClr val="FFB400"/>
+            </a:solidFill>
+            <a:prstDash val="solid"/>
+          </a:ln>
+        </p:spPr>
+      </p:sp>
+      <p:sp>
+        <p:nvSpPr>
+          <p:cNvPr id="7" name="Shape 4"/>
+          <p:cNvSpPr/>
+          <p:nvPr/>
+        </p:nvSpPr>
+        <p:spPr>
+          <a:xfrm>
+            <a:off x="5843930" y="1143000"/>
+            <a:ext cx="256032" cy="256032"/>
           </a:xfrm>
           <a:prstGeom prst="ellipse">
             <a:avLst/>
@@ -16031,14 +16101,14 @@
       </p:sp>
       <p:sp>
         <p:nvSpPr>
-          <p:cNvPr id="5" name="Text 3"/>
-          <p:cNvSpPr txBox="1"/>
-          <p:nvPr/>
-        </p:nvSpPr>
-        <p:spPr>
-          <a:xfrm>
-            <a:off x="731520" y="1490472"/>
-            <a:ext cx="384048" cy="384048"/>
+          <p:cNvPr id="8" name="Text 5"/>
+          <p:cNvSpPr txBox="1"/>
+          <p:nvPr/>
+        </p:nvSpPr>
+        <p:spPr>
+          <a:xfrm>
+            <a:off x="5843930" y="1143000"/>
+            <a:ext cx="256032" cy="256032"/>
           </a:xfrm>
           <a:prstGeom prst="rect">
             <a:avLst/>
@@ -16070,53 +16140,60 @@
       </p:sp>
       <p:sp>
         <p:nvSpPr>
-          <p:cNvPr id="6" name="Text 4"/>
-          <p:cNvSpPr txBox="1"/>
-          <p:nvPr/>
-        </p:nvSpPr>
-        <p:spPr>
-          <a:xfrm>
-            <a:off x="1371600" y="1417320"/>
-            <a:ext cx="10241280" cy="640080"/>
-          </a:xfrm>
-          <a:prstGeom prst="rect">
-            <a:avLst/>
-          </a:prstGeom>
-          <a:noFill/>
-          <a:ln/>
-        </p:spPr>
-        <p:txBody>
-          <a:bodyPr wrap="square" lIns="0" tIns="0" rIns="0" bIns="0" rtlCol="0" anchor="ctr"/>
-          <a:lstStyle/>
-          <a:p>
-            <a:pPr indent="0" marL="0">
-              <a:buNone/>
-            </a:pPr>
-            <a:r>
-              <a:rPr lang="en-US" sz="2200" dirty="0">
-                <a:solidFill>
-                  <a:srgbClr val="1B1B1B"/>
-                </a:solidFill>
-                <a:latin typeface="Calibri" pitchFamily="34" charset="0"/>
-                <a:ea typeface="Calibri" pitchFamily="34" charset="-122"/>
-                <a:cs typeface="Calibri" pitchFamily="34" charset="-120"/>
-              </a:rPr>
-              <a:t>Some jobs need a team lead to sign in with their own account.</a:t>
-            </a:r>
-            <a:endParaRPr lang="en-US" sz="2200" dirty="0"/>
-          </a:p>
-        </p:txBody>
-      </p:sp>
-      <p:sp>
-        <p:nvSpPr>
-          <p:cNvPr id="7" name="Shape 5"/>
-          <p:cNvSpPr/>
-          <p:nvPr/>
-        </p:nvSpPr>
-        <p:spPr>
-          <a:xfrm>
-            <a:off x="731520" y="2450592"/>
-            <a:ext cx="384048" cy="384048"/>
+          <p:cNvPr id="9" name="Shape 6"/>
+          <p:cNvSpPr/>
+          <p:nvPr/>
+        </p:nvSpPr>
+        <p:spPr>
+          <a:xfrm>
+            <a:off x="2292401" y="3269894"/>
+            <a:ext cx="2618842" cy="258775"/>
+          </a:xfrm>
+          <a:prstGeom prst="rect">
+            <a:avLst/>
+          </a:prstGeom>
+          <a:ln w="31750">
+            <a:solidFill>
+              <a:srgbClr val="000000">
+                <a:alpha val="55000"/>
+              </a:srgbClr>
+            </a:solidFill>
+            <a:prstDash val="solid"/>
+          </a:ln>
+        </p:spPr>
+      </p:sp>
+      <p:sp>
+        <p:nvSpPr>
+          <p:cNvPr id="10" name="Shape 7"/>
+          <p:cNvSpPr/>
+          <p:nvPr/>
+        </p:nvSpPr>
+        <p:spPr>
+          <a:xfrm>
+            <a:off x="2301545" y="3279038"/>
+            <a:ext cx="2600554" cy="240487"/>
+          </a:xfrm>
+          <a:prstGeom prst="rect">
+            <a:avLst/>
+          </a:prstGeom>
+          <a:ln w="19050">
+            <a:solidFill>
+              <a:srgbClr val="FFB400"/>
+            </a:solidFill>
+            <a:prstDash val="solid"/>
+          </a:ln>
+        </p:spPr>
+      </p:sp>
+      <p:sp>
+        <p:nvSpPr>
+          <p:cNvPr id="11" name="Shape 8"/>
+          <p:cNvSpPr/>
+          <p:nvPr/>
+        </p:nvSpPr>
+        <p:spPr>
+          <a:xfrm>
+            <a:off x="2155241" y="3132734"/>
+            <a:ext cx="256032" cy="256032"/>
           </a:xfrm>
           <a:prstGeom prst="ellipse">
             <a:avLst/>
@@ -16134,14 +16211,14 @@
       </p:sp>
       <p:sp>
         <p:nvSpPr>
-          <p:cNvPr id="8" name="Text 6"/>
-          <p:cNvSpPr txBox="1"/>
-          <p:nvPr/>
-        </p:nvSpPr>
-        <p:spPr>
-          <a:xfrm>
-            <a:off x="731520" y="2450592"/>
-            <a:ext cx="384048" cy="384048"/>
+          <p:cNvPr id="12" name="Text 9"/>
+          <p:cNvSpPr txBox="1"/>
+          <p:nvPr/>
+        </p:nvSpPr>
+        <p:spPr>
+          <a:xfrm>
+            <a:off x="2155241" y="3132734"/>
+            <a:ext cx="256032" cy="256032"/>
           </a:xfrm>
           <a:prstGeom prst="rect">
             <a:avLst/>
@@ -16173,53 +16250,60 @@
       </p:sp>
       <p:sp>
         <p:nvSpPr>
-          <p:cNvPr id="9" name="Text 7"/>
-          <p:cNvSpPr txBox="1"/>
-          <p:nvPr/>
-        </p:nvSpPr>
-        <p:spPr>
-          <a:xfrm>
-            <a:off x="1371600" y="2377440"/>
-            <a:ext cx="10241280" cy="640080"/>
-          </a:xfrm>
-          <a:prstGeom prst="rect">
-            <a:avLst/>
-          </a:prstGeom>
-          <a:noFill/>
-          <a:ln/>
-        </p:spPr>
-        <p:txBody>
-          <a:bodyPr wrap="square" lIns="0" tIns="0" rIns="0" bIns="0" rtlCol="0" anchor="ctr"/>
-          <a:lstStyle/>
-          <a:p>
-            <a:pPr indent="0" marL="0">
-              <a:buNone/>
-            </a:pPr>
-            <a:r>
-              <a:rPr lang="en-US" sz="2200" dirty="0">
-                <a:solidFill>
-                  <a:srgbClr val="1B1B1B"/>
-                </a:solidFill>
-                <a:latin typeface="Calibri" pitchFamily="34" charset="0"/>
-                <a:ea typeface="Calibri" pitchFamily="34" charset="-122"/>
-                <a:cs typeface="Calibri" pitchFamily="34" charset="-120"/>
-              </a:rPr>
-              <a:t>The sign-in lasts five minutes.</a:t>
-            </a:r>
-            <a:endParaRPr lang="en-US" sz="2200" dirty="0"/>
-          </a:p>
-        </p:txBody>
-      </p:sp>
-      <p:sp>
-        <p:nvSpPr>
-          <p:cNvPr id="10" name="Shape 8"/>
-          <p:cNvSpPr/>
-          <p:nvPr/>
-        </p:nvSpPr>
-        <p:spPr>
-          <a:xfrm>
-            <a:off x="731520" y="3410712"/>
-            <a:ext cx="384048" cy="384048"/>
+          <p:cNvPr id="13" name="Shape 10"/>
+          <p:cNvSpPr/>
+          <p:nvPr/>
+        </p:nvSpPr>
+        <p:spPr>
+          <a:xfrm>
+            <a:off x="2292401" y="4015130"/>
+            <a:ext cx="2457907" cy="321869"/>
+          </a:xfrm>
+          <a:prstGeom prst="rect">
+            <a:avLst/>
+          </a:prstGeom>
+          <a:ln w="31750">
+            <a:solidFill>
+              <a:srgbClr val="000000">
+                <a:alpha val="55000"/>
+              </a:srgbClr>
+            </a:solidFill>
+            <a:prstDash val="solid"/>
+          </a:ln>
+        </p:spPr>
+      </p:sp>
+      <p:sp>
+        <p:nvSpPr>
+          <p:cNvPr id="14" name="Shape 11"/>
+          <p:cNvSpPr/>
+          <p:nvPr/>
+        </p:nvSpPr>
+        <p:spPr>
+          <a:xfrm>
+            <a:off x="2301545" y="4024274"/>
+            <a:ext cx="2439619" cy="303581"/>
+          </a:xfrm>
+          <a:prstGeom prst="rect">
+            <a:avLst/>
+          </a:prstGeom>
+          <a:ln w="19050">
+            <a:solidFill>
+              <a:srgbClr val="FFB400"/>
+            </a:solidFill>
+            <a:prstDash val="solid"/>
+          </a:ln>
+        </p:spPr>
+      </p:sp>
+      <p:sp>
+        <p:nvSpPr>
+          <p:cNvPr id="15" name="Shape 12"/>
+          <p:cNvSpPr/>
+          <p:nvPr/>
+        </p:nvSpPr>
+        <p:spPr>
+          <a:xfrm>
+            <a:off x="2155241" y="3877970"/>
+            <a:ext cx="256032" cy="256032"/>
           </a:xfrm>
           <a:prstGeom prst="ellipse">
             <a:avLst/>
@@ -16237,14 +16321,14 @@
       </p:sp>
       <p:sp>
         <p:nvSpPr>
-          <p:cNvPr id="11" name="Text 9"/>
-          <p:cNvSpPr txBox="1"/>
-          <p:nvPr/>
-        </p:nvSpPr>
-        <p:spPr>
-          <a:xfrm>
-            <a:off x="731520" y="3410712"/>
-            <a:ext cx="384048" cy="384048"/>
+          <p:cNvPr id="16" name="Text 13"/>
+          <p:cNvSpPr txBox="1"/>
+          <p:nvPr/>
+        </p:nvSpPr>
+        <p:spPr>
+          <a:xfrm>
+            <a:off x="2155241" y="3877970"/>
+            <a:ext cx="256032" cy="256032"/>
           </a:xfrm>
           <a:prstGeom prst="rect">
             <a:avLst/>
@@ -16276,14 +16360,85 @@
       </p:sp>
       <p:sp>
         <p:nvSpPr>
-          <p:cNvPr id="12" name="Text 10"/>
-          <p:cNvSpPr txBox="1"/>
-          <p:nvPr/>
-        </p:nvSpPr>
-        <p:spPr>
-          <a:xfrm>
-            <a:off x="1371600" y="3337560"/>
-            <a:ext cx="10241280" cy="640080"/>
+          <p:cNvPr id="17" name="Shape 14"/>
+          <p:cNvSpPr/>
+          <p:nvPr/>
+        </p:nvSpPr>
+        <p:spPr>
+          <a:xfrm>
+            <a:off x="3993185" y="5343754"/>
+            <a:ext cx="917143" cy="258775"/>
+          </a:xfrm>
+          <a:prstGeom prst="rect">
+            <a:avLst/>
+          </a:prstGeom>
+          <a:ln w="31750">
+            <a:solidFill>
+              <a:srgbClr val="000000">
+                <a:alpha val="55000"/>
+              </a:srgbClr>
+            </a:solidFill>
+            <a:prstDash val="solid"/>
+          </a:ln>
+        </p:spPr>
+      </p:sp>
+      <p:sp>
+        <p:nvSpPr>
+          <p:cNvPr id="18" name="Shape 15"/>
+          <p:cNvSpPr/>
+          <p:nvPr/>
+        </p:nvSpPr>
+        <p:spPr>
+          <a:xfrm>
+            <a:off x="4002329" y="5352898"/>
+            <a:ext cx="898855" cy="240487"/>
+          </a:xfrm>
+          <a:prstGeom prst="rect">
+            <a:avLst/>
+          </a:prstGeom>
+          <a:ln w="19050">
+            <a:solidFill>
+              <a:srgbClr val="FFB400"/>
+            </a:solidFill>
+            <a:prstDash val="solid"/>
+          </a:ln>
+        </p:spPr>
+      </p:sp>
+      <p:sp>
+        <p:nvSpPr>
+          <p:cNvPr id="19" name="Shape 16"/>
+          <p:cNvSpPr/>
+          <p:nvPr/>
+        </p:nvSpPr>
+        <p:spPr>
+          <a:xfrm>
+            <a:off x="3856025" y="5206594"/>
+            <a:ext cx="256032" cy="256032"/>
+          </a:xfrm>
+          <a:prstGeom prst="ellipse">
+            <a:avLst/>
+          </a:prstGeom>
+          <a:solidFill>
+            <a:srgbClr val="FFB400"/>
+          </a:solidFill>
+          <a:ln w="9525">
+            <a:solidFill>
+              <a:srgbClr val="111111"/>
+            </a:solidFill>
+            <a:prstDash val="solid"/>
+          </a:ln>
+        </p:spPr>
+      </p:sp>
+      <p:sp>
+        <p:nvSpPr>
+          <p:cNvPr id="20" name="Text 17"/>
+          <p:cNvSpPr txBox="1"/>
+          <p:nvPr/>
+        </p:nvSpPr>
+        <p:spPr>
+          <a:xfrm>
+            <a:off x="3856025" y="5206594"/>
+            <a:ext cx="256032" cy="256032"/>
           </a:xfrm>
           <a:prstGeom prst="rect">
             <a:avLst/>
@@ -16295,11 +16450,114 @@
           <a:bodyPr wrap="square" lIns="0" tIns="0" rIns="0" bIns="0" rtlCol="0" anchor="ctr"/>
           <a:lstStyle/>
           <a:p>
+            <a:pPr algn="ctr" indent="0" marL="0">
+              <a:buNone/>
+            </a:pPr>
+            <a:r>
+              <a:rPr lang="en-US" sz="1200" b="1" dirty="0">
+                <a:solidFill>
+                  <a:srgbClr val="111111"/>
+                </a:solidFill>
+                <a:latin typeface="Arial" pitchFamily="34" charset="0"/>
+                <a:ea typeface="Arial" pitchFamily="34" charset="-122"/>
+                <a:cs typeface="Arial" pitchFamily="34" charset="-120"/>
+              </a:rPr>
+              <a:t>4</a:t>
+            </a:r>
+            <a:endParaRPr lang="en-US" sz="1200" dirty="0"/>
+          </a:p>
+        </p:txBody>
+      </p:sp>
+      <p:sp>
+        <p:nvSpPr>
+          <p:cNvPr id="21" name="Shape 18"/>
+          <p:cNvSpPr/>
+          <p:nvPr/>
+        </p:nvSpPr>
+        <p:spPr>
+          <a:xfrm>
+            <a:off x="8458200" y="1179576"/>
+            <a:ext cx="310896" cy="310896"/>
+          </a:xfrm>
+          <a:prstGeom prst="ellipse">
+            <a:avLst/>
+          </a:prstGeom>
+          <a:solidFill>
+            <a:srgbClr val="FFB400"/>
+          </a:solidFill>
+          <a:ln w="9525">
+            <a:solidFill>
+              <a:srgbClr val="111111"/>
+            </a:solidFill>
+            <a:prstDash val="solid"/>
+          </a:ln>
+        </p:spPr>
+      </p:sp>
+      <p:sp>
+        <p:nvSpPr>
+          <p:cNvPr id="22" name="Text 19"/>
+          <p:cNvSpPr txBox="1"/>
+          <p:nvPr/>
+        </p:nvSpPr>
+        <p:spPr>
+          <a:xfrm>
+            <a:off x="8458200" y="1179576"/>
+            <a:ext cx="310896" cy="310896"/>
+          </a:xfrm>
+          <a:prstGeom prst="rect">
+            <a:avLst/>
+          </a:prstGeom>
+          <a:noFill/>
+          <a:ln/>
+        </p:spPr>
+        <p:txBody>
+          <a:bodyPr wrap="square" lIns="0" tIns="0" rIns="0" bIns="0" rtlCol="0" anchor="ctr"/>
+          <a:lstStyle/>
+          <a:p>
+            <a:pPr algn="ctr" indent="0" marL="0">
+              <a:buNone/>
+            </a:pPr>
+            <a:r>
+              <a:rPr lang="en-US" sz="1200" b="1" dirty="0">
+                <a:solidFill>
+                  <a:srgbClr val="111111"/>
+                </a:solidFill>
+                <a:latin typeface="Arial" pitchFamily="34" charset="0"/>
+                <a:ea typeface="Arial" pitchFamily="34" charset="-122"/>
+                <a:cs typeface="Arial" pitchFamily="34" charset="-120"/>
+              </a:rPr>
+              <a:t>1</a:t>
+            </a:r>
+            <a:endParaRPr lang="en-US" sz="1200" dirty="0"/>
+          </a:p>
+        </p:txBody>
+      </p:sp>
+      <p:sp>
+        <p:nvSpPr>
+          <p:cNvPr id="23" name="Text 20"/>
+          <p:cNvSpPr txBox="1"/>
+          <p:nvPr/>
+        </p:nvSpPr>
+        <p:spPr>
+          <a:xfrm>
+            <a:off x="8897112" y="1143000"/>
+            <a:ext cx="2898648" cy="822960"/>
+          </a:xfrm>
+          <a:prstGeom prst="rect">
+            <a:avLst/>
+          </a:prstGeom>
+          <a:noFill/>
+          <a:ln/>
+        </p:spPr>
+        <p:txBody>
+          <a:bodyPr wrap="square" lIns="0" tIns="0" rIns="0" bIns="0" rtlCol="0" anchor="t"/>
+          <a:lstStyle/>
+          <a:p>
             <a:pPr indent="0" marL="0">
               <a:buNone/>
             </a:pPr>
             <a:r>
-              <a:rPr lang="en-US" sz="2200" dirty="0">
+              <a:rPr lang="en-US" sz="1700" dirty="0">
                 <a:solidFill>
                   <a:srgbClr val="1B1B1B"/>
                 </a:solidFill>
@@ -16307,65 +16565,405 @@
                 <a:ea typeface="Calibri" pitchFamily="34" charset="-122"/>
                 <a:cs typeface="Calibri" pitchFamily="34" charset="-120"/>
               </a:rPr>
-              <a:t>While it lasts, everything done here is saved under your name.</a:t>
-            </a:r>
-            <a:endParaRPr lang="en-US" sz="2200" dirty="0"/>
-          </a:p>
-        </p:txBody>
-      </p:sp>
-      <p:sp>
-        <p:nvSpPr>
-          <p:cNvPr id="13" name="Shape 11"/>
-          <p:cNvSpPr/>
-          <p:nvPr/>
-        </p:nvSpPr>
-        <p:spPr>
-          <a:xfrm>
-            <a:off x="411480" y="5257800"/>
-            <a:ext cx="11338560" cy="868680"/>
-          </a:xfrm>
-          <a:prstGeom prst="roundRect">
-            <a:avLst>
-              <a:gd name="adj" fmla="val 8421"/>
-            </a:avLst>
+              <a:t>Tap </a:t>
+            </a:r>
+            <a:pPr indent="0" marL="0">
+              <a:buNone/>
+            </a:pPr>
+            <a:r>
+              <a:rPr lang="en-US" sz="1700" b="1" dirty="0">
+                <a:solidFill>
+                  <a:srgbClr val="12263F"/>
+                </a:solidFill>
+                <a:latin typeface="Calibri" pitchFamily="34" charset="0"/>
+                <a:ea typeface="Calibri" pitchFamily="34" charset="-122"/>
+                <a:cs typeface="Calibri" pitchFamily="34" charset="-120"/>
+              </a:rPr>
+              <a:t>Supervisor Access</a:t>
+            </a:r>
+            <a:pPr indent="0" marL="0">
+              <a:buNone/>
+            </a:pPr>
+            <a:r>
+              <a:rPr lang="en-US" sz="1700" dirty="0">
+                <a:solidFill>
+                  <a:srgbClr val="1B1B1B"/>
+                </a:solidFill>
+                <a:latin typeface="Calibri" pitchFamily="34" charset="0"/>
+                <a:ea typeface="Calibri" pitchFamily="34" charset="-122"/>
+                <a:cs typeface="Calibri" pitchFamily="34" charset="-120"/>
+              </a:rPr>
+              <a:t>.</a:t>
+            </a:r>
+            <a:endParaRPr lang="en-US" sz="1700" dirty="0"/>
+          </a:p>
+        </p:txBody>
+      </p:sp>
+      <p:sp>
+        <p:nvSpPr>
+          <p:cNvPr id="24" name="Shape 21"/>
+          <p:cNvSpPr/>
+          <p:nvPr/>
+        </p:nvSpPr>
+        <p:spPr>
+          <a:xfrm>
+            <a:off x="8458200" y="2093976"/>
+            <a:ext cx="310896" cy="310896"/>
+          </a:xfrm>
+          <a:prstGeom prst="ellipse">
+            <a:avLst/>
+          </a:prstGeom>
+          <a:solidFill>
+            <a:srgbClr val="FFB400"/>
+          </a:solidFill>
+          <a:ln w="9525">
+            <a:solidFill>
+              <a:srgbClr val="111111"/>
+            </a:solidFill>
+            <a:prstDash val="solid"/>
+          </a:ln>
+        </p:spPr>
+      </p:sp>
+      <p:sp>
+        <p:nvSpPr>
+          <p:cNvPr id="25" name="Text 22"/>
+          <p:cNvSpPr txBox="1"/>
+          <p:nvPr/>
+        </p:nvSpPr>
+        <p:spPr>
+          <a:xfrm>
+            <a:off x="8458200" y="2093976"/>
+            <a:ext cx="310896" cy="310896"/>
+          </a:xfrm>
+          <a:prstGeom prst="rect">
+            <a:avLst/>
+          </a:prstGeom>
+          <a:noFill/>
+          <a:ln/>
+        </p:spPr>
+        <p:txBody>
+          <a:bodyPr wrap="square" lIns="0" tIns="0" rIns="0" bIns="0" rtlCol="0" anchor="ctr"/>
+          <a:lstStyle/>
+          <a:p>
+            <a:pPr algn="ctr" indent="0" marL="0">
+              <a:buNone/>
+            </a:pPr>
+            <a:r>
+              <a:rPr lang="en-US" sz="1200" b="1" dirty="0">
+                <a:solidFill>
+                  <a:srgbClr val="111111"/>
+                </a:solidFill>
+                <a:latin typeface="Arial" pitchFamily="34" charset="0"/>
+                <a:ea typeface="Arial" pitchFamily="34" charset="-122"/>
+                <a:cs typeface="Arial" pitchFamily="34" charset="-120"/>
+              </a:rPr>
+              <a:t>2</a:t>
+            </a:r>
+            <a:endParaRPr lang="en-US" sz="1200" dirty="0"/>
+          </a:p>
+        </p:txBody>
+      </p:sp>
+      <p:sp>
+        <p:nvSpPr>
+          <p:cNvPr id="26" name="Text 23"/>
+          <p:cNvSpPr txBox="1"/>
+          <p:nvPr/>
+        </p:nvSpPr>
+        <p:spPr>
+          <a:xfrm>
+            <a:off x="8897112" y="2057400"/>
+            <a:ext cx="2898648" cy="822960"/>
+          </a:xfrm>
+          <a:prstGeom prst="rect">
+            <a:avLst/>
+          </a:prstGeom>
+          <a:noFill/>
+          <a:ln/>
+        </p:spPr>
+        <p:txBody>
+          <a:bodyPr wrap="square" lIns="0" tIns="0" rIns="0" bIns="0" rtlCol="0" anchor="t"/>
+          <a:lstStyle/>
+          <a:p>
+            <a:pPr indent="0" marL="0">
+              <a:buNone/>
+            </a:pPr>
+            <a:r>
+              <a:rPr lang="en-US" sz="1700" dirty="0">
+                <a:solidFill>
+                  <a:srgbClr val="1B1B1B"/>
+                </a:solidFill>
+                <a:latin typeface="Calibri" pitchFamily="34" charset="0"/>
+                <a:ea typeface="Calibri" pitchFamily="34" charset="-122"/>
+                <a:cs typeface="Calibri" pitchFamily="34" charset="-120"/>
+              </a:rPr>
+              <a:t>Type your own AD user name.</a:t>
+            </a:r>
+            <a:endParaRPr lang="en-US" sz="1700" dirty="0"/>
+          </a:p>
+        </p:txBody>
+      </p:sp>
+      <p:sp>
+        <p:nvSpPr>
+          <p:cNvPr id="27" name="Shape 24"/>
+          <p:cNvSpPr/>
+          <p:nvPr/>
+        </p:nvSpPr>
+        <p:spPr>
+          <a:xfrm>
+            <a:off x="8458200" y="3008376"/>
+            <a:ext cx="310896" cy="310896"/>
+          </a:xfrm>
+          <a:prstGeom prst="ellipse">
+            <a:avLst/>
+          </a:prstGeom>
+          <a:solidFill>
+            <a:srgbClr val="FFB400"/>
+          </a:solidFill>
+          <a:ln w="9525">
+            <a:solidFill>
+              <a:srgbClr val="111111"/>
+            </a:solidFill>
+            <a:prstDash val="solid"/>
+          </a:ln>
+        </p:spPr>
+      </p:sp>
+      <p:sp>
+        <p:nvSpPr>
+          <p:cNvPr id="28" name="Text 25"/>
+          <p:cNvSpPr txBox="1"/>
+          <p:nvPr/>
+        </p:nvSpPr>
+        <p:spPr>
+          <a:xfrm>
+            <a:off x="8458200" y="3008376"/>
+            <a:ext cx="310896" cy="310896"/>
+          </a:xfrm>
+          <a:prstGeom prst="rect">
+            <a:avLst/>
+          </a:prstGeom>
+          <a:noFill/>
+          <a:ln/>
+        </p:spPr>
+        <p:txBody>
+          <a:bodyPr wrap="square" lIns="0" tIns="0" rIns="0" bIns="0" rtlCol="0" anchor="ctr"/>
+          <a:lstStyle/>
+          <a:p>
+            <a:pPr algn="ctr" indent="0" marL="0">
+              <a:buNone/>
+            </a:pPr>
+            <a:r>
+              <a:rPr lang="en-US" sz="1200" b="1" dirty="0">
+                <a:solidFill>
+                  <a:srgbClr val="111111"/>
+                </a:solidFill>
+                <a:latin typeface="Arial" pitchFamily="34" charset="0"/>
+                <a:ea typeface="Arial" pitchFamily="34" charset="-122"/>
+                <a:cs typeface="Arial" pitchFamily="34" charset="-120"/>
+              </a:rPr>
+              <a:t>3</a:t>
+            </a:r>
+            <a:endParaRPr lang="en-US" sz="1200" dirty="0"/>
+          </a:p>
+        </p:txBody>
+      </p:sp>
+      <p:sp>
+        <p:nvSpPr>
+          <p:cNvPr id="29" name="Text 26"/>
+          <p:cNvSpPr txBox="1"/>
+          <p:nvPr/>
+        </p:nvSpPr>
+        <p:spPr>
+          <a:xfrm>
+            <a:off x="8897112" y="2971800"/>
+            <a:ext cx="2898648" cy="822960"/>
+          </a:xfrm>
+          <a:prstGeom prst="rect">
+            <a:avLst/>
+          </a:prstGeom>
+          <a:noFill/>
+          <a:ln/>
+        </p:spPr>
+        <p:txBody>
+          <a:bodyPr wrap="square" lIns="0" tIns="0" rIns="0" bIns="0" rtlCol="0" anchor="t"/>
+          <a:lstStyle/>
+          <a:p>
+            <a:pPr indent="0" marL="0">
+              <a:buNone/>
+            </a:pPr>
+            <a:r>
+              <a:rPr lang="en-US" sz="1700" dirty="0">
+                <a:solidFill>
+                  <a:srgbClr val="1B1B1B"/>
+                </a:solidFill>
+                <a:latin typeface="Calibri" pitchFamily="34" charset="0"/>
+                <a:ea typeface="Calibri" pitchFamily="34" charset="-122"/>
+                <a:cs typeface="Calibri" pitchFamily="34" charset="-120"/>
+              </a:rPr>
+              <a:t>Type your password.</a:t>
+            </a:r>
+            <a:endParaRPr lang="en-US" sz="1700" dirty="0"/>
+          </a:p>
+        </p:txBody>
+      </p:sp>
+      <p:sp>
+        <p:nvSpPr>
+          <p:cNvPr id="30" name="Shape 27"/>
+          <p:cNvSpPr/>
+          <p:nvPr/>
+        </p:nvSpPr>
+        <p:spPr>
+          <a:xfrm>
+            <a:off x="8458200" y="3922776"/>
+            <a:ext cx="310896" cy="310896"/>
+          </a:xfrm>
+          <a:prstGeom prst="ellipse">
+            <a:avLst/>
+          </a:prstGeom>
+          <a:solidFill>
+            <a:srgbClr val="FFB400"/>
+          </a:solidFill>
+          <a:ln w="9525">
+            <a:solidFill>
+              <a:srgbClr val="111111"/>
+            </a:solidFill>
+            <a:prstDash val="solid"/>
+          </a:ln>
+        </p:spPr>
+      </p:sp>
+      <p:sp>
+        <p:nvSpPr>
+          <p:cNvPr id="31" name="Text 28"/>
+          <p:cNvSpPr txBox="1"/>
+          <p:nvPr/>
+        </p:nvSpPr>
+        <p:spPr>
+          <a:xfrm>
+            <a:off x="8458200" y="3922776"/>
+            <a:ext cx="310896" cy="310896"/>
+          </a:xfrm>
+          <a:prstGeom prst="rect">
+            <a:avLst/>
+          </a:prstGeom>
+          <a:noFill/>
+          <a:ln/>
+        </p:spPr>
+        <p:txBody>
+          <a:bodyPr wrap="square" lIns="0" tIns="0" rIns="0" bIns="0" rtlCol="0" anchor="ctr"/>
+          <a:lstStyle/>
+          <a:p>
+            <a:pPr algn="ctr" indent="0" marL="0">
+              <a:buNone/>
+            </a:pPr>
+            <a:r>
+              <a:rPr lang="en-US" sz="1200" b="1" dirty="0">
+                <a:solidFill>
+                  <a:srgbClr val="111111"/>
+                </a:solidFill>
+                <a:latin typeface="Arial" pitchFamily="34" charset="0"/>
+                <a:ea typeface="Arial" pitchFamily="34" charset="-122"/>
+                <a:cs typeface="Arial" pitchFamily="34" charset="-120"/>
+              </a:rPr>
+              <a:t>4</a:t>
+            </a:r>
+            <a:endParaRPr lang="en-US" sz="1200" dirty="0"/>
+          </a:p>
+        </p:txBody>
+      </p:sp>
+      <p:sp>
+        <p:nvSpPr>
+          <p:cNvPr id="32" name="Text 29"/>
+          <p:cNvSpPr txBox="1"/>
+          <p:nvPr/>
+        </p:nvSpPr>
+        <p:spPr>
+          <a:xfrm>
+            <a:off x="8897112" y="3886200"/>
+            <a:ext cx="2898648" cy="822960"/>
+          </a:xfrm>
+          <a:prstGeom prst="rect">
+            <a:avLst/>
+          </a:prstGeom>
+          <a:noFill/>
+          <a:ln/>
+        </p:spPr>
+        <p:txBody>
+          <a:bodyPr wrap="square" lIns="0" tIns="0" rIns="0" bIns="0" rtlCol="0" anchor="t"/>
+          <a:lstStyle/>
+          <a:p>
+            <a:pPr indent="0" marL="0">
+              <a:buNone/>
+            </a:pPr>
+            <a:r>
+              <a:rPr lang="en-US" sz="1700" dirty="0">
+                <a:solidFill>
+                  <a:srgbClr val="1B1B1B"/>
+                </a:solidFill>
+                <a:latin typeface="Calibri" pitchFamily="34" charset="0"/>
+                <a:ea typeface="Calibri" pitchFamily="34" charset="-122"/>
+                <a:cs typeface="Calibri" pitchFamily="34" charset="-120"/>
+              </a:rPr>
+              <a:t>Tap </a:t>
+            </a:r>
+            <a:pPr indent="0" marL="0">
+              <a:buNone/>
+            </a:pPr>
+            <a:r>
+              <a:rPr lang="en-US" sz="1700" b="1" dirty="0">
+                <a:solidFill>
+                  <a:srgbClr val="12263F"/>
+                </a:solidFill>
+                <a:latin typeface="Calibri" pitchFamily="34" charset="0"/>
+                <a:ea typeface="Calibri" pitchFamily="34" charset="-122"/>
+                <a:cs typeface="Calibri" pitchFamily="34" charset="-120"/>
+              </a:rPr>
+              <a:t>Authenticate</a:t>
+            </a:r>
+            <a:pPr indent="0" marL="0">
+              <a:buNone/>
+            </a:pPr>
+            <a:r>
+              <a:rPr lang="en-US" sz="1700" dirty="0">
+                <a:solidFill>
+                  <a:srgbClr val="1B1B1B"/>
+                </a:solidFill>
+                <a:latin typeface="Calibri" pitchFamily="34" charset="0"/>
+                <a:ea typeface="Calibri" pitchFamily="34" charset="-122"/>
+                <a:cs typeface="Calibri" pitchFamily="34" charset="-120"/>
+              </a:rPr>
+              <a:t>.</a:t>
+            </a:r>
+            <a:endParaRPr lang="en-US" sz="1700" dirty="0"/>
+          </a:p>
+        </p:txBody>
+      </p:sp>
+      <p:sp>
+        <p:nvSpPr>
+          <p:cNvPr id="33" name="Text 30"/>
+          <p:cNvSpPr txBox="1"/>
+          <p:nvPr/>
+        </p:nvSpPr>
+        <p:spPr>
+          <a:xfrm>
+            <a:off x="8458200" y="4892040"/>
+            <a:ext cx="3337560" cy="822960"/>
+          </a:xfrm>
+          <a:prstGeom prst="rect">
+            <a:avLst/>
           </a:prstGeom>
           <a:solidFill>
             <a:srgbClr val="EEF2F7"/>
           </a:solidFill>
-          <a:ln w="12700">
-            <a:solidFill>
-              <a:srgbClr val="C9D2DE"/>
-            </a:solidFill>
-            <a:prstDash val="dash"/>
-          </a:ln>
-        </p:spPr>
-      </p:sp>
-      <p:sp>
-        <p:nvSpPr>
-          <p:cNvPr id="14" name="Text 12"/>
-          <p:cNvSpPr txBox="1"/>
-          <p:nvPr/>
-        </p:nvSpPr>
-        <p:spPr>
-          <a:xfrm>
-            <a:off x="685800" y="5257800"/>
-            <a:ext cx="10789920" cy="868680"/>
-          </a:xfrm>
-          <a:prstGeom prst="rect">
-            <a:avLst/>
-          </a:prstGeom>
-          <a:noFill/>
-          <a:ln/>
-        </p:spPr>
-        <p:txBody>
-          <a:bodyPr wrap="square" lIns="0" tIns="0" rIns="0" bIns="0" rtlCol="0" anchor="ctr"/>
+          <a:ln/>
+        </p:spPr>
+        <p:txBody>
+          <a:bodyPr wrap="square" lIns="101600" tIns="101600" rIns="101600" bIns="101600" rtlCol="0" anchor="t"/>
           <a:lstStyle/>
           <a:p>
             <a:pPr indent="0" marL="0">
               <a:buNone/>
             </a:pPr>
             <a:r>
-              <a:rPr lang="en-US" sz="1600" i="1" dirty="0">
+              <a:rPr lang="en-US" sz="1300" dirty="0">
                 <a:solidFill>
                   <a:srgbClr val="5A6472"/>
                 </a:solidFill>
@@ -16373,9 +16971,9 @@
                 <a:ea typeface="Calibri" pitchFamily="34" charset="-122"/>
                 <a:cs typeface="Calibri" pitchFamily="34" charset="-120"/>
               </a:rPr>
-              <a:t>Screen pictures and step-by-step for this job come in the next version of this deck.</a:t>
-            </a:r>
-            <a:endParaRPr lang="en-US" sz="1600" dirty="0"/>
+              <a:t>The sign-in lasts five minutes. Everything done then is saved under your name.</a:t>
+            </a:r>
+            <a:endParaRPr lang="en-US" sz="1300" dirty="0"/>
           </a:p>
         </p:txBody>
       </p:sp>
@@ -16482,16 +17080,86 @@
           </a:p>
         </p:txBody>
       </p:sp>
-      <p:sp>
-        <p:nvSpPr>
-          <p:cNvPr id="4" name="Shape 2"/>
-          <p:cNvSpPr/>
-          <p:nvPr/>
-        </p:nvSpPr>
-        <p:spPr>
-          <a:xfrm>
-            <a:off x="731520" y="1490472"/>
-            <a:ext cx="384048" cy="384048"/>
+      <p:pic>
+        <p:nvPicPr>
+          <p:cNvPr id="4" name="Image 0" descr="Screenshot of the die cast terminal">    </p:cNvPr>
+          <p:cNvPicPr>
+            <a:picLocks noChangeAspect="1"/>
+          </p:cNvPicPr>
+          <p:nvPr/>
+        </p:nvPicPr>
+        <p:blipFill>
+          <a:blip r:embed="rId1"/>
+          <a:stretch>
+            <a:fillRect/>
+          </a:stretch>
+        </p:blipFill>
+        <p:spPr>
+          <a:xfrm>
+            <a:off x="411480" y="1143000"/>
+            <a:ext cx="7772400" cy="5303520"/>
+          </a:xfrm>
+          <a:prstGeom prst="rect">
+            <a:avLst/>
+          </a:prstGeom>
+        </p:spPr>
+      </p:pic>
+      <p:sp>
+        <p:nvSpPr>
+          <p:cNvPr id="5" name="Shape 2"/>
+          <p:cNvSpPr/>
+          <p:nvPr/>
+        </p:nvSpPr>
+        <p:spPr>
+          <a:xfrm>
+            <a:off x="7079285" y="1897380"/>
+            <a:ext cx="927202" cy="297180"/>
+          </a:xfrm>
+          <a:prstGeom prst="rect">
+            <a:avLst/>
+          </a:prstGeom>
+          <a:ln w="31750">
+            <a:solidFill>
+              <a:srgbClr val="000000">
+                <a:alpha val="55000"/>
+              </a:srgbClr>
+            </a:solidFill>
+            <a:prstDash val="solid"/>
+          </a:ln>
+        </p:spPr>
+      </p:sp>
+      <p:sp>
+        <p:nvSpPr>
+          <p:cNvPr id="6" name="Shape 3"/>
+          <p:cNvSpPr/>
+          <p:nvPr/>
+        </p:nvSpPr>
+        <p:spPr>
+          <a:xfrm>
+            <a:off x="7088429" y="1906524"/>
+            <a:ext cx="908914" cy="278892"/>
+          </a:xfrm>
+          <a:prstGeom prst="rect">
+            <a:avLst/>
+          </a:prstGeom>
+          <a:ln w="19050">
+            <a:solidFill>
+              <a:srgbClr val="FFB400"/>
+            </a:solidFill>
+            <a:prstDash val="solid"/>
+          </a:ln>
+        </p:spPr>
+      </p:sp>
+      <p:sp>
+        <p:nvSpPr>
+          <p:cNvPr id="7" name="Shape 4"/>
+          <p:cNvSpPr/>
+          <p:nvPr/>
+        </p:nvSpPr>
+        <p:spPr>
+          <a:xfrm>
+            <a:off x="6942125" y="1760220"/>
+            <a:ext cx="256032" cy="256032"/>
           </a:xfrm>
           <a:prstGeom prst="ellipse">
             <a:avLst/>
@@ -16509,14 +17177,14 @@
       </p:sp>
       <p:sp>
         <p:nvSpPr>
-          <p:cNvPr id="5" name="Text 3"/>
-          <p:cNvSpPr txBox="1"/>
-          <p:nvPr/>
-        </p:nvSpPr>
-        <p:spPr>
-          <a:xfrm>
-            <a:off x="731520" y="1490472"/>
-            <a:ext cx="384048" cy="384048"/>
+          <p:cNvPr id="8" name="Text 5"/>
+          <p:cNvSpPr txBox="1"/>
+          <p:nvPr/>
+        </p:nvSpPr>
+        <p:spPr>
+          <a:xfrm>
+            <a:off x="6942125" y="1760220"/>
+            <a:ext cx="256032" cy="256032"/>
           </a:xfrm>
           <a:prstGeom prst="rect">
             <a:avLst/>
@@ -16548,53 +17216,60 @@
       </p:sp>
       <p:sp>
         <p:nvSpPr>
-          <p:cNvPr id="6" name="Text 4"/>
-          <p:cNvSpPr txBox="1"/>
-          <p:nvPr/>
-        </p:nvSpPr>
-        <p:spPr>
-          <a:xfrm>
-            <a:off x="1371600" y="1417320"/>
-            <a:ext cx="10241280" cy="640080"/>
-          </a:xfrm>
-          <a:prstGeom prst="rect">
-            <a:avLst/>
-          </a:prstGeom>
-          <a:noFill/>
-          <a:ln/>
-        </p:spPr>
-        <p:txBody>
-          <a:bodyPr wrap="square" lIns="0" tIns="0" rIns="0" bIns="0" rtlCol="0" anchor="ctr"/>
-          <a:lstStyle/>
-          <a:p>
-            <a:pPr indent="0" marL="0">
-              <a:buNone/>
-            </a:pPr>
-            <a:r>
-              <a:rPr lang="en-US" sz="2200" dirty="0">
-                <a:solidFill>
-                  <a:srgbClr val="1B1B1B"/>
-                </a:solidFill>
-                <a:latin typeface="Calibri" pitchFamily="34" charset="0"/>
-                <a:ea typeface="Calibri" pitchFamily="34" charset="-122"/>
-                <a:cs typeface="Calibri" pitchFamily="34" charset="-120"/>
-              </a:rPr>
-              <a:t>Use it when a die is changed on a press.</a:t>
-            </a:r>
-            <a:endParaRPr lang="en-US" sz="2200" dirty="0"/>
-          </a:p>
-        </p:txBody>
-      </p:sp>
-      <p:sp>
-        <p:nvSpPr>
-          <p:cNvPr id="7" name="Shape 5"/>
-          <p:cNvSpPr/>
-          <p:nvPr/>
-        </p:nvSpPr>
-        <p:spPr>
-          <a:xfrm>
-            <a:off x="731520" y="2450592"/>
-            <a:ext cx="384048" cy="384048"/>
+          <p:cNvPr id="9" name="Shape 6"/>
+          <p:cNvSpPr/>
+          <p:nvPr/>
+        </p:nvSpPr>
+        <p:spPr>
+          <a:xfrm>
+            <a:off x="1357884" y="2999232"/>
+            <a:ext cx="3031236" cy="297180"/>
+          </a:xfrm>
+          <a:prstGeom prst="rect">
+            <a:avLst/>
+          </a:prstGeom>
+          <a:ln w="31750">
+            <a:solidFill>
+              <a:srgbClr val="000000">
+                <a:alpha val="55000"/>
+              </a:srgbClr>
+            </a:solidFill>
+            <a:prstDash val="solid"/>
+          </a:ln>
+        </p:spPr>
+      </p:sp>
+      <p:sp>
+        <p:nvSpPr>
+          <p:cNvPr id="10" name="Shape 7"/>
+          <p:cNvSpPr/>
+          <p:nvPr/>
+        </p:nvSpPr>
+        <p:spPr>
+          <a:xfrm>
+            <a:off x="1367028" y="3008376"/>
+            <a:ext cx="3012948" cy="278892"/>
+          </a:xfrm>
+          <a:prstGeom prst="rect">
+            <a:avLst/>
+          </a:prstGeom>
+          <a:ln w="19050">
+            <a:solidFill>
+              <a:srgbClr val="FFB400"/>
+            </a:solidFill>
+            <a:prstDash val="solid"/>
+          </a:ln>
+        </p:spPr>
+      </p:sp>
+      <p:sp>
+        <p:nvSpPr>
+          <p:cNvPr id="11" name="Shape 8"/>
+          <p:cNvSpPr/>
+          <p:nvPr/>
+        </p:nvSpPr>
+        <p:spPr>
+          <a:xfrm>
+            <a:off x="1220724" y="2862072"/>
+            <a:ext cx="256032" cy="256032"/>
           </a:xfrm>
           <a:prstGeom prst="ellipse">
             <a:avLst/>
@@ -16612,14 +17287,14 @@
       </p:sp>
       <p:sp>
         <p:nvSpPr>
-          <p:cNvPr id="8" name="Text 6"/>
-          <p:cNvSpPr txBox="1"/>
-          <p:nvPr/>
-        </p:nvSpPr>
-        <p:spPr>
-          <a:xfrm>
-            <a:off x="731520" y="2450592"/>
-            <a:ext cx="384048" cy="384048"/>
+          <p:cNvPr id="12" name="Text 9"/>
+          <p:cNvSpPr txBox="1"/>
+          <p:nvPr/>
+        </p:nvSpPr>
+        <p:spPr>
+          <a:xfrm>
+            <a:off x="1220724" y="2862072"/>
+            <a:ext cx="256032" cy="256032"/>
           </a:xfrm>
           <a:prstGeom prst="rect">
             <a:avLst/>
@@ -16651,14 +17326,85 @@
       </p:sp>
       <p:sp>
         <p:nvSpPr>
-          <p:cNvPr id="9" name="Text 7"/>
-          <p:cNvSpPr txBox="1"/>
-          <p:nvPr/>
-        </p:nvSpPr>
-        <p:spPr>
-          <a:xfrm>
-            <a:off x="1371600" y="2377440"/>
-            <a:ext cx="10241280" cy="640080"/>
+          <p:cNvPr id="13" name="Shape 10"/>
+          <p:cNvSpPr/>
+          <p:nvPr/>
+        </p:nvSpPr>
+        <p:spPr>
+          <a:xfrm>
+            <a:off x="3329330" y="5402275"/>
+            <a:ext cx="1060704" cy="297180"/>
+          </a:xfrm>
+          <a:prstGeom prst="rect">
+            <a:avLst/>
+          </a:prstGeom>
+          <a:ln w="31750">
+            <a:solidFill>
+              <a:srgbClr val="000000">
+                <a:alpha val="55000"/>
+              </a:srgbClr>
+            </a:solidFill>
+            <a:prstDash val="solid"/>
+          </a:ln>
+        </p:spPr>
+      </p:sp>
+      <p:sp>
+        <p:nvSpPr>
+          <p:cNvPr id="14" name="Shape 11"/>
+          <p:cNvSpPr/>
+          <p:nvPr/>
+        </p:nvSpPr>
+        <p:spPr>
+          <a:xfrm>
+            <a:off x="3338474" y="5411419"/>
+            <a:ext cx="1042416" cy="278892"/>
+          </a:xfrm>
+          <a:prstGeom prst="rect">
+            <a:avLst/>
+          </a:prstGeom>
+          <a:ln w="19050">
+            <a:solidFill>
+              <a:srgbClr val="FFB400"/>
+            </a:solidFill>
+            <a:prstDash val="solid"/>
+          </a:ln>
+        </p:spPr>
+      </p:sp>
+      <p:sp>
+        <p:nvSpPr>
+          <p:cNvPr id="15" name="Shape 12"/>
+          <p:cNvSpPr/>
+          <p:nvPr/>
+        </p:nvSpPr>
+        <p:spPr>
+          <a:xfrm>
+            <a:off x="3192170" y="5265115"/>
+            <a:ext cx="256032" cy="256032"/>
+          </a:xfrm>
+          <a:prstGeom prst="ellipse">
+            <a:avLst/>
+          </a:prstGeom>
+          <a:solidFill>
+            <a:srgbClr val="FFB400"/>
+          </a:solidFill>
+          <a:ln w="9525">
+            <a:solidFill>
+              <a:srgbClr val="111111"/>
+            </a:solidFill>
+            <a:prstDash val="solid"/>
+          </a:ln>
+        </p:spPr>
+      </p:sp>
+      <p:sp>
+        <p:nvSpPr>
+          <p:cNvPr id="16" name="Text 13"/>
+          <p:cNvSpPr txBox="1"/>
+          <p:nvPr/>
+        </p:nvSpPr>
+        <p:spPr>
+          <a:xfrm>
+            <a:off x="3192170" y="5265115"/>
+            <a:ext cx="256032" cy="256032"/>
           </a:xfrm>
           <a:prstGeom prst="rect">
             <a:avLst/>
@@ -16670,11 +17416,114 @@
           <a:bodyPr wrap="square" lIns="0" tIns="0" rIns="0" bIns="0" rtlCol="0" anchor="ctr"/>
           <a:lstStyle/>
           <a:p>
+            <a:pPr algn="ctr" indent="0" marL="0">
+              <a:buNone/>
+            </a:pPr>
+            <a:r>
+              <a:rPr lang="en-US" sz="1200" b="1" dirty="0">
+                <a:solidFill>
+                  <a:srgbClr val="111111"/>
+                </a:solidFill>
+                <a:latin typeface="Arial" pitchFamily="34" charset="0"/>
+                <a:ea typeface="Arial" pitchFamily="34" charset="-122"/>
+                <a:cs typeface="Arial" pitchFamily="34" charset="-120"/>
+              </a:rPr>
+              <a:t>3</a:t>
+            </a:r>
+            <a:endParaRPr lang="en-US" sz="1200" dirty="0"/>
+          </a:p>
+        </p:txBody>
+      </p:sp>
+      <p:sp>
+        <p:nvSpPr>
+          <p:cNvPr id="17" name="Shape 14"/>
+          <p:cNvSpPr/>
+          <p:nvPr/>
+        </p:nvSpPr>
+        <p:spPr>
+          <a:xfrm>
+            <a:off x="8458200" y="1179576"/>
+            <a:ext cx="310896" cy="310896"/>
+          </a:xfrm>
+          <a:prstGeom prst="ellipse">
+            <a:avLst/>
+          </a:prstGeom>
+          <a:solidFill>
+            <a:srgbClr val="FFB400"/>
+          </a:solidFill>
+          <a:ln w="9525">
+            <a:solidFill>
+              <a:srgbClr val="111111"/>
+            </a:solidFill>
+            <a:prstDash val="solid"/>
+          </a:ln>
+        </p:spPr>
+      </p:sp>
+      <p:sp>
+        <p:nvSpPr>
+          <p:cNvPr id="18" name="Text 15"/>
+          <p:cNvSpPr txBox="1"/>
+          <p:nvPr/>
+        </p:nvSpPr>
+        <p:spPr>
+          <a:xfrm>
+            <a:off x="8458200" y="1179576"/>
+            <a:ext cx="310896" cy="310896"/>
+          </a:xfrm>
+          <a:prstGeom prst="rect">
+            <a:avLst/>
+          </a:prstGeom>
+          <a:noFill/>
+          <a:ln/>
+        </p:spPr>
+        <p:txBody>
+          <a:bodyPr wrap="square" lIns="0" tIns="0" rIns="0" bIns="0" rtlCol="0" anchor="ctr"/>
+          <a:lstStyle/>
+          <a:p>
+            <a:pPr algn="ctr" indent="0" marL="0">
+              <a:buNone/>
+            </a:pPr>
+            <a:r>
+              <a:rPr lang="en-US" sz="1200" b="1" dirty="0">
+                <a:solidFill>
+                  <a:srgbClr val="111111"/>
+                </a:solidFill>
+                <a:latin typeface="Arial" pitchFamily="34" charset="0"/>
+                <a:ea typeface="Arial" pitchFamily="34" charset="-122"/>
+                <a:cs typeface="Arial" pitchFamily="34" charset="-120"/>
+              </a:rPr>
+              <a:t>1</a:t>
+            </a:r>
+            <a:endParaRPr lang="en-US" sz="1200" dirty="0"/>
+          </a:p>
+        </p:txBody>
+      </p:sp>
+      <p:sp>
+        <p:nvSpPr>
+          <p:cNvPr id="19" name="Text 16"/>
+          <p:cNvSpPr txBox="1"/>
+          <p:nvPr/>
+        </p:nvSpPr>
+        <p:spPr>
+          <a:xfrm>
+            <a:off x="8897112" y="1143000"/>
+            <a:ext cx="2898648" cy="822960"/>
+          </a:xfrm>
+          <a:prstGeom prst="rect">
+            <a:avLst/>
+          </a:prstGeom>
+          <a:noFill/>
+          <a:ln/>
+        </p:spPr>
+        <p:txBody>
+          <a:bodyPr wrap="square" lIns="0" tIns="0" rIns="0" bIns="0" rtlCol="0" anchor="t"/>
+          <a:lstStyle/>
+          <a:p>
             <a:pPr indent="0" marL="0">
               <a:buNone/>
             </a:pPr>
             <a:r>
-              <a:rPr lang="en-US" sz="2200" dirty="0">
+              <a:rPr lang="en-US" sz="1700" dirty="0">
                 <a:solidFill>
                   <a:srgbClr val="1B1B1B"/>
                 </a:solidFill>
@@ -16682,65 +17531,302 @@
                 <a:ea typeface="Calibri" pitchFamily="34" charset="-122"/>
                 <a:cs typeface="Calibri" pitchFamily="34" charset="-120"/>
               </a:rPr>
-              <a:t>The screen must always show the die that is really in the press.</a:t>
-            </a:r>
-            <a:endParaRPr lang="en-US" sz="2200" dirty="0"/>
-          </a:p>
-        </p:txBody>
-      </p:sp>
-      <p:sp>
-        <p:nvSpPr>
-          <p:cNvPr id="10" name="Shape 8"/>
-          <p:cNvSpPr/>
-          <p:nvPr/>
-        </p:nvSpPr>
-        <p:spPr>
-          <a:xfrm>
-            <a:off x="411480" y="5257800"/>
-            <a:ext cx="11338560" cy="868680"/>
-          </a:xfrm>
-          <a:prstGeom prst="roundRect">
-            <a:avLst>
-              <a:gd name="adj" fmla="val 8421"/>
-            </a:avLst>
+              <a:t>Die changed on the press? Tap </a:t>
+            </a:r>
+            <a:pPr indent="0" marL="0">
+              <a:buNone/>
+            </a:pPr>
+            <a:r>
+              <a:rPr lang="en-US" sz="1700" b="1" dirty="0">
+                <a:solidFill>
+                  <a:srgbClr val="12263F"/>
+                </a:solidFill>
+                <a:latin typeface="Calibri" pitchFamily="34" charset="0"/>
+                <a:ea typeface="Calibri" pitchFamily="34" charset="-122"/>
+                <a:cs typeface="Calibri" pitchFamily="34" charset="-120"/>
+              </a:rPr>
+              <a:t>Die Mount</a:t>
+            </a:r>
+            <a:pPr indent="0" marL="0">
+              <a:buNone/>
+            </a:pPr>
+            <a:r>
+              <a:rPr lang="en-US" sz="1700" dirty="0">
+                <a:solidFill>
+                  <a:srgbClr val="1B1B1B"/>
+                </a:solidFill>
+                <a:latin typeface="Calibri" pitchFamily="34" charset="0"/>
+                <a:ea typeface="Calibri" pitchFamily="34" charset="-122"/>
+                <a:cs typeface="Calibri" pitchFamily="34" charset="-120"/>
+              </a:rPr>
+              <a:t>.</a:t>
+            </a:r>
+            <a:endParaRPr lang="en-US" sz="1700" dirty="0"/>
+          </a:p>
+        </p:txBody>
+      </p:sp>
+      <p:sp>
+        <p:nvSpPr>
+          <p:cNvPr id="20" name="Shape 17"/>
+          <p:cNvSpPr/>
+          <p:nvPr/>
+        </p:nvSpPr>
+        <p:spPr>
+          <a:xfrm>
+            <a:off x="8458200" y="2093976"/>
+            <a:ext cx="310896" cy="310896"/>
+          </a:xfrm>
+          <a:prstGeom prst="ellipse">
+            <a:avLst/>
+          </a:prstGeom>
+          <a:solidFill>
+            <a:srgbClr val="FFB400"/>
+          </a:solidFill>
+          <a:ln w="9525">
+            <a:solidFill>
+              <a:srgbClr val="111111"/>
+            </a:solidFill>
+            <a:prstDash val="solid"/>
+          </a:ln>
+        </p:spPr>
+      </p:sp>
+      <p:sp>
+        <p:nvSpPr>
+          <p:cNvPr id="21" name="Text 18"/>
+          <p:cNvSpPr txBox="1"/>
+          <p:nvPr/>
+        </p:nvSpPr>
+        <p:spPr>
+          <a:xfrm>
+            <a:off x="8458200" y="2093976"/>
+            <a:ext cx="310896" cy="310896"/>
+          </a:xfrm>
+          <a:prstGeom prst="rect">
+            <a:avLst/>
+          </a:prstGeom>
+          <a:noFill/>
+          <a:ln/>
+        </p:spPr>
+        <p:txBody>
+          <a:bodyPr wrap="square" lIns="0" tIns="0" rIns="0" bIns="0" rtlCol="0" anchor="ctr"/>
+          <a:lstStyle/>
+          <a:p>
+            <a:pPr algn="ctr" indent="0" marL="0">
+              <a:buNone/>
+            </a:pPr>
+            <a:r>
+              <a:rPr lang="en-US" sz="1200" b="1" dirty="0">
+                <a:solidFill>
+                  <a:srgbClr val="111111"/>
+                </a:solidFill>
+                <a:latin typeface="Arial" pitchFamily="34" charset="0"/>
+                <a:ea typeface="Arial" pitchFamily="34" charset="-122"/>
+                <a:cs typeface="Arial" pitchFamily="34" charset="-120"/>
+              </a:rPr>
+              <a:t>2</a:t>
+            </a:r>
+            <a:endParaRPr lang="en-US" sz="1200" dirty="0"/>
+          </a:p>
+        </p:txBody>
+      </p:sp>
+      <p:sp>
+        <p:nvSpPr>
+          <p:cNvPr id="22" name="Text 19"/>
+          <p:cNvSpPr txBox="1"/>
+          <p:nvPr/>
+        </p:nvSpPr>
+        <p:spPr>
+          <a:xfrm>
+            <a:off x="8897112" y="2057400"/>
+            <a:ext cx="2898648" cy="822960"/>
+          </a:xfrm>
+          <a:prstGeom prst="rect">
+            <a:avLst/>
+          </a:prstGeom>
+          <a:noFill/>
+          <a:ln/>
+        </p:spPr>
+        <p:txBody>
+          <a:bodyPr wrap="square" lIns="0" tIns="0" rIns="0" bIns="0" rtlCol="0" anchor="t"/>
+          <a:lstStyle/>
+          <a:p>
+            <a:pPr indent="0" marL="0">
+              <a:buNone/>
+            </a:pPr>
+            <a:r>
+              <a:rPr lang="en-US" sz="1700" dirty="0">
+                <a:solidFill>
+                  <a:srgbClr val="1B1B1B"/>
+                </a:solidFill>
+                <a:latin typeface="Calibri" pitchFamily="34" charset="0"/>
+                <a:ea typeface="Calibri" pitchFamily="34" charset="-122"/>
+                <a:cs typeface="Calibri" pitchFamily="34" charset="-120"/>
+              </a:rPr>
+              <a:t>Sign in with your own AD user name and password.</a:t>
+            </a:r>
+            <a:endParaRPr lang="en-US" sz="1700" dirty="0"/>
+          </a:p>
+        </p:txBody>
+      </p:sp>
+      <p:sp>
+        <p:nvSpPr>
+          <p:cNvPr id="23" name="Shape 20"/>
+          <p:cNvSpPr/>
+          <p:nvPr/>
+        </p:nvSpPr>
+        <p:spPr>
+          <a:xfrm>
+            <a:off x="8458200" y="3008376"/>
+            <a:ext cx="310896" cy="310896"/>
+          </a:xfrm>
+          <a:prstGeom prst="ellipse">
+            <a:avLst/>
+          </a:prstGeom>
+          <a:solidFill>
+            <a:srgbClr val="FFB400"/>
+          </a:solidFill>
+          <a:ln w="9525">
+            <a:solidFill>
+              <a:srgbClr val="111111"/>
+            </a:solidFill>
+            <a:prstDash val="solid"/>
+          </a:ln>
+        </p:spPr>
+      </p:sp>
+      <p:sp>
+        <p:nvSpPr>
+          <p:cNvPr id="24" name="Text 21"/>
+          <p:cNvSpPr txBox="1"/>
+          <p:nvPr/>
+        </p:nvSpPr>
+        <p:spPr>
+          <a:xfrm>
+            <a:off x="8458200" y="3008376"/>
+            <a:ext cx="310896" cy="310896"/>
+          </a:xfrm>
+          <a:prstGeom prst="rect">
+            <a:avLst/>
+          </a:prstGeom>
+          <a:noFill/>
+          <a:ln/>
+        </p:spPr>
+        <p:txBody>
+          <a:bodyPr wrap="square" lIns="0" tIns="0" rIns="0" bIns="0" rtlCol="0" anchor="ctr"/>
+          <a:lstStyle/>
+          <a:p>
+            <a:pPr algn="ctr" indent="0" marL="0">
+              <a:buNone/>
+            </a:pPr>
+            <a:r>
+              <a:rPr lang="en-US" sz="1200" b="1" dirty="0">
+                <a:solidFill>
+                  <a:srgbClr val="111111"/>
+                </a:solidFill>
+                <a:latin typeface="Arial" pitchFamily="34" charset="0"/>
+                <a:ea typeface="Arial" pitchFamily="34" charset="-122"/>
+                <a:cs typeface="Arial" pitchFamily="34" charset="-120"/>
+              </a:rPr>
+              <a:t>3</a:t>
+            </a:r>
+            <a:endParaRPr lang="en-US" sz="1200" dirty="0"/>
+          </a:p>
+        </p:txBody>
+      </p:sp>
+      <p:sp>
+        <p:nvSpPr>
+          <p:cNvPr id="25" name="Text 22"/>
+          <p:cNvSpPr txBox="1"/>
+          <p:nvPr/>
+        </p:nvSpPr>
+        <p:spPr>
+          <a:xfrm>
+            <a:off x="8897112" y="2971800"/>
+            <a:ext cx="2898648" cy="822960"/>
+          </a:xfrm>
+          <a:prstGeom prst="rect">
+            <a:avLst/>
+          </a:prstGeom>
+          <a:noFill/>
+          <a:ln/>
+        </p:spPr>
+        <p:txBody>
+          <a:bodyPr wrap="square" lIns="0" tIns="0" rIns="0" bIns="0" rtlCol="0" anchor="t"/>
+          <a:lstStyle/>
+          <a:p>
+            <a:pPr indent="0" marL="0">
+              <a:buNone/>
+            </a:pPr>
+            <a:r>
+              <a:rPr lang="en-US" sz="1700" dirty="0">
+                <a:solidFill>
+                  <a:srgbClr val="1B1B1B"/>
+                </a:solidFill>
+                <a:latin typeface="Calibri" pitchFamily="34" charset="0"/>
+                <a:ea typeface="Calibri" pitchFamily="34" charset="-122"/>
+                <a:cs typeface="Calibri" pitchFamily="34" charset="-120"/>
+              </a:rPr>
+              <a:t>Tap </a:t>
+            </a:r>
+            <a:pPr indent="0" marL="0">
+              <a:buNone/>
+            </a:pPr>
+            <a:r>
+              <a:rPr lang="en-US" sz="1700" b="1" dirty="0">
+                <a:solidFill>
+                  <a:srgbClr val="12263F"/>
+                </a:solidFill>
+                <a:latin typeface="Calibri" pitchFamily="34" charset="0"/>
+                <a:ea typeface="Calibri" pitchFamily="34" charset="-122"/>
+                <a:cs typeface="Calibri" pitchFamily="34" charset="-120"/>
+              </a:rPr>
+              <a:t>Authenticate</a:t>
+            </a:r>
+            <a:pPr indent="0" marL="0">
+              <a:buNone/>
+            </a:pPr>
+            <a:r>
+              <a:rPr lang="en-US" sz="1700" dirty="0">
+                <a:solidFill>
+                  <a:srgbClr val="1B1B1B"/>
+                </a:solidFill>
+                <a:latin typeface="Calibri" pitchFamily="34" charset="0"/>
+                <a:ea typeface="Calibri" pitchFamily="34" charset="-122"/>
+                <a:cs typeface="Calibri" pitchFamily="34" charset="-120"/>
+              </a:rPr>
+              <a:t>. Then pick the die that is in the press.</a:t>
+            </a:r>
+            <a:endParaRPr lang="en-US" sz="1700" dirty="0"/>
+          </a:p>
+        </p:txBody>
+      </p:sp>
+      <p:sp>
+        <p:nvSpPr>
+          <p:cNvPr id="26" name="Text 23"/>
+          <p:cNvSpPr txBox="1"/>
+          <p:nvPr/>
+        </p:nvSpPr>
+        <p:spPr>
+          <a:xfrm>
+            <a:off x="8458200" y="3977640"/>
+            <a:ext cx="3337560" cy="822960"/>
+          </a:xfrm>
+          <a:prstGeom prst="rect">
+            <a:avLst/>
           </a:prstGeom>
           <a:solidFill>
             <a:srgbClr val="EEF2F7"/>
           </a:solidFill>
-          <a:ln w="12700">
-            <a:solidFill>
-              <a:srgbClr val="C9D2DE"/>
-            </a:solidFill>
-            <a:prstDash val="dash"/>
-          </a:ln>
-        </p:spPr>
-      </p:sp>
-      <p:sp>
-        <p:nvSpPr>
-          <p:cNvPr id="11" name="Text 9"/>
-          <p:cNvSpPr txBox="1"/>
-          <p:nvPr/>
-        </p:nvSpPr>
-        <p:spPr>
-          <a:xfrm>
-            <a:off x="685800" y="5257800"/>
-            <a:ext cx="10789920" cy="868680"/>
-          </a:xfrm>
-          <a:prstGeom prst="rect">
-            <a:avLst/>
-          </a:prstGeom>
-          <a:noFill/>
-          <a:ln/>
-        </p:spPr>
-        <p:txBody>
-          <a:bodyPr wrap="square" lIns="0" tIns="0" rIns="0" bIns="0" rtlCol="0" anchor="ctr"/>
+          <a:ln/>
+        </p:spPr>
+        <p:txBody>
+          <a:bodyPr wrap="square" lIns="101600" tIns="101600" rIns="101600" bIns="101600" rtlCol="0" anchor="t"/>
           <a:lstStyle/>
           <a:p>
             <a:pPr indent="0" marL="0">
               <a:buNone/>
             </a:pPr>
             <a:r>
-              <a:rPr lang="en-US" sz="1600" i="1" dirty="0">
+              <a:rPr lang="en-US" sz="1300" dirty="0">
                 <a:solidFill>
                   <a:srgbClr val="5A6472"/>
                 </a:solidFill>
@@ -16748,9 +17834,9 @@
                 <a:ea typeface="Calibri" pitchFamily="34" charset="-122"/>
                 <a:cs typeface="Calibri" pitchFamily="34" charset="-120"/>
               </a:rPr>
-              <a:t>Screen pictures and step-by-step for this job come in the next version of this deck.</a:t>
-            </a:r>
-            <a:endParaRPr lang="en-US" sz="1600" dirty="0"/>
+              <a:t>The screen must always show the die that is really in the press.</a:t>
+            </a:r>
+            <a:endParaRPr lang="en-US" sz="1300" dirty="0"/>
           </a:p>
         </p:txBody>
       </p:sp>
@@ -16857,16 +17943,86 @@
           </a:p>
         </p:txBody>
       </p:sp>
-      <p:sp>
-        <p:nvSpPr>
-          <p:cNvPr id="4" name="Shape 2"/>
-          <p:cNvSpPr/>
-          <p:nvPr/>
-        </p:nvSpPr>
-        <p:spPr>
-          <a:xfrm>
-            <a:off x="731520" y="1490472"/>
-            <a:ext cx="384048" cy="384048"/>
+      <p:pic>
+        <p:nvPicPr>
+          <p:cNvPr id="4" name="Image 0" descr="Screenshot of the die cast terminal">    </p:cNvPr>
+          <p:cNvPicPr>
+            <a:picLocks noChangeAspect="1"/>
+          </p:cNvPicPr>
+          <p:nvPr/>
+        </p:nvPicPr>
+        <p:blipFill>
+          <a:blip r:embed="rId1"/>
+          <a:stretch>
+            <a:fillRect/>
+          </a:stretch>
+        </p:blipFill>
+        <p:spPr>
+          <a:xfrm>
+            <a:off x="411480" y="1143000"/>
+            <a:ext cx="7772400" cy="5301691"/>
+          </a:xfrm>
+          <a:prstGeom prst="rect">
+            <a:avLst/>
+          </a:prstGeom>
+        </p:spPr>
+      </p:pic>
+      <p:sp>
+        <p:nvSpPr>
+          <p:cNvPr id="5" name="Shape 2"/>
+          <p:cNvSpPr/>
+          <p:nvPr/>
+        </p:nvSpPr>
+        <p:spPr>
+          <a:xfrm>
+            <a:off x="7193585" y="1255471"/>
+            <a:ext cx="935431" cy="241402"/>
+          </a:xfrm>
+          <a:prstGeom prst="rect">
+            <a:avLst/>
+          </a:prstGeom>
+          <a:ln w="31750">
+            <a:solidFill>
+              <a:srgbClr val="000000">
+                <a:alpha val="55000"/>
+              </a:srgbClr>
+            </a:solidFill>
+            <a:prstDash val="solid"/>
+          </a:ln>
+        </p:spPr>
+      </p:sp>
+      <p:sp>
+        <p:nvSpPr>
+          <p:cNvPr id="6" name="Shape 3"/>
+          <p:cNvSpPr/>
+          <p:nvPr/>
+        </p:nvSpPr>
+        <p:spPr>
+          <a:xfrm>
+            <a:off x="7202729" y="1264615"/>
+            <a:ext cx="917143" cy="223114"/>
+          </a:xfrm>
+          <a:prstGeom prst="rect">
+            <a:avLst/>
+          </a:prstGeom>
+          <a:ln w="19050">
+            <a:solidFill>
+              <a:srgbClr val="FFB400"/>
+            </a:solidFill>
+            <a:prstDash val="solid"/>
+          </a:ln>
+        </p:spPr>
+      </p:sp>
+      <p:sp>
+        <p:nvSpPr>
+          <p:cNvPr id="7" name="Shape 4"/>
+          <p:cNvSpPr/>
+          <p:nvPr/>
+        </p:nvSpPr>
+        <p:spPr>
+          <a:xfrm>
+            <a:off x="7056425" y="1143000"/>
+            <a:ext cx="256032" cy="256032"/>
           </a:xfrm>
           <a:prstGeom prst="ellipse">
             <a:avLst/>
@@ -16884,14 +18040,14 @@
       </p:sp>
       <p:sp>
         <p:nvSpPr>
-          <p:cNvPr id="5" name="Text 3"/>
-          <p:cNvSpPr txBox="1"/>
-          <p:nvPr/>
-        </p:nvSpPr>
-        <p:spPr>
-          <a:xfrm>
-            <a:off x="731520" y="1490472"/>
-            <a:ext cx="384048" cy="384048"/>
+          <p:cNvPr id="8" name="Text 5"/>
+          <p:cNvSpPr txBox="1"/>
+          <p:nvPr/>
+        </p:nvSpPr>
+        <p:spPr>
+          <a:xfrm>
+            <a:off x="7056425" y="1143000"/>
+            <a:ext cx="256032" cy="256032"/>
           </a:xfrm>
           <a:prstGeom prst="rect">
             <a:avLst/>
@@ -16923,14 +18079,85 @@
       </p:sp>
       <p:sp>
         <p:nvSpPr>
-          <p:cNvPr id="6" name="Text 4"/>
-          <p:cNvSpPr txBox="1"/>
-          <p:nvPr/>
-        </p:nvSpPr>
-        <p:spPr>
-          <a:xfrm>
-            <a:off x="1371600" y="1417320"/>
-            <a:ext cx="10241280" cy="640080"/>
+          <p:cNvPr id="9" name="Shape 6"/>
+          <p:cNvSpPr/>
+          <p:nvPr/>
+        </p:nvSpPr>
+        <p:spPr>
+          <a:xfrm>
+            <a:off x="2905049" y="3540557"/>
+            <a:ext cx="2075688" cy="2255825"/>
+          </a:xfrm>
+          <a:prstGeom prst="rect">
+            <a:avLst/>
+          </a:prstGeom>
+          <a:ln w="31750">
+            <a:solidFill>
+              <a:srgbClr val="000000">
+                <a:alpha val="55000"/>
+              </a:srgbClr>
+            </a:solidFill>
+            <a:prstDash val="solid"/>
+          </a:ln>
+        </p:spPr>
+      </p:sp>
+      <p:sp>
+        <p:nvSpPr>
+          <p:cNvPr id="10" name="Shape 7"/>
+          <p:cNvSpPr/>
+          <p:nvPr/>
+        </p:nvSpPr>
+        <p:spPr>
+          <a:xfrm>
+            <a:off x="2914193" y="3549701"/>
+            <a:ext cx="2057400" cy="2237537"/>
+          </a:xfrm>
+          <a:prstGeom prst="rect">
+            <a:avLst/>
+          </a:prstGeom>
+          <a:ln w="19050">
+            <a:solidFill>
+              <a:srgbClr val="FFB400"/>
+            </a:solidFill>
+            <a:prstDash val="solid"/>
+          </a:ln>
+        </p:spPr>
+      </p:sp>
+      <p:sp>
+        <p:nvSpPr>
+          <p:cNvPr id="11" name="Shape 8"/>
+          <p:cNvSpPr/>
+          <p:nvPr/>
+        </p:nvSpPr>
+        <p:spPr>
+          <a:xfrm>
+            <a:off x="2767889" y="3403397"/>
+            <a:ext cx="256032" cy="256032"/>
+          </a:xfrm>
+          <a:prstGeom prst="ellipse">
+            <a:avLst/>
+          </a:prstGeom>
+          <a:solidFill>
+            <a:srgbClr val="FFB400"/>
+          </a:solidFill>
+          <a:ln w="9525">
+            <a:solidFill>
+              <a:srgbClr val="111111"/>
+            </a:solidFill>
+            <a:prstDash val="solid"/>
+          </a:ln>
+        </p:spPr>
+      </p:sp>
+      <p:sp>
+        <p:nvSpPr>
+          <p:cNvPr id="12" name="Text 9"/>
+          <p:cNvSpPr txBox="1"/>
+          <p:nvPr/>
+        </p:nvSpPr>
+        <p:spPr>
+          <a:xfrm>
+            <a:off x="2767889" y="3403397"/>
+            <a:ext cx="256032" cy="256032"/>
           </a:xfrm>
           <a:prstGeom prst="rect">
             <a:avLst/>
@@ -16942,11 +18169,114 @@
           <a:bodyPr wrap="square" lIns="0" tIns="0" rIns="0" bIns="0" rtlCol="0" anchor="ctr"/>
           <a:lstStyle/>
           <a:p>
+            <a:pPr algn="ctr" indent="0" marL="0">
+              <a:buNone/>
+            </a:pPr>
+            <a:r>
+              <a:rPr lang="en-US" sz="1200" b="1" dirty="0">
+                <a:solidFill>
+                  <a:srgbClr val="111111"/>
+                </a:solidFill>
+                <a:latin typeface="Arial" pitchFamily="34" charset="0"/>
+                <a:ea typeface="Arial" pitchFamily="34" charset="-122"/>
+                <a:cs typeface="Arial" pitchFamily="34" charset="-120"/>
+              </a:rPr>
+              <a:t>2</a:t>
+            </a:r>
+            <a:endParaRPr lang="en-US" sz="1200" dirty="0"/>
+          </a:p>
+        </p:txBody>
+      </p:sp>
+      <p:sp>
+        <p:nvSpPr>
+          <p:cNvPr id="13" name="Shape 10"/>
+          <p:cNvSpPr/>
+          <p:nvPr/>
+        </p:nvSpPr>
+        <p:spPr>
+          <a:xfrm>
+            <a:off x="8458200" y="1179576"/>
+            <a:ext cx="310896" cy="310896"/>
+          </a:xfrm>
+          <a:prstGeom prst="ellipse">
+            <a:avLst/>
+          </a:prstGeom>
+          <a:solidFill>
+            <a:srgbClr val="FFB400"/>
+          </a:solidFill>
+          <a:ln w="9525">
+            <a:solidFill>
+              <a:srgbClr val="111111"/>
+            </a:solidFill>
+            <a:prstDash val="solid"/>
+          </a:ln>
+        </p:spPr>
+      </p:sp>
+      <p:sp>
+        <p:nvSpPr>
+          <p:cNvPr id="14" name="Text 11"/>
+          <p:cNvSpPr txBox="1"/>
+          <p:nvPr/>
+        </p:nvSpPr>
+        <p:spPr>
+          <a:xfrm>
+            <a:off x="8458200" y="1179576"/>
+            <a:ext cx="310896" cy="310896"/>
+          </a:xfrm>
+          <a:prstGeom prst="rect">
+            <a:avLst/>
+          </a:prstGeom>
+          <a:noFill/>
+          <a:ln/>
+        </p:spPr>
+        <p:txBody>
+          <a:bodyPr wrap="square" lIns="0" tIns="0" rIns="0" bIns="0" rtlCol="0" anchor="ctr"/>
+          <a:lstStyle/>
+          <a:p>
+            <a:pPr algn="ctr" indent="0" marL="0">
+              <a:buNone/>
+            </a:pPr>
+            <a:r>
+              <a:rPr lang="en-US" sz="1200" b="1" dirty="0">
+                <a:solidFill>
+                  <a:srgbClr val="111111"/>
+                </a:solidFill>
+                <a:latin typeface="Arial" pitchFamily="34" charset="0"/>
+                <a:ea typeface="Arial" pitchFamily="34" charset="-122"/>
+                <a:cs typeface="Arial" pitchFamily="34" charset="-120"/>
+              </a:rPr>
+              <a:t>1</a:t>
+            </a:r>
+            <a:endParaRPr lang="en-US" sz="1200" dirty="0"/>
+          </a:p>
+        </p:txBody>
+      </p:sp>
+      <p:sp>
+        <p:nvSpPr>
+          <p:cNvPr id="15" name="Text 12"/>
+          <p:cNvSpPr txBox="1"/>
+          <p:nvPr/>
+        </p:nvSpPr>
+        <p:spPr>
+          <a:xfrm>
+            <a:off x="8897112" y="1143000"/>
+            <a:ext cx="2898648" cy="822960"/>
+          </a:xfrm>
+          <a:prstGeom prst="rect">
+            <a:avLst/>
+          </a:prstGeom>
+          <a:noFill/>
+          <a:ln/>
+        </p:spPr>
+        <p:txBody>
+          <a:bodyPr wrap="square" lIns="0" tIns="0" rIns="0" bIns="0" rtlCol="0" anchor="t"/>
+          <a:lstStyle/>
+          <a:p>
             <a:pPr indent="0" marL="0">
               <a:buNone/>
             </a:pPr>
             <a:r>
-              <a:rPr lang="en-US" sz="2200" dirty="0">
+              <a:rPr lang="en-US" sz="1700" dirty="0">
                 <a:solidFill>
                   <a:srgbClr val="1B1B1B"/>
                 </a:solidFill>
@@ -16954,65 +18284,171 @@
                 <a:ea typeface="Calibri" pitchFamily="34" charset="-122"/>
                 <a:cs typeface="Calibri" pitchFamily="34" charset="-120"/>
               </a:rPr>
-              <a:t>Use it when the screen is stuck or shows the wrong place.</a:t>
-            </a:r>
-            <a:endParaRPr lang="en-US" sz="2200" dirty="0"/>
-          </a:p>
-        </p:txBody>
-      </p:sp>
-      <p:sp>
-        <p:nvSpPr>
-          <p:cNvPr id="7" name="Shape 5"/>
-          <p:cNvSpPr/>
-          <p:nvPr/>
-        </p:nvSpPr>
-        <p:spPr>
-          <a:xfrm>
-            <a:off x="411480" y="5257800"/>
-            <a:ext cx="11338560" cy="868680"/>
-          </a:xfrm>
-          <a:prstGeom prst="roundRect">
-            <a:avLst>
-              <a:gd name="adj" fmla="val 8421"/>
-            </a:avLst>
+              <a:t>Tap </a:t>
+            </a:r>
+            <a:pPr indent="0" marL="0">
+              <a:buNone/>
+            </a:pPr>
+            <a:r>
+              <a:rPr lang="en-US" sz="1700" b="1" dirty="0">
+                <a:solidFill>
+                  <a:srgbClr val="12263F"/>
+                </a:solidFill>
+                <a:latin typeface="Calibri" pitchFamily="34" charset="0"/>
+                <a:ea typeface="Calibri" pitchFamily="34" charset="-122"/>
+                <a:cs typeface="Calibri" pitchFamily="34" charset="-120"/>
+              </a:rPr>
+              <a:t>Reset Terminal</a:t>
+            </a:r>
+            <a:pPr indent="0" marL="0">
+              <a:buNone/>
+            </a:pPr>
+            <a:r>
+              <a:rPr lang="en-US" sz="1700" dirty="0">
+                <a:solidFill>
+                  <a:srgbClr val="1B1B1B"/>
+                </a:solidFill>
+                <a:latin typeface="Calibri" pitchFamily="34" charset="0"/>
+                <a:ea typeface="Calibri" pitchFamily="34" charset="-122"/>
+                <a:cs typeface="Calibri" pitchFamily="34" charset="-120"/>
+              </a:rPr>
+              <a:t>.</a:t>
+            </a:r>
+            <a:endParaRPr lang="en-US" sz="1700" dirty="0"/>
+          </a:p>
+        </p:txBody>
+      </p:sp>
+      <p:sp>
+        <p:nvSpPr>
+          <p:cNvPr id="16" name="Shape 13"/>
+          <p:cNvSpPr/>
+          <p:nvPr/>
+        </p:nvSpPr>
+        <p:spPr>
+          <a:xfrm>
+            <a:off x="8458200" y="2093976"/>
+            <a:ext cx="310896" cy="310896"/>
+          </a:xfrm>
+          <a:prstGeom prst="ellipse">
+            <a:avLst/>
+          </a:prstGeom>
+          <a:solidFill>
+            <a:srgbClr val="FFB400"/>
+          </a:solidFill>
+          <a:ln w="9525">
+            <a:solidFill>
+              <a:srgbClr val="111111"/>
+            </a:solidFill>
+            <a:prstDash val="solid"/>
+          </a:ln>
+        </p:spPr>
+      </p:sp>
+      <p:sp>
+        <p:nvSpPr>
+          <p:cNvPr id="17" name="Text 14"/>
+          <p:cNvSpPr txBox="1"/>
+          <p:nvPr/>
+        </p:nvSpPr>
+        <p:spPr>
+          <a:xfrm>
+            <a:off x="8458200" y="2093976"/>
+            <a:ext cx="310896" cy="310896"/>
+          </a:xfrm>
+          <a:prstGeom prst="rect">
+            <a:avLst/>
+          </a:prstGeom>
+          <a:noFill/>
+          <a:ln/>
+        </p:spPr>
+        <p:txBody>
+          <a:bodyPr wrap="square" lIns="0" tIns="0" rIns="0" bIns="0" rtlCol="0" anchor="ctr"/>
+          <a:lstStyle/>
+          <a:p>
+            <a:pPr algn="ctr" indent="0" marL="0">
+              <a:buNone/>
+            </a:pPr>
+            <a:r>
+              <a:rPr lang="en-US" sz="1200" b="1" dirty="0">
+                <a:solidFill>
+                  <a:srgbClr val="111111"/>
+                </a:solidFill>
+                <a:latin typeface="Arial" pitchFamily="34" charset="0"/>
+                <a:ea typeface="Arial" pitchFamily="34" charset="-122"/>
+                <a:cs typeface="Arial" pitchFamily="34" charset="-120"/>
+              </a:rPr>
+              <a:t>2</a:t>
+            </a:r>
+            <a:endParaRPr lang="en-US" sz="1200" dirty="0"/>
+          </a:p>
+        </p:txBody>
+      </p:sp>
+      <p:sp>
+        <p:nvSpPr>
+          <p:cNvPr id="18" name="Text 15"/>
+          <p:cNvSpPr txBox="1"/>
+          <p:nvPr/>
+        </p:nvSpPr>
+        <p:spPr>
+          <a:xfrm>
+            <a:off x="8897112" y="2057400"/>
+            <a:ext cx="2898648" cy="822960"/>
+          </a:xfrm>
+          <a:prstGeom prst="rect">
+            <a:avLst/>
+          </a:prstGeom>
+          <a:noFill/>
+          <a:ln/>
+        </p:spPr>
+        <p:txBody>
+          <a:bodyPr wrap="square" lIns="0" tIns="0" rIns="0" bIns="0" rtlCol="0" anchor="t"/>
+          <a:lstStyle/>
+          <a:p>
+            <a:pPr indent="0" marL="0">
+              <a:buNone/>
+            </a:pPr>
+            <a:r>
+              <a:rPr lang="en-US" sz="1700" dirty="0">
+                <a:solidFill>
+                  <a:srgbClr val="1B1B1B"/>
+                </a:solidFill>
+                <a:latin typeface="Calibri" pitchFamily="34" charset="0"/>
+                <a:ea typeface="Calibri" pitchFamily="34" charset="-122"/>
+                <a:cs typeface="Calibri" pitchFamily="34" charset="-120"/>
+              </a:rPr>
+              <a:t>The person on the screen is signed out. The next person types their PIN.</a:t>
+            </a:r>
+            <a:endParaRPr lang="en-US" sz="1700" dirty="0"/>
+          </a:p>
+        </p:txBody>
+      </p:sp>
+      <p:sp>
+        <p:nvSpPr>
+          <p:cNvPr id="19" name="Text 16"/>
+          <p:cNvSpPr txBox="1"/>
+          <p:nvPr/>
+        </p:nvSpPr>
+        <p:spPr>
+          <a:xfrm>
+            <a:off x="8458200" y="3063240"/>
+            <a:ext cx="3337560" cy="822960"/>
+          </a:xfrm>
+          <a:prstGeom prst="rect">
+            <a:avLst/>
           </a:prstGeom>
           <a:solidFill>
             <a:srgbClr val="EEF2F7"/>
           </a:solidFill>
-          <a:ln w="12700">
-            <a:solidFill>
-              <a:srgbClr val="C9D2DE"/>
-            </a:solidFill>
-            <a:prstDash val="dash"/>
-          </a:ln>
-        </p:spPr>
-      </p:sp>
-      <p:sp>
-        <p:nvSpPr>
-          <p:cNvPr id="8" name="Text 6"/>
-          <p:cNvSpPr txBox="1"/>
-          <p:nvPr/>
-        </p:nvSpPr>
-        <p:spPr>
-          <a:xfrm>
-            <a:off x="685800" y="5257800"/>
-            <a:ext cx="10789920" cy="868680"/>
-          </a:xfrm>
-          <a:prstGeom prst="rect">
-            <a:avLst/>
-          </a:prstGeom>
-          <a:noFill/>
-          <a:ln/>
-        </p:spPr>
-        <p:txBody>
-          <a:bodyPr wrap="square" lIns="0" tIns="0" rIns="0" bIns="0" rtlCol="0" anchor="ctr"/>
+          <a:ln/>
+        </p:spPr>
+        <p:txBody>
+          <a:bodyPr wrap="square" lIns="101600" tIns="101600" rIns="101600" bIns="101600" rtlCol="0" anchor="t"/>
           <a:lstStyle/>
           <a:p>
             <a:pPr indent="0" marL="0">
               <a:buNone/>
             </a:pPr>
             <a:r>
-              <a:rPr lang="en-US" sz="1600" i="1" dirty="0">
+              <a:rPr lang="en-US" sz="1300" dirty="0">
                 <a:solidFill>
                   <a:srgbClr val="5A6472"/>
                 </a:solidFill>
@@ -17020,9 +18456,9 @@
                 <a:ea typeface="Calibri" pitchFamily="34" charset="-122"/>
                 <a:cs typeface="Calibri" pitchFamily="34" charset="-120"/>
               </a:rPr>
-              <a:t>Screen pictures and step-by-step for this job come in the next version of this deck.</a:t>
-            </a:r>
-            <a:endParaRPr lang="en-US" sz="1600" dirty="0"/>
+              <a:t>It signs out whoever is on the screen, right away. It does not ask first.</a:t>
+            </a:r>
+            <a:endParaRPr lang="en-US" sz="1300" dirty="0"/>
           </a:p>
         </p:txBody>
       </p:sp>
@@ -17129,41 +18565,251 @@
           </a:p>
         </p:txBody>
       </p:sp>
-      <p:sp>
-        <p:nvSpPr>
-          <p:cNvPr id="4" name="Shape 2"/>
-          <p:cNvSpPr/>
-          <p:nvPr/>
-        </p:nvSpPr>
-        <p:spPr>
-          <a:xfrm>
-            <a:off x="731520" y="1490472"/>
-            <a:ext cx="384048" cy="384048"/>
-          </a:xfrm>
-          <a:prstGeom prst="ellipse">
-            <a:avLst/>
+      <p:pic>
+        <p:nvPicPr>
+          <p:cNvPr id="4" name="Image 0" descr="Screenshot of the die cast terminal">    </p:cNvPr>
+          <p:cNvPicPr>
+            <a:picLocks noChangeAspect="1"/>
+          </p:cNvPicPr>
+          <p:nvPr/>
+        </p:nvPicPr>
+        <p:blipFill>
+          <a:blip r:embed="rId1"/>
+          <a:stretch>
+            <a:fillRect/>
+          </a:stretch>
+        </p:blipFill>
+        <p:spPr>
+          <a:xfrm>
+            <a:off x="411480" y="1143000"/>
+            <a:ext cx="7772400" cy="4858207"/>
+          </a:xfrm>
+          <a:prstGeom prst="rect">
+            <a:avLst/>
+          </a:prstGeom>
+        </p:spPr>
+      </p:pic>
+      <p:sp>
+        <p:nvSpPr>
+          <p:cNvPr id="5" name="Shape 2"/>
+          <p:cNvSpPr/>
+          <p:nvPr/>
+        </p:nvSpPr>
+        <p:spPr>
+          <a:xfrm>
+            <a:off x="5746090" y="1624889"/>
+            <a:ext cx="1446581" cy="358445"/>
+          </a:xfrm>
+          <a:prstGeom prst="rect">
+            <a:avLst/>
+          </a:prstGeom>
+          <a:ln w="31750">
+            <a:solidFill>
+              <a:srgbClr val="000000">
+                <a:alpha val="55000"/>
+              </a:srgbClr>
+            </a:solidFill>
+            <a:prstDash val="solid"/>
+          </a:ln>
+        </p:spPr>
+      </p:sp>
+      <p:sp>
+        <p:nvSpPr>
+          <p:cNvPr id="6" name="Shape 3"/>
+          <p:cNvSpPr/>
+          <p:nvPr/>
+        </p:nvSpPr>
+        <p:spPr>
+          <a:xfrm>
+            <a:off x="5755234" y="1634033"/>
+            <a:ext cx="1428293" cy="340157"/>
+          </a:xfrm>
+          <a:prstGeom prst="rect">
+            <a:avLst/>
+          </a:prstGeom>
+          <a:ln w="19050">
+            <a:solidFill>
+              <a:srgbClr val="2E86DE"/>
+            </a:solidFill>
+            <a:prstDash val="solid"/>
+          </a:ln>
+        </p:spPr>
+      </p:sp>
+      <p:sp>
+        <p:nvSpPr>
+          <p:cNvPr id="7" name="Shape 4"/>
+          <p:cNvSpPr/>
+          <p:nvPr/>
+        </p:nvSpPr>
+        <p:spPr>
+          <a:xfrm>
+            <a:off x="465430" y="2081174"/>
+            <a:ext cx="4574743" cy="610819"/>
+          </a:xfrm>
+          <a:prstGeom prst="rect">
+            <a:avLst/>
+          </a:prstGeom>
+          <a:ln w="31750">
+            <a:solidFill>
+              <a:srgbClr val="000000">
+                <a:alpha val="55000"/>
+              </a:srgbClr>
+            </a:solidFill>
+            <a:prstDash val="solid"/>
+          </a:ln>
+        </p:spPr>
+      </p:sp>
+      <p:sp>
+        <p:nvSpPr>
+          <p:cNvPr id="8" name="Shape 5"/>
+          <p:cNvSpPr/>
+          <p:nvPr/>
+        </p:nvSpPr>
+        <p:spPr>
+          <a:xfrm>
+            <a:off x="474574" y="2090318"/>
+            <a:ext cx="4556455" cy="592531"/>
+          </a:xfrm>
+          <a:prstGeom prst="rect">
+            <a:avLst/>
+          </a:prstGeom>
+          <a:ln w="19050">
+            <a:solidFill>
+              <a:srgbClr val="E67E22"/>
+            </a:solidFill>
+            <a:prstDash val="solid"/>
+          </a:ln>
+        </p:spPr>
+      </p:sp>
+      <p:sp>
+        <p:nvSpPr>
+          <p:cNvPr id="9" name="Shape 6"/>
+          <p:cNvSpPr/>
+          <p:nvPr/>
+        </p:nvSpPr>
+        <p:spPr>
+          <a:xfrm>
+            <a:off x="465430" y="2722169"/>
+            <a:ext cx="3816706" cy="3225089"/>
+          </a:xfrm>
+          <a:prstGeom prst="rect">
+            <a:avLst/>
+          </a:prstGeom>
+          <a:ln w="31750">
+            <a:solidFill>
+              <a:srgbClr val="000000">
+                <a:alpha val="55000"/>
+              </a:srgbClr>
+            </a:solidFill>
+            <a:prstDash val="solid"/>
+          </a:ln>
+        </p:spPr>
+      </p:sp>
+      <p:sp>
+        <p:nvSpPr>
+          <p:cNvPr id="10" name="Shape 7"/>
+          <p:cNvSpPr/>
+          <p:nvPr/>
+        </p:nvSpPr>
+        <p:spPr>
+          <a:xfrm>
+            <a:off x="474574" y="2731313"/>
+            <a:ext cx="3798418" cy="3206801"/>
+          </a:xfrm>
+          <a:prstGeom prst="rect">
+            <a:avLst/>
+          </a:prstGeom>
+          <a:ln w="19050">
+            <a:solidFill>
+              <a:srgbClr val="8E44AD"/>
+            </a:solidFill>
+            <a:prstDash val="solid"/>
+          </a:ln>
+        </p:spPr>
+      </p:sp>
+      <p:sp>
+        <p:nvSpPr>
+          <p:cNvPr id="11" name="Shape 8"/>
+          <p:cNvSpPr/>
+          <p:nvPr/>
+        </p:nvSpPr>
+        <p:spPr>
+          <a:xfrm>
+            <a:off x="4313225" y="2722169"/>
+            <a:ext cx="3816706" cy="3225089"/>
+          </a:xfrm>
+          <a:prstGeom prst="rect">
+            <a:avLst/>
+          </a:prstGeom>
+          <a:ln w="31750">
+            <a:solidFill>
+              <a:srgbClr val="000000">
+                <a:alpha val="55000"/>
+              </a:srgbClr>
+            </a:solidFill>
+            <a:prstDash val="solid"/>
+          </a:ln>
+        </p:spPr>
+      </p:sp>
+      <p:sp>
+        <p:nvSpPr>
+          <p:cNvPr id="12" name="Shape 9"/>
+          <p:cNvSpPr/>
+          <p:nvPr/>
+        </p:nvSpPr>
+        <p:spPr>
+          <a:xfrm>
+            <a:off x="4322369" y="2731313"/>
+            <a:ext cx="3798418" cy="3206801"/>
+          </a:xfrm>
+          <a:prstGeom prst="rect">
+            <a:avLst/>
+          </a:prstGeom>
+          <a:ln w="19050">
+            <a:solidFill>
+              <a:srgbClr val="16A085"/>
+            </a:solidFill>
+            <a:prstDash val="solid"/>
+          </a:ln>
+        </p:spPr>
+      </p:sp>
+      <p:sp>
+        <p:nvSpPr>
+          <p:cNvPr id="13" name="Shape 10"/>
+          <p:cNvSpPr/>
+          <p:nvPr/>
+        </p:nvSpPr>
+        <p:spPr>
+          <a:xfrm>
+            <a:off x="5755234" y="1350569"/>
+            <a:ext cx="237744" cy="237744"/>
+          </a:xfrm>
+          <a:prstGeom prst="roundRect">
+            <a:avLst>
+              <a:gd name="adj" fmla="val 15385"/>
+            </a:avLst>
           </a:prstGeom>
           <a:solidFill>
-            <a:srgbClr val="FFB400"/>
+            <a:srgbClr val="2E86DE"/>
           </a:solidFill>
           <a:ln w="9525">
             <a:solidFill>
-              <a:srgbClr val="111111"/>
-            </a:solidFill>
-            <a:prstDash val="solid"/>
-          </a:ln>
-        </p:spPr>
-      </p:sp>
-      <p:sp>
-        <p:nvSpPr>
-          <p:cNvPr id="5" name="Text 3"/>
-          <p:cNvSpPr txBox="1"/>
-          <p:nvPr/>
-        </p:nvSpPr>
-        <p:spPr>
-          <a:xfrm>
-            <a:off x="731520" y="1490472"/>
-            <a:ext cx="384048" cy="384048"/>
+              <a:srgbClr val="FFFFFF"/>
+            </a:solidFill>
+            <a:prstDash val="solid"/>
+          </a:ln>
+        </p:spPr>
+      </p:sp>
+      <p:sp>
+        <p:nvSpPr>
+          <p:cNvPr id="14" name="Text 11"/>
+          <p:cNvSpPr txBox="1"/>
+          <p:nvPr/>
+        </p:nvSpPr>
+        <p:spPr>
+          <a:xfrm>
+            <a:off x="5755234" y="1350569"/>
+            <a:ext cx="237744" cy="237744"/>
           </a:xfrm>
           <a:prstGeom prst="rect">
             <a:avLst/>
@@ -17179,94 +18825,57 @@
               <a:buNone/>
             </a:pPr>
             <a:r>
-              <a:rPr lang="en-US" sz="1200" b="1" dirty="0">
-                <a:solidFill>
-                  <a:srgbClr val="111111"/>
+              <a:rPr lang="en-US" sz="1100" b="1" dirty="0">
+                <a:solidFill>
+                  <a:srgbClr val="FFFFFF"/>
                 </a:solidFill>
                 <a:latin typeface="Arial" pitchFamily="34" charset="0"/>
                 <a:ea typeface="Arial" pitchFamily="34" charset="-122"/>
                 <a:cs typeface="Arial" pitchFamily="34" charset="-120"/>
               </a:rPr>
-              <a:t>1</a:t>
-            </a:r>
-            <a:endParaRPr lang="en-US" sz="1200" dirty="0"/>
-          </a:p>
-        </p:txBody>
-      </p:sp>
-      <p:sp>
-        <p:nvSpPr>
-          <p:cNvPr id="6" name="Text 4"/>
-          <p:cNvSpPr txBox="1"/>
-          <p:nvPr/>
-        </p:nvSpPr>
-        <p:spPr>
-          <a:xfrm>
-            <a:off x="1371600" y="1417320"/>
-            <a:ext cx="10241280" cy="640080"/>
-          </a:xfrm>
-          <a:prstGeom prst="rect">
-            <a:avLst/>
-          </a:prstGeom>
-          <a:noFill/>
-          <a:ln/>
-        </p:spPr>
-        <p:txBody>
-          <a:bodyPr wrap="square" lIns="0" tIns="0" rIns="0" bIns="0" rtlCol="0" anchor="ctr"/>
-          <a:lstStyle/>
-          <a:p>
-            <a:pPr indent="0" marL="0">
-              <a:buNone/>
-            </a:pPr>
-            <a:r>
-              <a:rPr lang="en-US" sz="2200" dirty="0">
-                <a:solidFill>
-                  <a:srgbClr val="1B1B1B"/>
-                </a:solidFill>
-                <a:latin typeface="Calibri" pitchFamily="34" charset="0"/>
-                <a:ea typeface="Calibri" pitchFamily="34" charset="-122"/>
-                <a:cs typeface="Calibri" pitchFamily="34" charset="-120"/>
-              </a:rPr>
-              <a:t>Shows good parts for this shift and the last shift.</a:t>
-            </a:r>
-            <a:endParaRPr lang="en-US" sz="2200" dirty="0"/>
-          </a:p>
-        </p:txBody>
-      </p:sp>
-      <p:sp>
-        <p:nvSpPr>
-          <p:cNvPr id="7" name="Shape 5"/>
-          <p:cNvSpPr/>
-          <p:nvPr/>
-        </p:nvSpPr>
-        <p:spPr>
-          <a:xfrm>
-            <a:off x="731520" y="2450592"/>
-            <a:ext cx="384048" cy="384048"/>
-          </a:xfrm>
-          <a:prstGeom prst="ellipse">
-            <a:avLst/>
+              <a:t>A</a:t>
+            </a:r>
+            <a:endParaRPr lang="en-US" sz="1100" dirty="0"/>
+          </a:p>
+        </p:txBody>
+      </p:sp>
+      <p:sp>
+        <p:nvSpPr>
+          <p:cNvPr id="15" name="Shape 12"/>
+          <p:cNvSpPr/>
+          <p:nvPr/>
+        </p:nvSpPr>
+        <p:spPr>
+          <a:xfrm>
+            <a:off x="474574" y="1806854"/>
+            <a:ext cx="237744" cy="237744"/>
+          </a:xfrm>
+          <a:prstGeom prst="roundRect">
+            <a:avLst>
+              <a:gd name="adj" fmla="val 15385"/>
+            </a:avLst>
           </a:prstGeom>
           <a:solidFill>
-            <a:srgbClr val="FFB400"/>
+            <a:srgbClr val="E67E22"/>
           </a:solidFill>
           <a:ln w="9525">
             <a:solidFill>
-              <a:srgbClr val="111111"/>
-            </a:solidFill>
-            <a:prstDash val="solid"/>
-          </a:ln>
-        </p:spPr>
-      </p:sp>
-      <p:sp>
-        <p:nvSpPr>
-          <p:cNvPr id="8" name="Text 6"/>
-          <p:cNvSpPr txBox="1"/>
-          <p:nvPr/>
-        </p:nvSpPr>
-        <p:spPr>
-          <a:xfrm>
-            <a:off x="731520" y="2450592"/>
-            <a:ext cx="384048" cy="384048"/>
+              <a:srgbClr val="FFFFFF"/>
+            </a:solidFill>
+            <a:prstDash val="solid"/>
+          </a:ln>
+        </p:spPr>
+      </p:sp>
+      <p:sp>
+        <p:nvSpPr>
+          <p:cNvPr id="16" name="Text 13"/>
+          <p:cNvSpPr txBox="1"/>
+          <p:nvPr/>
+        </p:nvSpPr>
+        <p:spPr>
+          <a:xfrm>
+            <a:off x="474574" y="1806854"/>
+            <a:ext cx="237744" cy="237744"/>
           </a:xfrm>
           <a:prstGeom prst="rect">
             <a:avLst/>
@@ -17282,94 +18891,57 @@
               <a:buNone/>
             </a:pPr>
             <a:r>
-              <a:rPr lang="en-US" sz="1200" b="1" dirty="0">
-                <a:solidFill>
-                  <a:srgbClr val="111111"/>
+              <a:rPr lang="en-US" sz="1100" b="1" dirty="0">
+                <a:solidFill>
+                  <a:srgbClr val="FFFFFF"/>
                 </a:solidFill>
                 <a:latin typeface="Arial" pitchFamily="34" charset="0"/>
                 <a:ea typeface="Arial" pitchFamily="34" charset="-122"/>
                 <a:cs typeface="Arial" pitchFamily="34" charset="-120"/>
               </a:rPr>
-              <a:t>2</a:t>
-            </a:r>
-            <a:endParaRPr lang="en-US" sz="1200" dirty="0"/>
-          </a:p>
-        </p:txBody>
-      </p:sp>
-      <p:sp>
-        <p:nvSpPr>
-          <p:cNvPr id="9" name="Text 7"/>
-          <p:cNvSpPr txBox="1"/>
-          <p:nvPr/>
-        </p:nvSpPr>
-        <p:spPr>
-          <a:xfrm>
-            <a:off x="1371600" y="2377440"/>
-            <a:ext cx="10241280" cy="640080"/>
-          </a:xfrm>
-          <a:prstGeom prst="rect">
-            <a:avLst/>
-          </a:prstGeom>
-          <a:noFill/>
-          <a:ln/>
-        </p:spPr>
-        <p:txBody>
-          <a:bodyPr wrap="square" lIns="0" tIns="0" rIns="0" bIns="0" rtlCol="0" anchor="ctr"/>
-          <a:lstStyle/>
-          <a:p>
-            <a:pPr indent="0" marL="0">
-              <a:buNone/>
-            </a:pPr>
-            <a:r>
-              <a:rPr lang="en-US" sz="2200" dirty="0">
-                <a:solidFill>
-                  <a:srgbClr val="1B1B1B"/>
-                </a:solidFill>
-                <a:latin typeface="Calibri" pitchFamily="34" charset="0"/>
-                <a:ea typeface="Calibri" pitchFamily="34" charset="-122"/>
-                <a:cs typeface="Calibri" pitchFamily="34" charset="-120"/>
-              </a:rPr>
-              <a:t>Pick one area, or leave it on all of die cast.</a:t>
-            </a:r>
-            <a:endParaRPr lang="en-US" sz="2200" dirty="0"/>
-          </a:p>
-        </p:txBody>
-      </p:sp>
-      <p:sp>
-        <p:nvSpPr>
-          <p:cNvPr id="10" name="Shape 8"/>
-          <p:cNvSpPr/>
-          <p:nvPr/>
-        </p:nvSpPr>
-        <p:spPr>
-          <a:xfrm>
-            <a:off x="731520" y="3410712"/>
-            <a:ext cx="384048" cy="384048"/>
-          </a:xfrm>
-          <a:prstGeom prst="ellipse">
-            <a:avLst/>
+              <a:t>B</a:t>
+            </a:r>
+            <a:endParaRPr lang="en-US" sz="1100" dirty="0"/>
+          </a:p>
+        </p:txBody>
+      </p:sp>
+      <p:sp>
+        <p:nvSpPr>
+          <p:cNvPr id="17" name="Shape 14"/>
+          <p:cNvSpPr/>
+          <p:nvPr/>
+        </p:nvSpPr>
+        <p:spPr>
+          <a:xfrm>
+            <a:off x="191110" y="4215841"/>
+            <a:ext cx="237744" cy="237744"/>
+          </a:xfrm>
+          <a:prstGeom prst="roundRect">
+            <a:avLst>
+              <a:gd name="adj" fmla="val 15385"/>
+            </a:avLst>
           </a:prstGeom>
           <a:solidFill>
-            <a:srgbClr val="FFB400"/>
+            <a:srgbClr val="8E44AD"/>
           </a:solidFill>
           <a:ln w="9525">
             <a:solidFill>
-              <a:srgbClr val="111111"/>
-            </a:solidFill>
-            <a:prstDash val="solid"/>
-          </a:ln>
-        </p:spPr>
-      </p:sp>
-      <p:sp>
-        <p:nvSpPr>
-          <p:cNvPr id="11" name="Text 9"/>
-          <p:cNvSpPr txBox="1"/>
-          <p:nvPr/>
-        </p:nvSpPr>
-        <p:spPr>
-          <a:xfrm>
-            <a:off x="731520" y="3410712"/>
-            <a:ext cx="384048" cy="384048"/>
+              <a:srgbClr val="FFFFFF"/>
+            </a:solidFill>
+            <a:prstDash val="solid"/>
+          </a:ln>
+        </p:spPr>
+      </p:sp>
+      <p:sp>
+        <p:nvSpPr>
+          <p:cNvPr id="18" name="Text 15"/>
+          <p:cNvSpPr txBox="1"/>
+          <p:nvPr/>
+        </p:nvSpPr>
+        <p:spPr>
+          <a:xfrm>
+            <a:off x="191110" y="4215841"/>
+            <a:ext cx="237744" cy="237744"/>
           </a:xfrm>
           <a:prstGeom prst="rect">
             <a:avLst/>
@@ -17385,96 +18957,123 @@
               <a:buNone/>
             </a:pPr>
             <a:r>
-              <a:rPr lang="en-US" sz="1200" b="1" dirty="0">
-                <a:solidFill>
-                  <a:srgbClr val="111111"/>
+              <a:rPr lang="en-US" sz="1100" b="1" dirty="0">
+                <a:solidFill>
+                  <a:srgbClr val="FFFFFF"/>
                 </a:solidFill>
                 <a:latin typeface="Arial" pitchFamily="34" charset="0"/>
                 <a:ea typeface="Arial" pitchFamily="34" charset="-122"/>
                 <a:cs typeface="Arial" pitchFamily="34" charset="-120"/>
               </a:rPr>
-              <a:t>3</a:t>
-            </a:r>
-            <a:endParaRPr lang="en-US" sz="1200" dirty="0"/>
-          </a:p>
-        </p:txBody>
-      </p:sp>
-      <p:sp>
-        <p:nvSpPr>
-          <p:cNvPr id="12" name="Text 10"/>
-          <p:cNvSpPr txBox="1"/>
-          <p:nvPr/>
-        </p:nvSpPr>
-        <p:spPr>
-          <a:xfrm>
-            <a:off x="1371600" y="3337560"/>
-            <a:ext cx="10241280" cy="640080"/>
-          </a:xfrm>
-          <a:prstGeom prst="rect">
-            <a:avLst/>
-          </a:prstGeom>
-          <a:noFill/>
-          <a:ln/>
-        </p:spPr>
-        <p:txBody>
-          <a:bodyPr wrap="square" lIns="0" tIns="0" rIns="0" bIns="0" rtlCol="0" anchor="ctr"/>
-          <a:lstStyle/>
-          <a:p>
-            <a:pPr indent="0" marL="0">
-              <a:buNone/>
-            </a:pPr>
-            <a:r>
-              <a:rPr lang="en-US" sz="2200" dirty="0">
-                <a:solidFill>
-                  <a:srgbClr val="1B1B1B"/>
-                </a:solidFill>
-                <a:latin typeface="Calibri" pitchFamily="34" charset="0"/>
-                <a:ea typeface="Calibri" pitchFamily="34" charset="-122"/>
-                <a:cs typeface="Calibri" pitchFamily="34" charset="-120"/>
-              </a:rPr>
-              <a:t>One row for each press, with its die and part.</a:t>
-            </a:r>
-            <a:endParaRPr lang="en-US" sz="2200" dirty="0"/>
-          </a:p>
-        </p:txBody>
-      </p:sp>
-      <p:sp>
-        <p:nvSpPr>
-          <p:cNvPr id="13" name="Shape 11"/>
-          <p:cNvSpPr/>
-          <p:nvPr/>
-        </p:nvSpPr>
-        <p:spPr>
-          <a:xfrm>
-            <a:off x="411480" y="5257800"/>
-            <a:ext cx="11338560" cy="868680"/>
+              <a:t>C</a:t>
+            </a:r>
+            <a:endParaRPr lang="en-US" sz="1100" dirty="0"/>
+          </a:p>
+        </p:txBody>
+      </p:sp>
+      <p:sp>
+        <p:nvSpPr>
+          <p:cNvPr id="19" name="Shape 16"/>
+          <p:cNvSpPr/>
+          <p:nvPr/>
+        </p:nvSpPr>
+        <p:spPr>
+          <a:xfrm>
+            <a:off x="4322369" y="5983834"/>
+            <a:ext cx="237744" cy="237744"/>
           </a:xfrm>
           <a:prstGeom prst="roundRect">
             <a:avLst>
-              <a:gd name="adj" fmla="val 8421"/>
+              <a:gd name="adj" fmla="val 15385"/>
             </a:avLst>
           </a:prstGeom>
           <a:solidFill>
-            <a:srgbClr val="EEF2F7"/>
+            <a:srgbClr val="16A085"/>
+          </a:solidFill>
+          <a:ln w="9525">
+            <a:solidFill>
+              <a:srgbClr val="FFFFFF"/>
+            </a:solidFill>
+            <a:prstDash val="solid"/>
+          </a:ln>
+        </p:spPr>
+      </p:sp>
+      <p:sp>
+        <p:nvSpPr>
+          <p:cNvPr id="20" name="Text 17"/>
+          <p:cNvSpPr txBox="1"/>
+          <p:nvPr/>
+        </p:nvSpPr>
+        <p:spPr>
+          <a:xfrm>
+            <a:off x="4322369" y="5983834"/>
+            <a:ext cx="237744" cy="237744"/>
+          </a:xfrm>
+          <a:prstGeom prst="rect">
+            <a:avLst/>
+          </a:prstGeom>
+          <a:noFill/>
+          <a:ln/>
+        </p:spPr>
+        <p:txBody>
+          <a:bodyPr wrap="square" lIns="0" tIns="0" rIns="0" bIns="0" rtlCol="0" anchor="ctr"/>
+          <a:lstStyle/>
+          <a:p>
+            <a:pPr algn="ctr" indent="0" marL="0">
+              <a:buNone/>
+            </a:pPr>
+            <a:r>
+              <a:rPr lang="en-US" sz="1100" b="1" dirty="0">
+                <a:solidFill>
+                  <a:srgbClr val="FFFFFF"/>
+                </a:solidFill>
+                <a:latin typeface="Arial" pitchFamily="34" charset="0"/>
+                <a:ea typeface="Arial" pitchFamily="34" charset="-122"/>
+                <a:cs typeface="Arial" pitchFamily="34" charset="-120"/>
+              </a:rPr>
+              <a:t>D</a:t>
+            </a:r>
+            <a:endParaRPr lang="en-US" sz="1100" dirty="0"/>
+          </a:p>
+        </p:txBody>
+      </p:sp>
+      <p:sp>
+        <p:nvSpPr>
+          <p:cNvPr id="21" name="Shape 18"/>
+          <p:cNvSpPr/>
+          <p:nvPr/>
+        </p:nvSpPr>
+        <p:spPr>
+          <a:xfrm>
+            <a:off x="8458200" y="1143000"/>
+            <a:ext cx="310896" cy="310896"/>
+          </a:xfrm>
+          <a:prstGeom prst="roundRect">
+            <a:avLst>
+              <a:gd name="adj" fmla="val 14706"/>
+            </a:avLst>
+          </a:prstGeom>
+          <a:solidFill>
+            <a:srgbClr val="2E86DE"/>
           </a:solidFill>
           <a:ln w="12700">
             <a:solidFill>
-              <a:srgbClr val="C9D2DE"/>
-            </a:solidFill>
-            <a:prstDash val="dash"/>
-          </a:ln>
-        </p:spPr>
-      </p:sp>
-      <p:sp>
-        <p:nvSpPr>
-          <p:cNvPr id="14" name="Text 12"/>
-          <p:cNvSpPr txBox="1"/>
-          <p:nvPr/>
-        </p:nvSpPr>
-        <p:spPr>
-          <a:xfrm>
-            <a:off x="685800" y="5257800"/>
-            <a:ext cx="10789920" cy="868680"/>
+              <a:srgbClr val="2E86DE"/>
+            </a:solidFill>
+            <a:prstDash val="solid"/>
+          </a:ln>
+        </p:spPr>
+      </p:sp>
+      <p:sp>
+        <p:nvSpPr>
+          <p:cNvPr id="22" name="Text 19"/>
+          <p:cNvSpPr txBox="1"/>
+          <p:nvPr/>
+        </p:nvSpPr>
+        <p:spPr>
+          <a:xfrm>
+            <a:off x="8458200" y="1143000"/>
+            <a:ext cx="310896" cy="310896"/>
           </a:xfrm>
           <a:prstGeom prst="rect">
             <a:avLst/>
@@ -17486,21 +19085,375 @@
           <a:bodyPr wrap="square" lIns="0" tIns="0" rIns="0" bIns="0" rtlCol="0" anchor="ctr"/>
           <a:lstStyle/>
           <a:p>
+            <a:pPr algn="ctr" indent="0" marL="0">
+              <a:buNone/>
+            </a:pPr>
+            <a:r>
+              <a:rPr lang="en-US" sz="1400" b="1" dirty="0">
+                <a:solidFill>
+                  <a:srgbClr val="FFFFFF"/>
+                </a:solidFill>
+                <a:latin typeface="Arial" pitchFamily="34" charset="0"/>
+                <a:ea typeface="Arial" pitchFamily="34" charset="-122"/>
+                <a:cs typeface="Arial" pitchFamily="34" charset="-120"/>
+              </a:rPr>
+              <a:t>A</a:t>
+            </a:r>
+            <a:endParaRPr lang="en-US" sz="1400" dirty="0"/>
+          </a:p>
+        </p:txBody>
+      </p:sp>
+      <p:sp>
+        <p:nvSpPr>
+          <p:cNvPr id="23" name="Text 20"/>
+          <p:cNvSpPr txBox="1"/>
+          <p:nvPr/>
+        </p:nvSpPr>
+        <p:spPr>
+          <a:xfrm>
+            <a:off x="8915400" y="1115568"/>
+            <a:ext cx="2880360" cy="548640"/>
+          </a:xfrm>
+          <a:prstGeom prst="rect">
+            <a:avLst/>
+          </a:prstGeom>
+          <a:noFill/>
+          <a:ln/>
+        </p:spPr>
+        <p:txBody>
+          <a:bodyPr wrap="square" lIns="0" tIns="0" rIns="0" bIns="0" rtlCol="0" anchor="t"/>
+          <a:lstStyle/>
+          <a:p>
             <a:pPr indent="0" marL="0">
               <a:buNone/>
             </a:pPr>
             <a:r>
-              <a:rPr lang="en-US" sz="1600" i="1" dirty="0">
-                <a:solidFill>
-                  <a:srgbClr val="5A6472"/>
-                </a:solidFill>
-                <a:latin typeface="Calibri" pitchFamily="34" charset="0"/>
-                <a:ea typeface="Calibri" pitchFamily="34" charset="-122"/>
-                <a:cs typeface="Calibri" pitchFamily="34" charset="-120"/>
-              </a:rPr>
-              <a:t>Screen pictures and step-by-step for this job come in the next version of this deck.</a:t>
-            </a:r>
-            <a:endParaRPr lang="en-US" sz="1600" dirty="0"/>
+              <a:rPr lang="en-US" sz="1500" dirty="0">
+                <a:solidFill>
+                  <a:srgbClr val="1B1B1B"/>
+                </a:solidFill>
+                <a:latin typeface="Calibri" pitchFamily="34" charset="0"/>
+                <a:ea typeface="Calibri" pitchFamily="34" charset="-122"/>
+                <a:cs typeface="Calibri" pitchFamily="34" charset="-120"/>
+              </a:rPr>
+              <a:t>Pick one area, or all of die cast</a:t>
+            </a:r>
+            <a:endParaRPr lang="en-US" sz="1500" dirty="0"/>
+          </a:p>
+        </p:txBody>
+      </p:sp>
+      <p:sp>
+        <p:nvSpPr>
+          <p:cNvPr id="24" name="Shape 21"/>
+          <p:cNvSpPr/>
+          <p:nvPr/>
+        </p:nvSpPr>
+        <p:spPr>
+          <a:xfrm>
+            <a:off x="8458200" y="1801368"/>
+            <a:ext cx="310896" cy="310896"/>
+          </a:xfrm>
+          <a:prstGeom prst="roundRect">
+            <a:avLst>
+              <a:gd name="adj" fmla="val 14706"/>
+            </a:avLst>
+          </a:prstGeom>
+          <a:solidFill>
+            <a:srgbClr val="E67E22"/>
+          </a:solidFill>
+          <a:ln w="12700">
+            <a:solidFill>
+              <a:srgbClr val="E67E22"/>
+            </a:solidFill>
+            <a:prstDash val="solid"/>
+          </a:ln>
+        </p:spPr>
+      </p:sp>
+      <p:sp>
+        <p:nvSpPr>
+          <p:cNvPr id="25" name="Text 22"/>
+          <p:cNvSpPr txBox="1"/>
+          <p:nvPr/>
+        </p:nvSpPr>
+        <p:spPr>
+          <a:xfrm>
+            <a:off x="8458200" y="1801368"/>
+            <a:ext cx="310896" cy="310896"/>
+          </a:xfrm>
+          <a:prstGeom prst="rect">
+            <a:avLst/>
+          </a:prstGeom>
+          <a:noFill/>
+          <a:ln/>
+        </p:spPr>
+        <p:txBody>
+          <a:bodyPr wrap="square" lIns="0" tIns="0" rIns="0" bIns="0" rtlCol="0" anchor="ctr"/>
+          <a:lstStyle/>
+          <a:p>
+            <a:pPr algn="ctr" indent="0" marL="0">
+              <a:buNone/>
+            </a:pPr>
+            <a:r>
+              <a:rPr lang="en-US" sz="1400" b="1" dirty="0">
+                <a:solidFill>
+                  <a:srgbClr val="FFFFFF"/>
+                </a:solidFill>
+                <a:latin typeface="Arial" pitchFamily="34" charset="0"/>
+                <a:ea typeface="Arial" pitchFamily="34" charset="-122"/>
+                <a:cs typeface="Arial" pitchFamily="34" charset="-120"/>
+              </a:rPr>
+              <a:t>B</a:t>
+            </a:r>
+            <a:endParaRPr lang="en-US" sz="1400" dirty="0"/>
+          </a:p>
+        </p:txBody>
+      </p:sp>
+      <p:sp>
+        <p:nvSpPr>
+          <p:cNvPr id="26" name="Text 23"/>
+          <p:cNvSpPr txBox="1"/>
+          <p:nvPr/>
+        </p:nvSpPr>
+        <p:spPr>
+          <a:xfrm>
+            <a:off x="8915400" y="1773936"/>
+            <a:ext cx="2880360" cy="548640"/>
+          </a:xfrm>
+          <a:prstGeom prst="rect">
+            <a:avLst/>
+          </a:prstGeom>
+          <a:noFill/>
+          <a:ln/>
+        </p:spPr>
+        <p:txBody>
+          <a:bodyPr wrap="square" lIns="0" tIns="0" rIns="0" bIns="0" rtlCol="0" anchor="t"/>
+          <a:lstStyle/>
+          <a:p>
+            <a:pPr indent="0" marL="0">
+              <a:buNone/>
+            </a:pPr>
+            <a:r>
+              <a:rPr lang="en-US" sz="1500" dirty="0">
+                <a:solidFill>
+                  <a:srgbClr val="1B1B1B"/>
+                </a:solidFill>
+                <a:latin typeface="Calibri" pitchFamily="34" charset="0"/>
+                <a:ea typeface="Calibri" pitchFamily="34" charset="-122"/>
+                <a:cs typeface="Calibri" pitchFamily="34" charset="-120"/>
+              </a:rPr>
+              <a:t>This shift, the last shift, and the change</a:t>
+            </a:r>
+            <a:endParaRPr lang="en-US" sz="1500" dirty="0"/>
+          </a:p>
+        </p:txBody>
+      </p:sp>
+      <p:sp>
+        <p:nvSpPr>
+          <p:cNvPr id="27" name="Shape 24"/>
+          <p:cNvSpPr/>
+          <p:nvPr/>
+        </p:nvSpPr>
+        <p:spPr>
+          <a:xfrm>
+            <a:off x="8458200" y="2459736"/>
+            <a:ext cx="310896" cy="310896"/>
+          </a:xfrm>
+          <a:prstGeom prst="roundRect">
+            <a:avLst>
+              <a:gd name="adj" fmla="val 14706"/>
+            </a:avLst>
+          </a:prstGeom>
+          <a:solidFill>
+            <a:srgbClr val="8E44AD"/>
+          </a:solidFill>
+          <a:ln w="12700">
+            <a:solidFill>
+              <a:srgbClr val="8E44AD"/>
+            </a:solidFill>
+            <a:prstDash val="solid"/>
+          </a:ln>
+        </p:spPr>
+      </p:sp>
+      <p:sp>
+        <p:nvSpPr>
+          <p:cNvPr id="28" name="Text 25"/>
+          <p:cNvSpPr txBox="1"/>
+          <p:nvPr/>
+        </p:nvSpPr>
+        <p:spPr>
+          <a:xfrm>
+            <a:off x="8458200" y="2459736"/>
+            <a:ext cx="310896" cy="310896"/>
+          </a:xfrm>
+          <a:prstGeom prst="rect">
+            <a:avLst/>
+          </a:prstGeom>
+          <a:noFill/>
+          <a:ln/>
+        </p:spPr>
+        <p:txBody>
+          <a:bodyPr wrap="square" lIns="0" tIns="0" rIns="0" bIns="0" rtlCol="0" anchor="ctr"/>
+          <a:lstStyle/>
+          <a:p>
+            <a:pPr algn="ctr" indent="0" marL="0">
+              <a:buNone/>
+            </a:pPr>
+            <a:r>
+              <a:rPr lang="en-US" sz="1400" b="1" dirty="0">
+                <a:solidFill>
+                  <a:srgbClr val="FFFFFF"/>
+                </a:solidFill>
+                <a:latin typeface="Arial" pitchFamily="34" charset="0"/>
+                <a:ea typeface="Arial" pitchFamily="34" charset="-122"/>
+                <a:cs typeface="Arial" pitchFamily="34" charset="-120"/>
+              </a:rPr>
+              <a:t>C</a:t>
+            </a:r>
+            <a:endParaRPr lang="en-US" sz="1400" dirty="0"/>
+          </a:p>
+        </p:txBody>
+      </p:sp>
+      <p:sp>
+        <p:nvSpPr>
+          <p:cNvPr id="29" name="Text 26"/>
+          <p:cNvSpPr txBox="1"/>
+          <p:nvPr/>
+        </p:nvSpPr>
+        <p:spPr>
+          <a:xfrm>
+            <a:off x="8915400" y="2432304"/>
+            <a:ext cx="2880360" cy="548640"/>
+          </a:xfrm>
+          <a:prstGeom prst="rect">
+            <a:avLst/>
+          </a:prstGeom>
+          <a:noFill/>
+          <a:ln/>
+        </p:spPr>
+        <p:txBody>
+          <a:bodyPr wrap="square" lIns="0" tIns="0" rIns="0" bIns="0" rtlCol="0" anchor="t"/>
+          <a:lstStyle/>
+          <a:p>
+            <a:pPr indent="0" marL="0">
+              <a:buNone/>
+            </a:pPr>
+            <a:r>
+              <a:rPr lang="en-US" sz="1500" dirty="0">
+                <a:solidFill>
+                  <a:srgbClr val="1B1B1B"/>
+                </a:solidFill>
+                <a:latin typeface="Calibri" pitchFamily="34" charset="0"/>
+                <a:ea typeface="Calibri" pitchFamily="34" charset="-122"/>
+                <a:cs typeface="Calibri" pitchFamily="34" charset="-120"/>
+              </a:rPr>
+              <a:t>Each press and part this shift</a:t>
+            </a:r>
+            <a:endParaRPr lang="en-US" sz="1500" dirty="0"/>
+          </a:p>
+        </p:txBody>
+      </p:sp>
+      <p:sp>
+        <p:nvSpPr>
+          <p:cNvPr id="30" name="Shape 27"/>
+          <p:cNvSpPr/>
+          <p:nvPr/>
+        </p:nvSpPr>
+        <p:spPr>
+          <a:xfrm>
+            <a:off x="8458200" y="3118104"/>
+            <a:ext cx="310896" cy="310896"/>
+          </a:xfrm>
+          <a:prstGeom prst="roundRect">
+            <a:avLst>
+              <a:gd name="adj" fmla="val 14706"/>
+            </a:avLst>
+          </a:prstGeom>
+          <a:solidFill>
+            <a:srgbClr val="16A085"/>
+          </a:solidFill>
+          <a:ln w="12700">
+            <a:solidFill>
+              <a:srgbClr val="16A085"/>
+            </a:solidFill>
+            <a:prstDash val="solid"/>
+          </a:ln>
+        </p:spPr>
+      </p:sp>
+      <p:sp>
+        <p:nvSpPr>
+          <p:cNvPr id="31" name="Text 28"/>
+          <p:cNvSpPr txBox="1"/>
+          <p:nvPr/>
+        </p:nvSpPr>
+        <p:spPr>
+          <a:xfrm>
+            <a:off x="8458200" y="3118104"/>
+            <a:ext cx="310896" cy="310896"/>
+          </a:xfrm>
+          <a:prstGeom prst="rect">
+            <a:avLst/>
+          </a:prstGeom>
+          <a:noFill/>
+          <a:ln/>
+        </p:spPr>
+        <p:txBody>
+          <a:bodyPr wrap="square" lIns="0" tIns="0" rIns="0" bIns="0" rtlCol="0" anchor="ctr"/>
+          <a:lstStyle/>
+          <a:p>
+            <a:pPr algn="ctr" indent="0" marL="0">
+              <a:buNone/>
+            </a:pPr>
+            <a:r>
+              <a:rPr lang="en-US" sz="1400" b="1" dirty="0">
+                <a:solidFill>
+                  <a:srgbClr val="FFFFFF"/>
+                </a:solidFill>
+                <a:latin typeface="Arial" pitchFamily="34" charset="0"/>
+                <a:ea typeface="Arial" pitchFamily="34" charset="-122"/>
+                <a:cs typeface="Arial" pitchFamily="34" charset="-120"/>
+              </a:rPr>
+              <a:t>D</a:t>
+            </a:r>
+            <a:endParaRPr lang="en-US" sz="1400" dirty="0"/>
+          </a:p>
+        </p:txBody>
+      </p:sp>
+      <p:sp>
+        <p:nvSpPr>
+          <p:cNvPr id="32" name="Text 29"/>
+          <p:cNvSpPr txBox="1"/>
+          <p:nvPr/>
+        </p:nvSpPr>
+        <p:spPr>
+          <a:xfrm>
+            <a:off x="8915400" y="3090672"/>
+            <a:ext cx="2880360" cy="548640"/>
+          </a:xfrm>
+          <a:prstGeom prst="rect">
+            <a:avLst/>
+          </a:prstGeom>
+          <a:noFill/>
+          <a:ln/>
+        </p:spPr>
+        <p:txBody>
+          <a:bodyPr wrap="square" lIns="0" tIns="0" rIns="0" bIns="0" rtlCol="0" anchor="t"/>
+          <a:lstStyle/>
+          <a:p>
+            <a:pPr indent="0" marL="0">
+              <a:buNone/>
+            </a:pPr>
+            <a:r>
+              <a:rPr lang="en-US" sz="1500" dirty="0">
+                <a:solidFill>
+                  <a:srgbClr val="1B1B1B"/>
+                </a:solidFill>
+                <a:latin typeface="Calibri" pitchFamily="34" charset="0"/>
+                <a:ea typeface="Calibri" pitchFamily="34" charset="-122"/>
+                <a:cs typeface="Calibri" pitchFamily="34" charset="-120"/>
+              </a:rPr>
+              <a:t>Each press and part last shift</a:t>
+            </a:r>
+            <a:endParaRPr lang="en-US" sz="1500" dirty="0"/>
           </a:p>
         </p:txBody>
       </p:sp>

</xml_diff>